<commit_message>
feat(calibration): fit full validation temperatures OOD and refresh measured evidence
</commit_message>
<xml_diff>
--- a/presentation/tynys_project_10slides_kz.pptx
+++ b/presentation/tynys_project_10slides_kz.pptx
@@ -2,22 +2,24 @@
 <file path=ppt/presentation.xml><?xml version="1.0" encoding="utf-8"?>
 <p:presentation xmlns:p="http://schemas.openxmlformats.org/presentationml/2006/main">
   <p:sldMasterIdLst>
-    <p:sldMasterId xmlns:r="http://schemas.openxmlformats.org/officeDocument/2006/relationships" id="2147483648" r:id="R13dc72665ba74566"/>
+    <p:sldMasterId xmlns:r="http://schemas.openxmlformats.org/officeDocument/2006/relationships" id="2147483648" r:id="Rf6ca39ad066a4f2e"/>
   </p:sldMasterIdLst>
   <p:notesMasterIdLst>
-    <p:notesMasterId xmlns:r="http://schemas.openxmlformats.org/officeDocument/2006/relationships" r:id="R41076a58386a466c"/>
+    <p:notesMasterId xmlns:r="http://schemas.openxmlformats.org/officeDocument/2006/relationships" r:id="R7296dc908b164706"/>
   </p:notesMasterIdLst>
   <p:sldIdLst>
-    <p:sldId xmlns:r="http://schemas.openxmlformats.org/officeDocument/2006/relationships" id="256" r:id="Rc154dcd604564fba"/>
-    <p:sldId xmlns:r="http://schemas.openxmlformats.org/officeDocument/2006/relationships" id="257" r:id="R0ee6afed09c44174"/>
-    <p:sldId xmlns:r="http://schemas.openxmlformats.org/officeDocument/2006/relationships" id="258" r:id="R64fa0d6cff1b4b39"/>
-    <p:sldId xmlns:r="http://schemas.openxmlformats.org/officeDocument/2006/relationships" id="259" r:id="R91e38ee43bbc427a"/>
-    <p:sldId xmlns:r="http://schemas.openxmlformats.org/officeDocument/2006/relationships" id="260" r:id="R96736aab3111416b"/>
-    <p:sldId xmlns:r="http://schemas.openxmlformats.org/officeDocument/2006/relationships" id="261" r:id="R07468b5091734b3c"/>
-    <p:sldId xmlns:r="http://schemas.openxmlformats.org/officeDocument/2006/relationships" id="262" r:id="R64ea846c9f6d4b4a"/>
-    <p:sldId xmlns:r="http://schemas.openxmlformats.org/officeDocument/2006/relationships" id="263" r:id="Rd811c2ad81a54d49"/>
-    <p:sldId xmlns:r="http://schemas.openxmlformats.org/officeDocument/2006/relationships" id="264" r:id="Rc8a9849c2571421c"/>
-    <p:sldId xmlns:r="http://schemas.openxmlformats.org/officeDocument/2006/relationships" id="265" r:id="Rce8610cc1453408c"/>
+    <p:sldId xmlns:r="http://schemas.openxmlformats.org/officeDocument/2006/relationships" id="256" r:id="R00e62bdc6d2d430e"/>
+    <p:sldId xmlns:r="http://schemas.openxmlformats.org/officeDocument/2006/relationships" id="257" r:id="R8fb2e52f4532441d"/>
+    <p:sldId xmlns:r="http://schemas.openxmlformats.org/officeDocument/2006/relationships" id="258" r:id="R07ada17e20604cff"/>
+    <p:sldId xmlns:r="http://schemas.openxmlformats.org/officeDocument/2006/relationships" id="259" r:id="Rb0145468882841eb"/>
+    <p:sldId xmlns:r="http://schemas.openxmlformats.org/officeDocument/2006/relationships" id="260" r:id="R7d3882c1225c4a84"/>
+    <p:sldId xmlns:r="http://schemas.openxmlformats.org/officeDocument/2006/relationships" id="261" r:id="R2ed3aaad64a849cf"/>
+    <p:sldId xmlns:r="http://schemas.openxmlformats.org/officeDocument/2006/relationships" id="262" r:id="R68d10881bedf408b"/>
+    <p:sldId xmlns:r="http://schemas.openxmlformats.org/officeDocument/2006/relationships" id="263" r:id="Rad21329a70424b60"/>
+    <p:sldId xmlns:r="http://schemas.openxmlformats.org/officeDocument/2006/relationships" id="264" r:id="Rcda2d06ea15f4c22"/>
+    <p:sldId xmlns:r="http://schemas.openxmlformats.org/officeDocument/2006/relationships" id="265" r:id="R7fbb8ef651184338"/>
+    <p:sldId xmlns:r="http://schemas.openxmlformats.org/officeDocument/2006/relationships" id="266" r:id="R46d79641aa1b4ead"/>
+    <p:sldId xmlns:r="http://schemas.openxmlformats.org/officeDocument/2006/relationships" id="267" r:id="Re278e2e6f8624623"/>
   </p:sldIdLst>
   <p:sldSz cx="12192000" cy="6858000"/>
   <p:notesSz cx="6858000" cy="9144000"/>
@@ -451,7 +453,7 @@
           <a:lstStyle xmlns:a="http://schemas.openxmlformats.org/drawingml/2006/main"/>
           <a:p xmlns:a="http://schemas.openxmlformats.org/drawingml/2006/main">
             <a:r>
-              <a:t>Менің жобамның атауы — Tynys. Ол кеуде рентгенін NORMAL және PNEUMONIA санаттарына жіктейтін машиналық оқыту моделін және қазақша веб-сайтты біріктіреді. TensorFlow және Keras арқылы CNN мен MobileNetV2 үйреттім. Colab-та сақталған модельдерді сайтқа қосып, нақты суретті тексеру, екі модельді салыстыру, Grad-CAM, есеп жүктеу және талдау тарихын жасадым. Бұл презентацияда жобаның мақсатын, орындалу жолын және соңғы нәтижесін көрсетемін. Мұқабадағы өкпе — жасалған иллюстрация.</a:t>
+              <a:t>Tynys өкпе рентгенін NORMAL және PNEUMONIA санаттарына жіктейді. CNN мен MobileNetV2-ні TensorFlow/Keras арқылы үйретіп, қазақша сайтқа қостым. Қазір validation калибрлеуі мен OOD ескертуі де іске қосылды.</a:t>
             </a:r>
           </a:p>
           <a:p xmlns:a="http://schemas.openxmlformats.org/drawingml/2006/main">
@@ -461,17 +463,7 @@
           </a:p>
           <a:p xmlns:a="http://schemas.openxmlformats.org/drawingml/2006/main">
             <a:r>
-              <a:t>Дереккөздер:</a:t>
-            </a:r>
-          </a:p>
-          <a:p xmlns:a="http://schemas.openxmlformats.org/drawingml/2006/main">
-            <a:r>
-              <a:t/>
-            </a:r>
-          </a:p>
-          <a:p xmlns:a="http://schemas.openxmlformats.org/drawingml/2006/main">
-            <a:r>
-              <a:t>Жоба: outputs/tynys-site. Нақты метрикалар: model/test_metrics.csv, 20261013_110349_325207.zip архиві.</a:t>
+              <a:t>Дереккөздер: site/model/model_config.json; test_metrics.csv; mcnemar.json; external_validation.json; training/calibration_report.json.</a:t>
             </a:r>
           </a:p>
         </p:txBody>
@@ -541,7 +533,7 @@
           <a:lstStyle xmlns:a="http://schemas.openxmlformats.org/drawingml/2006/main"/>
           <a:p xmlns:a="http://schemas.openxmlformats.org/drawingml/2006/main">
             <a:r>
-              <a:t>Жобада деректерді тазалап, CNN және MobileNetV2 модельдерін үйреттім. Соңғы тестте MobileNetV2 accuracy 89,16% және recall 96,12% көрсетті. Модельдерді қазақша сайтқа қосып, сурет тексеру, салыстыру, Grad-CAM, есеп жүктеу және сессия тарихын іске асырдым. Қазіргі сайт жергілікті компьютерде жұмыс істейді. Келесі кезең — модельді сыртқы деректе тексеру және тиісті белгілері бар жаңа датасетпен бірнеше ауруға кеңейту. Бір суретте бірнеше белгі болуы мүмкін, сондықтан multi-label classification қажет. Бұл мүмкіндік әзірге жоспар. Қазіргі модель екі класқа арналған. NORMAL жауабы барлық ауруды жоққа шығармайды. Клиникалық қолдану үшін мамандармен бөлек тексеру қажет.</a:t>
+              <a:t>Калибрлеу, OOD және DICOM жұмыс істейді, 40 тест өтті. Docker конфигурациясы бар, бірақ daemon өшірулі болғандықтан контейнер тексерілмеді. Келесі кезең — ensemble, кейін multi-label жеке эксперименті.</a:t>
             </a:r>
           </a:p>
           <a:p xmlns:a="http://schemas.openxmlformats.org/drawingml/2006/main">
@@ -551,7 +543,77 @@
           </a:p>
           <a:p xmlns:a="http://schemas.openxmlformats.org/drawingml/2006/main">
             <a:r>
-              <a:t>Дереккөздер:</a:t>
+              <a:t>Дереккөздер: site/model/model_config.json; test_metrics.csv; mcnemar.json; external_validation.json; training/calibration_report.json.</a:t>
+            </a:r>
+          </a:p>
+        </p:txBody>
+      </p:sp>
+      <p:sp>
+        <p:nvSpPr>
+          <p:cNvPr id="4" name="Slide Number Placeholder 3"/>
+          <p:cNvSpPr>
+            <a:spLocks xmlns:a="http://schemas.openxmlformats.org/drawingml/2006/main" noGrp="1"/>
+          </p:cNvSpPr>
+          <p:nvPr>
+            <p:ph type="sldNum" idx="5"/>
+          </p:nvPr>
+        </p:nvSpPr>
+        <p:spPr/>
+        <p:txBody>
+          <a:bodyPr xmlns:a="http://schemas.openxmlformats.org/drawingml/2006/main"/>
+          <a:lstStyle xmlns:a="http://schemas.openxmlformats.org/drawingml/2006/main"/>
+          <a:p xmlns:a="http://schemas.openxmlformats.org/drawingml/2006/main"/>
+        </p:txBody>
+      </p:sp>
+    </p:spTree>
+  </p:cSld>
+  <p:clrMapOvr>
+    <a:masterClrMapping xmlns:a="http://schemas.openxmlformats.org/drawingml/2006/main"/>
+  </p:clrMapOvr>
+</p:notes>
+</file>
+
+<file path=ppt/notesSlides/notesSlide11.xml><?xml version="1.0" encoding="utf-8"?>
+<p:notes xmlns:p="http://schemas.openxmlformats.org/presentationml/2006/main">
+  <p:cSld>
+    <p:spTree>
+      <p:nvGrpSpPr>
+        <p:cNvPr id="1" name=""/>
+        <p:cNvGrpSpPr/>
+        <p:nvPr/>
+      </p:nvGrpSpPr>
+      <p:grpSpPr>
+        <a:xfrm xmlns:a="http://schemas.openxmlformats.org/drawingml/2006/main"/>
+      </p:grpSpPr>
+      <p:sp>
+        <p:nvSpPr>
+          <p:cNvPr id="2" name="Slide Image Placeholder 1"/>
+          <p:cNvSpPr>
+            <a:spLocks xmlns:a="http://schemas.openxmlformats.org/drawingml/2006/main" noGrp="1"/>
+          </p:cNvSpPr>
+          <p:nvPr>
+            <p:ph type="sldImg" idx="0"/>
+          </p:nvPr>
+        </p:nvSpPr>
+        <p:spPr/>
+      </p:sp>
+      <p:sp>
+        <p:nvSpPr>
+          <p:cNvPr id="3" name="Notes Placeholder 2"/>
+          <p:cNvSpPr>
+            <a:spLocks xmlns:a="http://schemas.openxmlformats.org/drawingml/2006/main" noGrp="1"/>
+          </p:cNvSpPr>
+          <p:nvPr>
+            <p:ph type="body" idx="1"/>
+          </p:nvPr>
+        </p:nvSpPr>
+        <p:spPr/>
+        <p:txBody>
+          <a:bodyPr xmlns:a="http://schemas.openxmlformats.org/drawingml/2006/main"/>
+          <a:lstStyle xmlns:a="http://schemas.openxmlformats.org/drawingml/2006/main"/>
+          <a:p xmlns:a="http://schemas.openxmlformats.org/drawingml/2006/main">
+            <a:r>
+              <a:t>OpenI-дің сол 200 суретін жаңа калибрленген балл және 0,745 шегімен қайта бағаладым. Accuracy 55,00%, recall 57,50%, AUC 0,5442. Таңдау мен шекті сыртқы белгілерге қарап өзгерткен жоқпын. Report UID — surrogate топ, нақты пациент ID толық расталмаған.</a:t>
             </a:r>
           </a:p>
           <a:p xmlns:a="http://schemas.openxmlformats.org/drawingml/2006/main">
@@ -561,7 +623,87 @@
           </a:p>
           <a:p xmlns:a="http://schemas.openxmlformats.org/drawingml/2006/main">
             <a:r>
-              <a:t>Жоба: outputs/tynys-site. Нақты метрикалар: model/test_metrics.csv, 20261013_110349_325207.zip архиві.</a:t>
+              <a:t>Дереккөздер: site/model/model_config.json; test_metrics.csv; mcnemar.json; external_validation.json; training/calibration_report.json.</a:t>
+            </a:r>
+          </a:p>
+        </p:txBody>
+      </p:sp>
+      <p:sp>
+        <p:nvSpPr>
+          <p:cNvPr id="4" name="Slide Number Placeholder 3"/>
+          <p:cNvSpPr>
+            <a:spLocks xmlns:a="http://schemas.openxmlformats.org/drawingml/2006/main" noGrp="1"/>
+          </p:cNvSpPr>
+          <p:nvPr>
+            <p:ph type="sldNum" idx="5"/>
+          </p:nvPr>
+        </p:nvSpPr>
+        <p:spPr/>
+        <p:txBody>
+          <a:bodyPr xmlns:a="http://schemas.openxmlformats.org/drawingml/2006/main"/>
+          <a:lstStyle xmlns:a="http://schemas.openxmlformats.org/drawingml/2006/main"/>
+          <a:p xmlns:a="http://schemas.openxmlformats.org/drawingml/2006/main"/>
+        </p:txBody>
+      </p:sp>
+    </p:spTree>
+  </p:cSld>
+  <p:clrMapOvr>
+    <a:masterClrMapping xmlns:a="http://schemas.openxmlformats.org/drawingml/2006/main"/>
+  </p:clrMapOvr>
+</p:notes>
+</file>
+
+<file path=ppt/notesSlides/notesSlide12.xml><?xml version="1.0" encoding="utf-8"?>
+<p:notes xmlns:p="http://schemas.openxmlformats.org/presentationml/2006/main">
+  <p:cSld>
+    <p:spTree>
+      <p:nvGrpSpPr>
+        <p:cNvPr id="1" name=""/>
+        <p:cNvGrpSpPr/>
+        <p:nvPr/>
+      </p:nvGrpSpPr>
+      <p:grpSpPr>
+        <a:xfrm xmlns:a="http://schemas.openxmlformats.org/drawingml/2006/main"/>
+      </p:grpSpPr>
+      <p:sp>
+        <p:nvSpPr>
+          <p:cNvPr id="2" name="Slide Image Placeholder 1"/>
+          <p:cNvSpPr>
+            <a:spLocks xmlns:a="http://schemas.openxmlformats.org/drawingml/2006/main" noGrp="1"/>
+          </p:cNvSpPr>
+          <p:nvPr>
+            <p:ph type="sldImg" idx="0"/>
+          </p:nvPr>
+        </p:nvSpPr>
+        <p:spPr/>
+      </p:sp>
+      <p:sp>
+        <p:nvSpPr>
+          <p:cNvPr id="3" name="Notes Placeholder 2"/>
+          <p:cNvSpPr>
+            <a:spLocks xmlns:a="http://schemas.openxmlformats.org/drawingml/2006/main" noGrp="1"/>
+          </p:cNvSpPr>
+          <p:nvPr>
+            <p:ph type="body" idx="1"/>
+          </p:nvPr>
+        </p:nvSpPr>
+        <p:spPr/>
+        <p:txBody>
+          <a:bodyPr xmlns:a="http://schemas.openxmlformats.org/drawingml/2006/main"/>
+          <a:lstStyle xmlns:a="http://schemas.openxmlformats.org/drawingml/2006/main"/>
+          <a:p xmlns:a="http://schemas.openxmlformats.org/drawingml/2006/main">
+            <a:r>
+              <a:t>952 validation файлының бәрі SHA-256 бойынша тексерілді. MobileNetV2 T=0,97996, CNN T=0,68203. OOD 1280 белгі мен covariance арқылы есептелді, 95-процентиль шегі 26,3409. Non-X-ray сапасы бөлек тексерілген жоқ. Бұл оқу прототипі, клиникалық қолдануға бөлек тексеру қажет.</a:t>
+            </a:r>
+          </a:p>
+          <a:p xmlns:a="http://schemas.openxmlformats.org/drawingml/2006/main">
+            <a:r>
+              <a:t/>
+            </a:r>
+          </a:p>
+          <a:p xmlns:a="http://schemas.openxmlformats.org/drawingml/2006/main">
+            <a:r>
+              <a:t>Дереккөздер: site/model/model_config.json; test_metrics.csv; mcnemar.json; external_validation.json; training/calibration_report.json.</a:t>
             </a:r>
           </a:p>
         </p:txBody>
@@ -631,7 +773,7 @@
           <a:lstStyle xmlns:a="http://schemas.openxmlformats.org/drawingml/2006/main"/>
           <a:p xmlns:a="http://schemas.openxmlformats.org/drawingml/2006/main">
             <a:r>
-              <a:t>Бастапқы мәселе — аймақтарда рентгенді талдайтын мамандардың жетіспеушілігі және суреттерді жылдам бастапқы сұрыптау қажеттілігі. Жоба осы міндетке машиналық оқыту арқылы қолдау көрсету мүмкіндігін зерттейді. Нақты мақсатым — екі санатқа жіктейтін модель үйретіп, оны пайдалануға ыңғайлы сайтқа қосу. Пайдаланушы суретті жүктеп, санатты, баллды, шешім шегін және визуал түсіндірмені көреді. Екі модельді бірдей тестте салыстыру арқылы Transfer Learning тиімділігін тексердім. Мамандардың уақытын үнемдеу — көзделген пайда. Бұл әсерді нақты клиникада өлшеген жоқпын.</a:t>
+              <a:t>Мәселе — рентгенді бастапқы сұрыптауға қолдау қажеттілігі. Мақсат — екі санатты классификация моделін ыңғайлы сайт арқылы қолдану. Клиникада маман уақытын қаншалықты үнемдейтінін өлшеген жоқпын.</a:t>
             </a:r>
           </a:p>
           <a:p xmlns:a="http://schemas.openxmlformats.org/drawingml/2006/main">
@@ -641,17 +783,7 @@
           </a:p>
           <a:p xmlns:a="http://schemas.openxmlformats.org/drawingml/2006/main">
             <a:r>
-              <a:t>Дереккөздер:</a:t>
-            </a:r>
-          </a:p>
-          <a:p xmlns:a="http://schemas.openxmlformats.org/drawingml/2006/main">
-            <a:r>
-              <a:t/>
-            </a:r>
-          </a:p>
-          <a:p xmlns:a="http://schemas.openxmlformats.org/drawingml/2006/main">
-            <a:r>
-              <a:t>Жоба: outputs/tynys-site. Нақты метрикалар: model/test_metrics.csv, 20261013_110349_325207.zip архиві.</a:t>
+              <a:t>Дереккөздер: site/model/model_config.json; test_metrics.csv; mcnemar.json; external_validation.json; training/calibration_report.json.</a:t>
             </a:r>
           </a:p>
         </p:txBody>
@@ -721,7 +853,7 @@
           <a:lstStyle xmlns:a="http://schemas.openxmlformats.org/drawingml/2006/main"/>
           <a:p xmlns:a="http://schemas.openxmlformats.org/drawingml/2006/main">
             <a:r>
-              <a:t>Kaggle Chest X-Ray Images (Pneumonia) датасетін қолдандым. 5856 жарамды сурет оқылды. Көшірмелерді және тестпен топтық қиылысуларды тексергеннен кейін 5371 сурет қалды. Train 3801, validation 952, test 618 суреттен тұрады. Train модель салмақтарын үйретеді, validation модель кезеңі мен шешім шегін таңдайды, test дайын модельді бағалайды. Тестпен қиылысуына байланысты development жиынынан 453 сурет шығарылды. Файл атауынан алынған топтар ресми пациент ID емес. Бұл шектеуді нәтижені түсіндіргенде ескеру керек.</a:t>
+              <a:t>5856 жарамды суретті тазалағаннан кейін train 3801, validation 952, test 618 сурет қалды. Көшірмелерді SHA-256 және файл атауынан алынған топтармен тексердім. Бұл топтар ресми пациент ID емес.</a:t>
             </a:r>
           </a:p>
           <a:p xmlns:a="http://schemas.openxmlformats.org/drawingml/2006/main">
@@ -731,17 +863,7 @@
           </a:p>
           <a:p xmlns:a="http://schemas.openxmlformats.org/drawingml/2006/main">
             <a:r>
-              <a:t>Дереккөздер:</a:t>
-            </a:r>
-          </a:p>
-          <a:p xmlns:a="http://schemas.openxmlformats.org/drawingml/2006/main">
-            <a:r>
-              <a:t>https://www.kaggle.com/datasets/paultimothymooney/chest-xray-pneumonia</a:t>
-            </a:r>
-          </a:p>
-          <a:p xmlns:a="http://schemas.openxmlformats.org/drawingml/2006/main">
-            <a:r>
-              <a:t>Жоба: outputs/tynys-site. Нақты метрикалар: model/test_metrics.csv, 20261013_110349_325207.zip архиві.</a:t>
+              <a:t>Дереккөздер: site/model/model_config.json; test_metrics.csv; mcnemar.json; external_validation.json; training/calibration_report.json.</a:t>
             </a:r>
           </a:p>
         </p:txBody>
@@ -811,7 +933,7 @@
           <a:lstStyle xmlns:a="http://schemas.openxmlformats.org/drawingml/2006/main"/>
           <a:p xmlns:a="http://schemas.openxmlformats.org/drawingml/2006/main">
             <a:r>
-              <a:t>Екі модельге бірдей бөлінген деректер берілді. RGB суретті пропорциясын сақтап 224-ке 224 пиксельге келтіреміз. CNN барлық белгіні осы датасеттен үйренеді. MobileNetV2 ImageNet-та үйренген бастапқы салмақтарды пайдаланады. Алдымен жаңа классификаторды, кейін соңғы отыз қабаттың BatchNormalization емес қабаттарын кіші learning rate-пен баптадым. Validation loss бойынша fine кезеңін таңдадым. Сайттағы FastAPI сервері сақталған .keras модельдерін жүктейді. Суретті өңдеу мен шешім шегі Colab-тағы конфигурацияға сәйкес келеді. Python және TensorFlow серверде, HTML, CSS және JavaScript браузерде жұмыс істейді.</a:t>
+              <a:t>CNN белгілерді басынан үйренеді. MobileNetV2 ImageNet салмақтарына сүйенеді. Кіріс бұрынғыдай RGB, float32 және resize_with_pad 224×224. Жаңа validation шектері CNN үшін 0,475, MobileNetV2 үшін 0,745. Сыртқы нормализация қосылған жоқ.</a:t>
             </a:r>
           </a:p>
           <a:p xmlns:a="http://schemas.openxmlformats.org/drawingml/2006/main">
@@ -821,17 +943,7 @@
           </a:p>
           <a:p xmlns:a="http://schemas.openxmlformats.org/drawingml/2006/main">
             <a:r>
-              <a:t>Дереккөздер:</a:t>
-            </a:r>
-          </a:p>
-          <a:p xmlns:a="http://schemas.openxmlformats.org/drawingml/2006/main">
-            <a:r>
-              <a:t>https://www.tensorflow.org/tutorials/images/transfer_learning</a:t>
-            </a:r>
-          </a:p>
-          <a:p xmlns:a="http://schemas.openxmlformats.org/drawingml/2006/main">
-            <a:r>
-              <a:t>Жоба: outputs/tynys-site. Нақты метрикалар: model/test_metrics.csv, 20261013_110349_325207.zip архиві.</a:t>
+              <a:t>Дереккөздер: site/model/model_config.json; test_metrics.csv; mcnemar.json; external_validation.json; training/calibration_report.json.</a:t>
             </a:r>
           </a:p>
         </p:txBody>
@@ -901,7 +1013,7 @@
           <a:lstStyle xmlns:a="http://schemas.openxmlformats.org/drawingml/2006/main"/>
           <a:p xmlns:a="http://schemas.openxmlformats.org/drawingml/2006/main">
             <a:r>
-              <a:t>Нейрондық желі x суретін h тета x белгілеріне айналдырады. Соңғы классификатор z тең w транспонирленген h тета x плюс b мәнін есептейді. Sigmoid оны нөл мен бір аралығындағы p баллына айналдырады. Үйрету барысында класс салмағын ескеретін binary cross-entropy азаяды. Шартты есепте z натурал логарифм төрт болса, p 0,8 болады. Ол MobileNetV2 үшін validation арқылы таңдалған 0,740 шегінен жоғары болғандықтан, болжам PNEUMONIA болады. Нақты класс бір, класс салмағы бір болғанда қате минус ln 0,8, шамамен 0,2231. Бұл сандар формуланы түсіндіретін шартты мысал. Модель баллы клиникалық диагноздың ықтималдығы ретінде калибрленбеген.</a:t>
+              <a:t>Модель sigmoid арқылы raw балл шығарады. Оны sigmoid(logit(raw)/T) арқылы калибрлейміз. Шартты raw 0,80 болса, p_cal шамамен 0,804, ол 0,745 шегінен жоғары, сондықтан PNEUMONIA. Binary cross-entropy формуласы үйретудегі raw баллға қатысты.</a:t>
             </a:r>
           </a:p>
           <a:p xmlns:a="http://schemas.openxmlformats.org/drawingml/2006/main">
@@ -911,17 +1023,7 @@
           </a:p>
           <a:p xmlns:a="http://schemas.openxmlformats.org/drawingml/2006/main">
             <a:r>
-              <a:t>Дереккөздер:</a:t>
-            </a:r>
-          </a:p>
-          <a:p xmlns:a="http://schemas.openxmlformats.org/drawingml/2006/main">
-            <a:r>
-              <a:t>https://www.tensorflow.org/api_docs/python/tf/keras/losses/BinaryCrossentropy</a:t>
-            </a:r>
-          </a:p>
-          <a:p xmlns:a="http://schemas.openxmlformats.org/drawingml/2006/main">
-            <a:r>
-              <a:t>Жоба: outputs/tynys-site. Нақты метрикалар: model/test_metrics.csv, 20261013_110349_325207.zip архиві.</a:t>
+              <a:t>Дереккөздер: site/model/model_config.json; test_metrics.csv; mcnemar.json; external_validation.json; training/calibration_report.json.</a:t>
             </a:r>
           </a:p>
         </p:txBody>
@@ -991,7 +1093,7 @@
           <a:lstStyle xmlns:a="http://schemas.openxmlformats.org/drawingml/2006/main"/>
           <a:p xmlns:a="http://schemas.openxmlformats.org/drawingml/2006/main">
             <a:r>
-              <a:t>Соңғы сақталған архивтегі нәтижелерді көрсетіп отырмын. Бірдей 618 тест суретінде CNN accuracy 71,68%, MobileNetV2 accuracy 89,16% көрсетті. Айырма 17,48 пайыздық пункт. MobileNetV2 recall 96,12%, specificity 77,49%, F1 0,9174 және ROC-AUC 0,9581. Қалыпты 231 суреттің 179-ын дұрыс, 52-сін қате PNEUMONIA деп жіктеді. Пневмония санатындағы 387 суреттің 372-сін дұрыс, 15-ін қате NORMAL деп жіктеді. Барлығы 551 дұрыс және 67 қате. 90% accuracy мақсатына жеткен жоқпыз. Бұл көрсеткіштер тек осы эксперименттің тест жиынына қатысты.</a:t>
+              <a:t>Қазіргі калибрленген test: CNN accuracy 71,52%, MobileNetV2 89,16%. MobileNetV2 recall 96,12%, FN 15, FP 52. 90% мақсатына жетпеді. McNemar: CNN-only 19, MobileNetV2-only 128, p=4,83×10⁻²¹.</a:t>
             </a:r>
           </a:p>
           <a:p xmlns:a="http://schemas.openxmlformats.org/drawingml/2006/main">
@@ -1001,17 +1103,7 @@
           </a:p>
           <a:p xmlns:a="http://schemas.openxmlformats.org/drawingml/2006/main">
             <a:r>
-              <a:t>Дереккөздер:</a:t>
-            </a:r>
-          </a:p>
-          <a:p xmlns:a="http://schemas.openxmlformats.org/drawingml/2006/main">
-            <a:r>
-              <a:t/>
-            </a:r>
-          </a:p>
-          <a:p xmlns:a="http://schemas.openxmlformats.org/drawingml/2006/main">
-            <a:r>
-              <a:t>Жоба: outputs/tynys-site. Нақты метрикалар: model/test_metrics.csv, 20261013_110349_325207.zip архиві.</a:t>
+              <a:t>Дереккөздер: site/model/model_config.json; test_metrics.csv; mcnemar.json; external_validation.json; training/calibration_report.json.</a:t>
             </a:r>
           </a:p>
         </p:txBody>
@@ -1081,7 +1173,7 @@
           <a:lstStyle xmlns:a="http://schemas.openxmlformats.org/drawingml/2006/main"/>
           <a:p xmlns:a="http://schemas.openxmlformats.org/drawingml/2006/main">
             <a:r>
-              <a:t>Сайтта JPG немесе PNG суретін жүктеп, талдау батырмасын басамыз. Бір сурет көлемі он екі мегабайтқа дейін, бір топта он суретке дейін жүктеуге болады. CNN және MobileNetV2 бір файлды өз өңдеу тәсілімен тексереді. Әрқайсының болжамын, пневмония санатының баллын және өз шешім шегін салыстырамыз. Скриншотта CNN баллы 0,473713, шегі 0,485 болғандықтан NORMAL. MobileNetV2 баллы 0,083812, шегі 0,740 болғандықтан ол да NORMAL. Екі болжам сәйкес келді. Баллдардың айырмасы қай модель нақты дұрыс екенін өздігінен дәлелдемейді. Бұл — сайттағы нақты орындалған мысал.</a:t>
+              <a:t>Сайт бір суретке екі модельдің калибрленген баллын, санатын және өз шегін көрсетеді. JPG, PNG, CR/DX DICOM қолданылады. Бір топта 10 файлға дейін, әрқайсысы 12 МБ-қа дейін. CT/MR қабылданбайды.</a:t>
             </a:r>
           </a:p>
           <a:p xmlns:a="http://schemas.openxmlformats.org/drawingml/2006/main">
@@ -1091,17 +1183,7 @@
           </a:p>
           <a:p xmlns:a="http://schemas.openxmlformats.org/drawingml/2006/main">
             <a:r>
-              <a:t>Дереккөздер:</a:t>
-            </a:r>
-          </a:p>
-          <a:p xmlns:a="http://schemas.openxmlformats.org/drawingml/2006/main">
-            <a:r>
-              <a:t/>
-            </a:r>
-          </a:p>
-          <a:p xmlns:a="http://schemas.openxmlformats.org/drawingml/2006/main">
-            <a:r>
-              <a:t>Жоба: outputs/tynys-site. Нақты метрикалар: model/test_metrics.csv, 20261013_110349_325207.zip архиві.</a:t>
+              <a:t>Дереккөздер: site/model/model_config.json; test_metrics.csv; mcnemar.json; external_validation.json; training/calibration_report.json.</a:t>
             </a:r>
           </a:p>
         </p:txBody>
@@ -1171,7 +1253,7 @@
           <a:lstStyle xmlns:a="http://schemas.openxmlformats.org/drawingml/2006/main"/>
           <a:p xmlns:a="http://schemas.openxmlformats.org/drawingml/2006/main">
             <a:r>
-              <a:t>Grad-CAM болжамға ықпал еткен аймақтарды жылу картасымен көрсетеді. Сарыдан қызылға қарай ықпал күшейеді. Карта таңдалған санат үшін MobileNetV2-нің соңғы кеңістіктік белгілері мен градиенттерінен есептеледі. Сайтта түпнұсқа мен белгіленген суретті ауыстыруға және картаны PNG ретінде жүктеуге болады. Скриншоттағы мысалда модель PNEUMONIA санатына 0,993 балл берген. Grad-CAM клиникалық зақымның нақты шекарасын көрсетпейді. Ол модельдің шешімін зерттеуге көмектесетін жуық визуал түсіндірме. Сондықтан картаға қарап жаңа медициналық қорытынды қоспаймыз.</a:t>
+              <a:t>Grad-CAM таңдалған санатқа ықпал еткен аймақтарды жуық көрсетеді. Оның reconstructed_score мәні калибрленген емес, raw sigmoid-пен салыстырылады. Карта зақым шекарасы емес. OOD тек ескерту береді, болжамды блоктамайды.</a:t>
             </a:r>
           </a:p>
           <a:p xmlns:a="http://schemas.openxmlformats.org/drawingml/2006/main">
@@ -1181,17 +1263,7 @@
           </a:p>
           <a:p xmlns:a="http://schemas.openxmlformats.org/drawingml/2006/main">
             <a:r>
-              <a:t>Дереккөздер:</a:t>
-            </a:r>
-          </a:p>
-          <a:p xmlns:a="http://schemas.openxmlformats.org/drawingml/2006/main">
-            <a:r>
-              <a:t>https://keras.io/examples/vision/grad_cam/</a:t>
-            </a:r>
-          </a:p>
-          <a:p xmlns:a="http://schemas.openxmlformats.org/drawingml/2006/main">
-            <a:r>
-              <a:t>Жоба: outputs/tynys-site. Нақты метрикалар: model/test_metrics.csv, 20261013_110349_325207.zip архиві.</a:t>
+              <a:t>Дереккөздер: site/model/model_config.json; test_metrics.csv; mcnemar.json; external_validation.json; training/calibration_report.json.</a:t>
             </a:r>
           </a:p>
         </p:txBody>
@@ -1261,7 +1333,7 @@
           <a:lstStyle xmlns:a="http://schemas.openxmlformats.org/drawingml/2006/main"/>
           <a:p xmlns:a="http://schemas.openxmlformats.org/drawingml/2006/main">
             <a:r>
-              <a:t>Талдау нәтижесін мәтін немесе PDF ретінде жүктеуге болады. Есепте сурет, болжам, балл, шешім шегі және екі модельдің салыстыруы бар. PDF түпнұсқа мен Grad-CAM картасын қатар көрсетеді. Түсіндірме баллдың шекпен салыстырылуын жазады. PNEUMONIA болса балл шектен жоғары немесе тең, NORMAL болса төмен. Бұл ереже медициналық себепті толық түсіндірмейді. Осы бет ашық тұрған кезде соңғы жиырма талдау тарихта сақталады. Қайта ашу бұрынғы нәтиже мен суретті көрсетеді. Тарихты тазалау жазбалар мен ағымдағы нәтижені жояды. Бетті жаңартқанда тарих жоғалады.</a:t>
+              <a:t>PDF түпнұсқа, Grad-CAM, T, шешім шегі және салыстыруды көрсетеді. OOD ескертуі де кіреді. NORMAL мен PNEUMONIA беттерінің бір параққа сыйуын тексердім. Тарих тек бет жадында, жаңартқанда жойылады.</a:t>
             </a:r>
           </a:p>
           <a:p xmlns:a="http://schemas.openxmlformats.org/drawingml/2006/main">
@@ -1271,17 +1343,7 @@
           </a:p>
           <a:p xmlns:a="http://schemas.openxmlformats.org/drawingml/2006/main">
             <a:r>
-              <a:t>Дереккөздер:</a:t>
-            </a:r>
-          </a:p>
-          <a:p xmlns:a="http://schemas.openxmlformats.org/drawingml/2006/main">
-            <a:r>
-              <a:t/>
-            </a:r>
-          </a:p>
-          <a:p xmlns:a="http://schemas.openxmlformats.org/drawingml/2006/main">
-            <a:r>
-              <a:t>Жоба: outputs/tynys-site. Нақты метрикалар: model/test_metrics.csv, 20261013_110349_325207.zip архиві.</a:t>
+              <a:t>Дереккөздер: site/model/model_config.json; test_metrics.csv; mcnemar.json; external_validation.json; training/calibration_report.json.</a:t>
             </a:r>
           </a:p>
         </p:txBody>
@@ -1379,6 +1441,7 @@
                 <a:spcPts val="0"/>
               </a:spcAft>
               <a:buNone/>
+              <a:defRPr/>
             </a:lvl1pPr>
             <a:lvl2pPr marL="0" indent="0">
               <a:lnSpc>
@@ -1391,6 +1454,7 @@
                 <a:spcPts val="0"/>
               </a:spcAft>
               <a:buNone/>
+              <a:defRPr/>
             </a:lvl2pPr>
             <a:lvl3pPr marL="0" indent="0">
               <a:lnSpc>
@@ -1403,6 +1467,7 @@
                 <a:spcPts val="0"/>
               </a:spcAft>
               <a:buNone/>
+              <a:defRPr/>
             </a:lvl3pPr>
             <a:lvl4pPr marL="0" indent="0">
               <a:lnSpc>
@@ -1415,6 +1480,7 @@
                 <a:spcPts val="0"/>
               </a:spcAft>
               <a:buNone/>
+              <a:defRPr/>
             </a:lvl4pPr>
             <a:lvl5pPr marL="0" indent="0">
               <a:lnSpc>
@@ -1427,6 +1493,7 @@
                 <a:spcPts val="0"/>
               </a:spcAft>
               <a:buNone/>
+              <a:defRPr/>
             </a:lvl5pPr>
             <a:lvl6pPr marL="0" indent="0">
               <a:lnSpc>
@@ -1439,6 +1506,7 @@
                 <a:spcPts val="0"/>
               </a:spcAft>
               <a:buNone/>
+              <a:defRPr/>
             </a:lvl6pPr>
             <a:lvl7pPr marL="0" indent="0">
               <a:lnSpc>
@@ -1451,6 +1519,7 @@
                 <a:spcPts val="0"/>
               </a:spcAft>
               <a:buNone/>
+              <a:defRPr/>
             </a:lvl7pPr>
             <a:lvl8pPr marL="0" indent="0">
               <a:lnSpc>
@@ -1463,6 +1532,7 @@
                 <a:spcPts val="0"/>
               </a:spcAft>
               <a:buNone/>
+              <a:defRPr/>
             </a:lvl8pPr>
             <a:lvl9pPr marL="0" indent="0">
               <a:lnSpc>
@@ -1475,6 +1545,7 @@
                 <a:spcPts val="0"/>
               </a:spcAft>
               <a:buNone/>
+              <a:defRPr/>
             </a:lvl9pPr>
           </a:lstStyle>
           <a:p xmlns:a="http://schemas.openxmlformats.org/drawingml/2006/main"/>
@@ -1536,6 +1607,7 @@
                 <a:spcPts val="0"/>
               </a:spcAft>
               <a:buNone/>
+              <a:defRPr/>
             </a:lvl1pPr>
             <a:lvl2pPr marL="0" indent="0">
               <a:lnSpc>
@@ -1548,6 +1620,7 @@
                 <a:spcPts val="0"/>
               </a:spcAft>
               <a:buNone/>
+              <a:defRPr/>
             </a:lvl2pPr>
             <a:lvl3pPr marL="0" indent="0">
               <a:lnSpc>
@@ -1560,6 +1633,7 @@
                 <a:spcPts val="0"/>
               </a:spcAft>
               <a:buNone/>
+              <a:defRPr/>
             </a:lvl3pPr>
             <a:lvl4pPr marL="0" indent="0">
               <a:lnSpc>
@@ -1572,6 +1646,7 @@
                 <a:spcPts val="0"/>
               </a:spcAft>
               <a:buNone/>
+              <a:defRPr/>
             </a:lvl4pPr>
             <a:lvl5pPr marL="0" indent="0">
               <a:lnSpc>
@@ -1584,6 +1659,7 @@
                 <a:spcPts val="0"/>
               </a:spcAft>
               <a:buNone/>
+              <a:defRPr/>
             </a:lvl5pPr>
             <a:lvl6pPr marL="0" indent="0">
               <a:lnSpc>
@@ -1596,6 +1672,7 @@
                 <a:spcPts val="0"/>
               </a:spcAft>
               <a:buNone/>
+              <a:defRPr/>
             </a:lvl6pPr>
             <a:lvl7pPr marL="0" indent="0">
               <a:lnSpc>
@@ -1608,6 +1685,7 @@
                 <a:spcPts val="0"/>
               </a:spcAft>
               <a:buNone/>
+              <a:defRPr/>
             </a:lvl7pPr>
             <a:lvl8pPr marL="0" indent="0">
               <a:lnSpc>
@@ -1620,6 +1698,7 @@
                 <a:spcPts val="0"/>
               </a:spcAft>
               <a:buNone/>
+              <a:defRPr/>
             </a:lvl8pPr>
             <a:lvl9pPr marL="0" indent="0">
               <a:lnSpc>
@@ -1632,6 +1711,7 @@
                 <a:spcPts val="0"/>
               </a:spcAft>
               <a:buNone/>
+              <a:defRPr/>
             </a:lvl9pPr>
           </a:lstStyle>
           <a:p xmlns:a="http://schemas.openxmlformats.org/drawingml/2006/main"/>
@@ -1710,6 +1790,7 @@
                 <a:spcPts val="0"/>
               </a:spcAft>
               <a:buNone/>
+              <a:defRPr/>
             </a:lvl1pPr>
             <a:lvl2pPr marL="0" indent="0">
               <a:lnSpc>
@@ -1722,6 +1803,7 @@
                 <a:spcPts val="0"/>
               </a:spcAft>
               <a:buNone/>
+              <a:defRPr/>
             </a:lvl2pPr>
             <a:lvl3pPr marL="0" indent="0">
               <a:lnSpc>
@@ -1734,6 +1816,7 @@
                 <a:spcPts val="0"/>
               </a:spcAft>
               <a:buNone/>
+              <a:defRPr/>
             </a:lvl3pPr>
             <a:lvl4pPr marL="0" indent="0">
               <a:lnSpc>
@@ -1746,6 +1829,7 @@
                 <a:spcPts val="0"/>
               </a:spcAft>
               <a:buNone/>
+              <a:defRPr/>
             </a:lvl4pPr>
             <a:lvl5pPr marL="0" indent="0">
               <a:lnSpc>
@@ -1758,6 +1842,7 @@
                 <a:spcPts val="0"/>
               </a:spcAft>
               <a:buNone/>
+              <a:defRPr/>
             </a:lvl5pPr>
             <a:lvl6pPr marL="0" indent="0">
               <a:lnSpc>
@@ -1770,6 +1855,7 @@
                 <a:spcPts val="0"/>
               </a:spcAft>
               <a:buNone/>
+              <a:defRPr/>
             </a:lvl6pPr>
             <a:lvl7pPr marL="0" indent="0">
               <a:lnSpc>
@@ -1782,6 +1868,7 @@
                 <a:spcPts val="0"/>
               </a:spcAft>
               <a:buNone/>
+              <a:defRPr/>
             </a:lvl7pPr>
             <a:lvl8pPr marL="0" indent="0">
               <a:lnSpc>
@@ -1794,6 +1881,7 @@
                 <a:spcPts val="0"/>
               </a:spcAft>
               <a:buNone/>
+              <a:defRPr/>
             </a:lvl8pPr>
             <a:lvl9pPr marL="0" indent="0">
               <a:lnSpc>
@@ -1806,6 +1894,7 @@
                 <a:spcPts val="0"/>
               </a:spcAft>
               <a:buNone/>
+              <a:defRPr/>
             </a:lvl9pPr>
           </a:lstStyle>
           <a:p xmlns:a="http://schemas.openxmlformats.org/drawingml/2006/main"/>
@@ -1884,6 +1973,7 @@
                 <a:spcPts val="0"/>
               </a:spcAft>
               <a:buNone/>
+              <a:defRPr/>
             </a:lvl1pPr>
             <a:lvl2pPr marL="0" indent="0">
               <a:lnSpc>
@@ -1896,6 +1986,7 @@
                 <a:spcPts val="0"/>
               </a:spcAft>
               <a:buNone/>
+              <a:defRPr/>
             </a:lvl2pPr>
             <a:lvl3pPr marL="0" indent="0">
               <a:lnSpc>
@@ -1908,6 +1999,7 @@
                 <a:spcPts val="0"/>
               </a:spcAft>
               <a:buNone/>
+              <a:defRPr/>
             </a:lvl3pPr>
             <a:lvl4pPr marL="0" indent="0">
               <a:lnSpc>
@@ -1920,6 +2012,7 @@
                 <a:spcPts val="0"/>
               </a:spcAft>
               <a:buNone/>
+              <a:defRPr/>
             </a:lvl4pPr>
             <a:lvl5pPr marL="0" indent="0">
               <a:lnSpc>
@@ -1932,6 +2025,7 @@
                 <a:spcPts val="0"/>
               </a:spcAft>
               <a:buNone/>
+              <a:defRPr/>
             </a:lvl5pPr>
             <a:lvl6pPr marL="0" indent="0">
               <a:lnSpc>
@@ -1944,6 +2038,7 @@
                 <a:spcPts val="0"/>
               </a:spcAft>
               <a:buNone/>
+              <a:defRPr/>
             </a:lvl6pPr>
             <a:lvl7pPr marL="0" indent="0">
               <a:lnSpc>
@@ -1956,6 +2051,7 @@
                 <a:spcPts val="0"/>
               </a:spcAft>
               <a:buNone/>
+              <a:defRPr/>
             </a:lvl7pPr>
             <a:lvl8pPr marL="0" indent="0">
               <a:lnSpc>
@@ -1968,6 +2064,7 @@
                 <a:spcPts val="0"/>
               </a:spcAft>
               <a:buNone/>
+              <a:defRPr/>
             </a:lvl8pPr>
             <a:lvl9pPr marL="0" indent="0">
               <a:lnSpc>
@@ -1980,6 +2077,7 @@
                 <a:spcPts val="0"/>
               </a:spcAft>
               <a:buNone/>
+              <a:defRPr/>
             </a:lvl9pPr>
           </a:lstStyle>
           <a:p xmlns:a="http://schemas.openxmlformats.org/drawingml/2006/main"/>
@@ -2041,6 +2139,7 @@
                 <a:spcPts val="1200"/>
               </a:spcAft>
               <a:buChar char="•"/>
+              <a:defRPr/>
             </a:lvl1pPr>
             <a:lvl2pPr marL="533400" indent="-228600">
               <a:lnSpc>
@@ -2053,6 +2152,7 @@
                 <a:spcPts val="1200"/>
               </a:spcAft>
               <a:buChar char="•"/>
+              <a:defRPr/>
             </a:lvl2pPr>
             <a:lvl3pPr marL="838200" indent="-228600">
               <a:lnSpc>
@@ -2065,6 +2165,7 @@
                 <a:spcPts val="1200"/>
               </a:spcAft>
               <a:buChar char="•"/>
+              <a:defRPr/>
             </a:lvl3pPr>
             <a:lvl4pPr marL="1143000" indent="-228600">
               <a:lnSpc>
@@ -2077,6 +2178,7 @@
                 <a:spcPts val="1200"/>
               </a:spcAft>
               <a:buChar char="•"/>
+              <a:defRPr/>
             </a:lvl4pPr>
             <a:lvl5pPr marL="1447800" indent="-228600">
               <a:lnSpc>
@@ -2089,6 +2191,7 @@
                 <a:spcPts val="1200"/>
               </a:spcAft>
               <a:buChar char="•"/>
+              <a:defRPr/>
             </a:lvl5pPr>
             <a:lvl6pPr marL="1752600" indent="-228600">
               <a:lnSpc>
@@ -2101,6 +2204,7 @@
                 <a:spcPts val="1200"/>
               </a:spcAft>
               <a:buChar char="•"/>
+              <a:defRPr/>
             </a:lvl6pPr>
             <a:lvl7pPr marL="2057400" indent="-228600">
               <a:lnSpc>
@@ -2113,6 +2217,7 @@
                 <a:spcPts val="1200"/>
               </a:spcAft>
               <a:buChar char="•"/>
+              <a:defRPr/>
             </a:lvl7pPr>
             <a:lvl8pPr marL="2362200" indent="-228600">
               <a:lnSpc>
@@ -2125,6 +2230,7 @@
                 <a:spcPts val="1200"/>
               </a:spcAft>
               <a:buChar char="•"/>
+              <a:defRPr/>
             </a:lvl8pPr>
             <a:lvl9pPr marL="2667000" indent="-228600">
               <a:lnSpc>
@@ -2137,6 +2243,7 @@
                 <a:spcPts val="1200"/>
               </a:spcAft>
               <a:buChar char="•"/>
+              <a:defRPr/>
             </a:lvl9pPr>
           </a:lstStyle>
           <a:p xmlns:a="http://schemas.openxmlformats.org/drawingml/2006/main"/>
@@ -2215,6 +2322,7 @@
                 <a:spcPts val="0"/>
               </a:spcAft>
               <a:buNone/>
+              <a:defRPr/>
             </a:lvl1pPr>
             <a:lvl2pPr marL="0" indent="0">
               <a:lnSpc>
@@ -2227,6 +2335,7 @@
                 <a:spcPts val="0"/>
               </a:spcAft>
               <a:buNone/>
+              <a:defRPr/>
             </a:lvl2pPr>
             <a:lvl3pPr marL="0" indent="0">
               <a:lnSpc>
@@ -2239,6 +2348,7 @@
                 <a:spcPts val="0"/>
               </a:spcAft>
               <a:buNone/>
+              <a:defRPr/>
             </a:lvl3pPr>
             <a:lvl4pPr marL="0" indent="0">
               <a:lnSpc>
@@ -2251,6 +2361,7 @@
                 <a:spcPts val="0"/>
               </a:spcAft>
               <a:buNone/>
+              <a:defRPr/>
             </a:lvl4pPr>
             <a:lvl5pPr marL="0" indent="0">
               <a:lnSpc>
@@ -2263,6 +2374,7 @@
                 <a:spcPts val="0"/>
               </a:spcAft>
               <a:buNone/>
+              <a:defRPr/>
             </a:lvl5pPr>
             <a:lvl6pPr marL="0" indent="0">
               <a:lnSpc>
@@ -2275,6 +2387,7 @@
                 <a:spcPts val="0"/>
               </a:spcAft>
               <a:buNone/>
+              <a:defRPr/>
             </a:lvl6pPr>
             <a:lvl7pPr marL="0" indent="0">
               <a:lnSpc>
@@ -2287,6 +2400,7 @@
                 <a:spcPts val="0"/>
               </a:spcAft>
               <a:buNone/>
+              <a:defRPr/>
             </a:lvl7pPr>
             <a:lvl8pPr marL="0" indent="0">
               <a:lnSpc>
@@ -2299,6 +2413,7 @@
                 <a:spcPts val="0"/>
               </a:spcAft>
               <a:buNone/>
+              <a:defRPr/>
             </a:lvl8pPr>
             <a:lvl9pPr marL="0" indent="0">
               <a:lnSpc>
@@ -2311,6 +2426,7 @@
                 <a:spcPts val="0"/>
               </a:spcAft>
               <a:buNone/>
+              <a:defRPr/>
             </a:lvl9pPr>
           </a:lstStyle>
           <a:p xmlns:a="http://schemas.openxmlformats.org/drawingml/2006/main"/>
@@ -2372,6 +2488,7 @@
                 <a:spcPts val="1200"/>
               </a:spcAft>
               <a:buChar char="•"/>
+              <a:defRPr/>
             </a:lvl1pPr>
             <a:lvl2pPr marL="533400" indent="-228600">
               <a:lnSpc>
@@ -2384,6 +2501,7 @@
                 <a:spcPts val="1200"/>
               </a:spcAft>
               <a:buChar char="•"/>
+              <a:defRPr/>
             </a:lvl2pPr>
             <a:lvl3pPr marL="838200" indent="-228600">
               <a:lnSpc>
@@ -2396,6 +2514,7 @@
                 <a:spcPts val="1200"/>
               </a:spcAft>
               <a:buChar char="•"/>
+              <a:defRPr/>
             </a:lvl3pPr>
             <a:lvl4pPr marL="1143000" indent="-228600">
               <a:lnSpc>
@@ -2408,6 +2527,7 @@
                 <a:spcPts val="1200"/>
               </a:spcAft>
               <a:buChar char="•"/>
+              <a:defRPr/>
             </a:lvl4pPr>
             <a:lvl5pPr marL="1447800" indent="-228600">
               <a:lnSpc>
@@ -2420,6 +2540,7 @@
                 <a:spcPts val="1200"/>
               </a:spcAft>
               <a:buChar char="•"/>
+              <a:defRPr/>
             </a:lvl5pPr>
             <a:lvl6pPr marL="1752600" indent="-228600">
               <a:lnSpc>
@@ -2432,6 +2553,7 @@
                 <a:spcPts val="1200"/>
               </a:spcAft>
               <a:buChar char="•"/>
+              <a:defRPr/>
             </a:lvl6pPr>
             <a:lvl7pPr marL="2057400" indent="-228600">
               <a:lnSpc>
@@ -2444,6 +2566,7 @@
                 <a:spcPts val="1200"/>
               </a:spcAft>
               <a:buChar char="•"/>
+              <a:defRPr/>
             </a:lvl7pPr>
             <a:lvl8pPr marL="2362200" indent="-228600">
               <a:lnSpc>
@@ -2456,6 +2579,7 @@
                 <a:spcPts val="1200"/>
               </a:spcAft>
               <a:buChar char="•"/>
+              <a:defRPr/>
             </a:lvl8pPr>
             <a:lvl9pPr marL="2667000" indent="-228600">
               <a:lnSpc>
@@ -2468,6 +2592,7 @@
                 <a:spcPts val="1200"/>
               </a:spcAft>
               <a:buChar char="•"/>
+              <a:defRPr/>
             </a:lvl9pPr>
           </a:lstStyle>
           <a:p xmlns:a="http://schemas.openxmlformats.org/drawingml/2006/main"/>
@@ -2529,6 +2654,7 @@
                 <a:spcPts val="1200"/>
               </a:spcAft>
               <a:buChar char="•"/>
+              <a:defRPr/>
             </a:lvl1pPr>
             <a:lvl2pPr marL="533400" indent="-228600">
               <a:lnSpc>
@@ -2541,6 +2667,7 @@
                 <a:spcPts val="1200"/>
               </a:spcAft>
               <a:buChar char="•"/>
+              <a:defRPr/>
             </a:lvl2pPr>
             <a:lvl3pPr marL="838200" indent="-228600">
               <a:lnSpc>
@@ -2553,6 +2680,7 @@
                 <a:spcPts val="1200"/>
               </a:spcAft>
               <a:buChar char="•"/>
+              <a:defRPr/>
             </a:lvl3pPr>
             <a:lvl4pPr marL="1143000" indent="-228600">
               <a:lnSpc>
@@ -2565,6 +2693,7 @@
                 <a:spcPts val="1200"/>
               </a:spcAft>
               <a:buChar char="•"/>
+              <a:defRPr/>
             </a:lvl4pPr>
             <a:lvl5pPr marL="1447800" indent="-228600">
               <a:lnSpc>
@@ -2577,6 +2706,7 @@
                 <a:spcPts val="1200"/>
               </a:spcAft>
               <a:buChar char="•"/>
+              <a:defRPr/>
             </a:lvl5pPr>
             <a:lvl6pPr marL="1752600" indent="-228600">
               <a:lnSpc>
@@ -2589,6 +2719,7 @@
                 <a:spcPts val="1200"/>
               </a:spcAft>
               <a:buChar char="•"/>
+              <a:defRPr/>
             </a:lvl6pPr>
             <a:lvl7pPr marL="2057400" indent="-228600">
               <a:lnSpc>
@@ -2601,6 +2732,7 @@
                 <a:spcPts val="1200"/>
               </a:spcAft>
               <a:buChar char="•"/>
+              <a:defRPr/>
             </a:lvl7pPr>
             <a:lvl8pPr marL="2362200" indent="-228600">
               <a:lnSpc>
@@ -2613,6 +2745,7 @@
                 <a:spcPts val="1200"/>
               </a:spcAft>
               <a:buChar char="•"/>
+              <a:defRPr/>
             </a:lvl8pPr>
             <a:lvl9pPr marL="2667000" indent="-228600">
               <a:lnSpc>
@@ -2625,6 +2758,7 @@
                 <a:spcPts val="1200"/>
               </a:spcAft>
               <a:buChar char="•"/>
+              <a:defRPr/>
             </a:lvl9pPr>
           </a:lstStyle>
           <a:p xmlns:a="http://schemas.openxmlformats.org/drawingml/2006/main"/>
@@ -2703,6 +2837,7 @@
                 <a:spcPts val="0"/>
               </a:spcAft>
               <a:buNone/>
+              <a:defRPr/>
             </a:lvl1pPr>
             <a:lvl2pPr marL="0" indent="0">
               <a:lnSpc>
@@ -2715,6 +2850,7 @@
                 <a:spcPts val="0"/>
               </a:spcAft>
               <a:buNone/>
+              <a:defRPr/>
             </a:lvl2pPr>
             <a:lvl3pPr marL="0" indent="0">
               <a:lnSpc>
@@ -2727,6 +2863,7 @@
                 <a:spcPts val="0"/>
               </a:spcAft>
               <a:buNone/>
+              <a:defRPr/>
             </a:lvl3pPr>
             <a:lvl4pPr marL="0" indent="0">
               <a:lnSpc>
@@ -2739,6 +2876,7 @@
                 <a:spcPts val="0"/>
               </a:spcAft>
               <a:buNone/>
+              <a:defRPr/>
             </a:lvl4pPr>
             <a:lvl5pPr marL="0" indent="0">
               <a:lnSpc>
@@ -2751,6 +2889,7 @@
                 <a:spcPts val="0"/>
               </a:spcAft>
               <a:buNone/>
+              <a:defRPr/>
             </a:lvl5pPr>
             <a:lvl6pPr marL="0" indent="0">
               <a:lnSpc>
@@ -2763,6 +2902,7 @@
                 <a:spcPts val="0"/>
               </a:spcAft>
               <a:buNone/>
+              <a:defRPr/>
             </a:lvl6pPr>
             <a:lvl7pPr marL="0" indent="0">
               <a:lnSpc>
@@ -2775,6 +2915,7 @@
                 <a:spcPts val="0"/>
               </a:spcAft>
               <a:buNone/>
+              <a:defRPr/>
             </a:lvl7pPr>
             <a:lvl8pPr marL="0" indent="0">
               <a:lnSpc>
@@ -2787,6 +2928,7 @@
                 <a:spcPts val="0"/>
               </a:spcAft>
               <a:buNone/>
+              <a:defRPr/>
             </a:lvl8pPr>
             <a:lvl9pPr marL="0" indent="0">
               <a:lnSpc>
@@ -2799,6 +2941,7 @@
                 <a:spcPts val="0"/>
               </a:spcAft>
               <a:buNone/>
+              <a:defRPr/>
             </a:lvl9pPr>
           </a:lstStyle>
           <a:p xmlns:a="http://schemas.openxmlformats.org/drawingml/2006/main"/>
@@ -2860,6 +3003,7 @@
                 <a:spcPts val="1200"/>
               </a:spcAft>
               <a:buChar char="•"/>
+              <a:defRPr/>
             </a:lvl1pPr>
             <a:lvl2pPr marL="533400" indent="-228600">
               <a:lnSpc>
@@ -2872,6 +3016,7 @@
                 <a:spcPts val="1200"/>
               </a:spcAft>
               <a:buChar char="•"/>
+              <a:defRPr/>
             </a:lvl2pPr>
             <a:lvl3pPr marL="838200" indent="-228600">
               <a:lnSpc>
@@ -2884,6 +3029,7 @@
                 <a:spcPts val="1200"/>
               </a:spcAft>
               <a:buChar char="•"/>
+              <a:defRPr/>
             </a:lvl3pPr>
             <a:lvl4pPr marL="1143000" indent="-228600">
               <a:lnSpc>
@@ -2896,6 +3042,7 @@
                 <a:spcPts val="1200"/>
               </a:spcAft>
               <a:buChar char="•"/>
+              <a:defRPr/>
             </a:lvl4pPr>
             <a:lvl5pPr marL="1447800" indent="-228600">
               <a:lnSpc>
@@ -2908,6 +3055,7 @@
                 <a:spcPts val="1200"/>
               </a:spcAft>
               <a:buChar char="•"/>
+              <a:defRPr/>
             </a:lvl5pPr>
             <a:lvl6pPr marL="1752600" indent="-228600">
               <a:lnSpc>
@@ -2920,6 +3068,7 @@
                 <a:spcPts val="1200"/>
               </a:spcAft>
               <a:buChar char="•"/>
+              <a:defRPr/>
             </a:lvl6pPr>
             <a:lvl7pPr marL="2057400" indent="-228600">
               <a:lnSpc>
@@ -2932,6 +3081,7 @@
                 <a:spcPts val="1200"/>
               </a:spcAft>
               <a:buChar char="•"/>
+              <a:defRPr/>
             </a:lvl7pPr>
             <a:lvl8pPr marL="2362200" indent="-228600">
               <a:lnSpc>
@@ -2944,6 +3094,7 @@
                 <a:spcPts val="1200"/>
               </a:spcAft>
               <a:buChar char="•"/>
+              <a:defRPr/>
             </a:lvl8pPr>
             <a:lvl9pPr marL="2667000" indent="-228600">
               <a:lnSpc>
@@ -2956,6 +3107,7 @@
                 <a:spcPts val="1200"/>
               </a:spcAft>
               <a:buChar char="•"/>
+              <a:defRPr/>
             </a:lvl9pPr>
           </a:lstStyle>
           <a:p xmlns:a="http://schemas.openxmlformats.org/drawingml/2006/main"/>
@@ -3004,12 +3156,12 @@
   </p:cSld>
   <p:clrMap bg1="lt1" tx1="dk1" bg2="lt2" tx2="dk2" accent1="accent1" accent2="accent2" accent3="accent3" accent4="accent4" accent5="accent5" accent6="accent6" hlink="hlink" folHlink="folHlink"/>
   <p:sldLayoutIdLst>
-    <p:sldLayoutId xmlns:r="http://schemas.openxmlformats.org/officeDocument/2006/relationships" id="2147483649" r:id="Rf5348b70221147f9"/>
-    <p:sldLayoutId xmlns:r="http://schemas.openxmlformats.org/officeDocument/2006/relationships" id="2147483650" r:id="R90a968326576417d"/>
-    <p:sldLayoutId xmlns:r="http://schemas.openxmlformats.org/officeDocument/2006/relationships" id="2147483651" r:id="Ref89c220f2a1424e"/>
-    <p:sldLayoutId xmlns:r="http://schemas.openxmlformats.org/officeDocument/2006/relationships" id="2147483652" r:id="R2cd199e441ec45f1"/>
-    <p:sldLayoutId xmlns:r="http://schemas.openxmlformats.org/officeDocument/2006/relationships" id="2147483653" r:id="Ra3166ce571ea4b37"/>
-    <p:sldLayoutId xmlns:r="http://schemas.openxmlformats.org/officeDocument/2006/relationships" id="2147483654" r:id="R580922184ef04013"/>
+    <p:sldLayoutId xmlns:r="http://schemas.openxmlformats.org/officeDocument/2006/relationships" id="2147483649" r:id="Rc85075be2c11472a"/>
+    <p:sldLayoutId xmlns:r="http://schemas.openxmlformats.org/officeDocument/2006/relationships" id="2147483650" r:id="R5587874fa2774627"/>
+    <p:sldLayoutId xmlns:r="http://schemas.openxmlformats.org/officeDocument/2006/relationships" id="2147483651" r:id="R09ca4ece41bd4c65"/>
+    <p:sldLayoutId xmlns:r="http://schemas.openxmlformats.org/officeDocument/2006/relationships" id="2147483652" r:id="R8575af8970684e9d"/>
+    <p:sldLayoutId xmlns:r="http://schemas.openxmlformats.org/officeDocument/2006/relationships" id="2147483653" r:id="Rbd6d5d0273f141ef"/>
+    <p:sldLayoutId xmlns:r="http://schemas.openxmlformats.org/officeDocument/2006/relationships" id="2147483654" r:id="R84beafb5e8774597"/>
   </p:sldLayoutIdLst>
   <p:txStyles>
     <p:titleStyle>
@@ -3600,6 +3752,7 @@
           </a:lstStyle>
           <a:p xmlns:a="http://schemas.openxmlformats.org/drawingml/2006/main">
             <a:pPr>
+              <a:buNone/>
               <a:defRPr sz="1275" b="0">
                 <a:solidFill>
                   <a:srgbClr val="617C77"/>
@@ -3628,7 +3781,7 @@
           <p:cNvPr id="2" name="">
             <a:extLst xmlns:a="http://schemas.openxmlformats.org/drawingml/2006/main">
               <a:ext uri="{FF2B5EF4-FFF2-40B4-BE49-F238E27FC236}">
-                <a16:creationId xmlns:a16="http://schemas.microsoft.com/office/drawing/2014/main" id="{B27319BE-A025-4560-BA67-3CF130D33444}"/>
+                <a16:creationId xmlns:a16="http://schemas.microsoft.com/office/drawing/2014/main" id="{1AB3641E-C9A6-406B-9F15-6250F535801F}"/>
               </a:ext>
             </a:extLst>
           </p:cNvPr>
@@ -3638,7 +3791,7 @@
           <p:nvPr/>
         </p:nvPicPr>
         <p:blipFill>
-          <a:blip xmlns:r="http://schemas.openxmlformats.org/officeDocument/2006/relationships" xmlns:a="http://schemas.openxmlformats.org/drawingml/2006/main" r:embed="Re642b384c0d24686"/>
+          <a:blip xmlns:r="http://schemas.openxmlformats.org/officeDocument/2006/relationships" xmlns:a="http://schemas.openxmlformats.org/drawingml/2006/main" r:embed="R7dce5e7ed50b4d6c"/>
           <a:stretch xmlns:a="http://schemas.openxmlformats.org/drawingml/2006/main"/>
         </p:blipFill>
         <p:spPr>
@@ -3696,6 +3849,7 @@
           </a:lstStyle>
           <a:p xmlns:a="http://schemas.openxmlformats.org/drawingml/2006/main">
             <a:pPr>
+              <a:buNone/>
               <a:defRPr sz="6300" b="1">
                 <a:solidFill>
                   <a:srgbClr val="087F77"/>
@@ -3764,6 +3918,7 @@
           </a:lstStyle>
           <a:p xmlns:a="http://schemas.openxmlformats.org/drawingml/2006/main">
             <a:pPr>
+              <a:buNone/>
               <a:defRPr sz="3300" b="1">
                 <a:solidFill>
                   <a:srgbClr val="193E3A"/>
@@ -3787,6 +3942,7 @@
           </a:p>
           <a:p xmlns:a="http://schemas.openxmlformats.org/drawingml/2006/main">
             <a:pPr>
+              <a:buNone/>
               <a:defRPr sz="3300" b="1">
                 <a:solidFill>
                   <a:srgbClr val="193E3A"/>
@@ -3810,6 +3966,7 @@
           </a:p>
           <a:p xmlns:a="http://schemas.openxmlformats.org/drawingml/2006/main">
             <a:pPr>
+              <a:buNone/>
               <a:defRPr sz="3300" b="1">
                 <a:solidFill>
                   <a:srgbClr val="193E3A"/>
@@ -3878,6 +4035,7 @@
           </a:lstStyle>
           <a:p xmlns:a="http://schemas.openxmlformats.org/drawingml/2006/main">
             <a:pPr>
+              <a:buNone/>
               <a:defRPr sz="1875" b="0">
                 <a:solidFill>
                   <a:srgbClr val="617C77"/>
@@ -3901,6 +4059,7 @@
           </a:p>
           <a:p xmlns:a="http://schemas.openxmlformats.org/drawingml/2006/main">
             <a:pPr>
+              <a:buNone/>
               <a:defRPr sz="1875" b="0">
                 <a:solidFill>
                   <a:srgbClr val="617C77"/>
@@ -3998,6 +4157,7 @@
           </a:lstStyle>
           <a:p xmlns:a="http://schemas.openxmlformats.org/drawingml/2006/main">
             <a:pPr>
+              <a:buNone/>
               <a:defRPr sz="3225" b="1">
                 <a:solidFill>
                   <a:srgbClr val="FFFFFF"/>
@@ -4016,7 +4176,7 @@
                 <a:ea typeface="Arial"/>
                 <a:cs typeface="Arial"/>
               </a:rPr>
-              <a:t>Жоба нәтижесі және келесі кезең</a:t>
+              <a:t>Жаңа функциялар және шектеулер</a:t>
             </a:r>
           </a:p>
         </p:txBody>
@@ -4066,6 +4226,7 @@
           </a:lstStyle>
           <a:p xmlns:a="http://schemas.openxmlformats.org/drawingml/2006/main">
             <a:pPr>
+              <a:buNone/>
               <a:defRPr sz="1275" b="0">
                 <a:solidFill>
                   <a:srgbClr val="B8E5D8"/>
@@ -4134,6 +4295,7 @@
           </a:lstStyle>
           <a:p xmlns:a="http://schemas.openxmlformats.org/drawingml/2006/main">
             <a:pPr>
+              <a:buNone/>
               <a:defRPr sz="2325" b="1">
                 <a:solidFill>
                   <a:srgbClr val="B8E5D8"/>
@@ -4202,6 +4364,7 @@
           </a:lstStyle>
           <a:p xmlns:a="http://schemas.openxmlformats.org/drawingml/2006/main">
             <a:pPr>
+              <a:buNone/>
               <a:defRPr sz="2250" b="0">
                 <a:solidFill>
                   <a:srgbClr val="FFFFFF"/>
@@ -4220,11 +4383,12 @@
                 <a:ea typeface="Arial"/>
                 <a:cs typeface="Arial"/>
               </a:rPr>
-              <a:t>Екі үйретілген модель</a:t>
+              <a:t>CR / DX DICOM қолдауы</a:t>
             </a:r>
           </a:p>
           <a:p xmlns:a="http://schemas.openxmlformats.org/drawingml/2006/main">
             <a:pPr>
+              <a:buNone/>
               <a:defRPr sz="2250" b="0">
                 <a:solidFill>
                   <a:srgbClr val="FFFFFF"/>
@@ -4243,11 +4407,12 @@
                 <a:ea typeface="Arial"/>
                 <a:cs typeface="Arial"/>
               </a:rPr>
-              <a:t>Қазақша жұмыс істейтін сайт</a:t>
+              <a:t>Калибрлеу және OOD</a:t>
             </a:r>
           </a:p>
           <a:p xmlns:a="http://schemas.openxmlformats.org/drawingml/2006/main">
             <a:pPr>
+              <a:buNone/>
               <a:defRPr sz="2250" b="0">
                 <a:solidFill>
                   <a:srgbClr val="FFFFFF"/>
@@ -4266,11 +4431,12 @@
                 <a:ea typeface="Arial"/>
                 <a:cs typeface="Arial"/>
               </a:rPr>
-              <a:t>Grad-CAM және есептер</a:t>
+              <a:t>40 тест және CI</a:t>
             </a:r>
           </a:p>
           <a:p xmlns:a="http://schemas.openxmlformats.org/drawingml/2006/main">
             <a:pPr>
+              <a:buNone/>
               <a:defRPr sz="2250" b="0">
                 <a:solidFill>
                   <a:srgbClr val="FFFFFF"/>
@@ -4289,7 +4455,7 @@
                 <a:ea typeface="Arial"/>
                 <a:cs typeface="Arial"/>
               </a:rPr>
-              <a:t>Талдау тарихы</a:t>
+              <a:t>Сыртқы бағалау</a:t>
             </a:r>
           </a:p>
         </p:txBody>
@@ -4339,6 +4505,7 @@
           </a:lstStyle>
           <a:p xmlns:a="http://schemas.openxmlformats.org/drawingml/2006/main">
             <a:pPr>
+              <a:buNone/>
               <a:defRPr sz="2325" b="1">
                 <a:solidFill>
                   <a:srgbClr val="B8E5D8"/>
@@ -4407,6 +4574,7 @@
           </a:lstStyle>
           <a:p xmlns:a="http://schemas.openxmlformats.org/drawingml/2006/main">
             <a:pPr>
+              <a:buNone/>
               <a:defRPr sz="2175" b="0">
                 <a:solidFill>
                   <a:srgbClr val="FFFFFF"/>
@@ -4425,11 +4593,12 @@
                 <a:ea typeface="Arial"/>
                 <a:cs typeface="Arial"/>
               </a:rPr>
-              <a:t>Сыртқы деректе тексеру</a:t>
+              <a:t>Ensemble дайындау</a:t>
             </a:r>
           </a:p>
           <a:p xmlns:a="http://schemas.openxmlformats.org/drawingml/2006/main">
             <a:pPr>
+              <a:buNone/>
               <a:defRPr sz="2175" b="0">
                 <a:solidFill>
                   <a:srgbClr val="FFFFFF"/>
@@ -4448,11 +4617,12 @@
                 <a:ea typeface="Arial"/>
                 <a:cs typeface="Arial"/>
               </a:rPr>
-              <a:t>Бірнеше ауруға кеңейту</a:t>
+              <a:t>Multi-label жеке тәжірибесі</a:t>
             </a:r>
           </a:p>
           <a:p xmlns:a="http://schemas.openxmlformats.org/drawingml/2006/main">
             <a:pPr>
+              <a:buNone/>
               <a:defRPr sz="2175" b="0">
                 <a:solidFill>
                   <a:srgbClr val="FFFFFF"/>
@@ -4471,11 +4641,12 @@
                 <a:ea typeface="Arial"/>
                 <a:cs typeface="Arial"/>
               </a:rPr>
-              <a:t>Multi-label classification</a:t>
+              <a:t>Клиникалық сыртқы тексеру</a:t>
             </a:r>
           </a:p>
           <a:p xmlns:a="http://schemas.openxmlformats.org/drawingml/2006/main">
             <a:pPr>
+              <a:buNone/>
               <a:defRPr sz="2175" b="0">
                 <a:solidFill>
                   <a:srgbClr val="FFFFFF"/>
@@ -4494,7 +4665,7 @@
                 <a:ea typeface="Arial"/>
                 <a:cs typeface="Arial"/>
               </a:rPr>
-              <a:t>Сайтты серверге орналастыру</a:t>
+              <a:t>Серверге орналастыру</a:t>
             </a:r>
           </a:p>
         </p:txBody>
@@ -4544,6 +4715,7 @@
           </a:lstStyle>
           <a:p xmlns:a="http://schemas.openxmlformats.org/drawingml/2006/main">
             <a:pPr>
+              <a:buNone/>
               <a:defRPr sz="2175" b="1">
                 <a:solidFill>
                   <a:srgbClr val="B8E5D8"/>
@@ -4612,6 +4784,7 @@
           </a:lstStyle>
           <a:p xmlns:a="http://schemas.openxmlformats.org/drawingml/2006/main">
             <a:pPr>
+              <a:buNone/>
               <a:defRPr sz="1650" b="0">
                 <a:solidFill>
                   <a:srgbClr val="FFFFFF"/>
@@ -4639,6 +4812,1916 @@
     <p:extLst>
       <p:ext uri="{BB962C8B-B14F-4D97-AF65-F5344CB8AC3E}">
         <p14:creationId xmlns:p14="http://schemas.microsoft.com/office/powerpoint/2010/main" val="1517619638"/>
+      </p:ext>
+    </p:extLst>
+  </p:cSld>
+</p:sld>
+</file>
+
+<file path=ppt/slides/slide11.xml><?xml version="1.0" encoding="utf-8"?>
+<p:sld xmlns:p="http://schemas.openxmlformats.org/presentationml/2006/main">
+  <p:cSld>
+    <p:bg>
+      <p:bgPr>
+        <a:solidFill xmlns:a="http://schemas.openxmlformats.org/drawingml/2006/main">
+          <a:srgbClr val="F6FAF8"/>
+        </a:solidFill>
+      </p:bgPr>
+    </p:bg>
+    <p:spTree>
+      <p:nvGrpSpPr>
+        <p:cNvPr id="1" name=""/>
+        <p:cNvGrpSpPr/>
+        <p:nvPr/>
+      </p:nvGrpSpPr>
+      <p:grpSpPr>
+        <a:xfrm xmlns:a="http://schemas.openxmlformats.org/drawingml/2006/main"/>
+      </p:grpSpPr>
+      <p:sp>
+        <p:nvSpPr>
+          <p:cNvPr id="7" name="">
+            <a:extLst xmlns:a="http://schemas.openxmlformats.org/drawingml/2006/main">
+              <a:ext uri="{FF2B5EF4-FFF2-40B4-BE49-F238E27FC236}">
+                <a16:creationId xmlns:a16="http://schemas.microsoft.com/office/drawing/2014/main" id="{2DA3A4C0-50AA-42F9-9BB3-2BE339538506}"/>
+              </a:ext>
+            </a:extLst>
+          </p:cNvPr>
+          <p:cNvSpPr>
+            <a:spLocks xmlns:a="http://schemas.openxmlformats.org/drawingml/2006/main" noGrp="1"/>
+          </p:cNvSpPr>
+          <p:nvPr/>
+        </p:nvSpPr>
+        <p:spPr>
+          <a:xfrm xmlns:a="http://schemas.openxmlformats.org/drawingml/2006/main">
+            <a:off x="609600" y="495300"/>
+            <a:ext cx="10972800" cy="1066800"/>
+          </a:xfrm>
+          <a:prstGeom xmlns:a="http://schemas.openxmlformats.org/drawingml/2006/main" prst="rect">
+            <a:avLst/>
+          </a:prstGeom>
+          <a:noFill xmlns:a="http://schemas.openxmlformats.org/drawingml/2006/main"/>
+          <a:ln xmlns:a="http://schemas.openxmlformats.org/drawingml/2006/main" w="0">
+            <a:noFill/>
+          </a:ln>
+        </p:spPr>
+        <p:txBody>
+          <a:bodyPr xmlns:a="http://schemas.openxmlformats.org/drawingml/2006/main" lIns="0" tIns="0" rIns="0" bIns="0" anchor="t">
+            <a:noAutofit/>
+          </a:bodyPr>
+          <a:lstStyle xmlns:a="http://schemas.openxmlformats.org/drawingml/2006/main">
+            <a:defPPr>
+              <a:defRPr sz="3225" b="1">
+                <a:solidFill>
+                  <a:srgbClr val="193E3A"/>
+                </a:solidFill>
+                <a:latin typeface="Arial"/>
+                <a:ea typeface="Arial"/>
+                <a:cs typeface="Arial"/>
+              </a:defRPr>
+            </a:defPPr>
+          </a:lstStyle>
+          <a:p xmlns:a="http://schemas.openxmlformats.org/drawingml/2006/main">
+            <a:pPr>
+              <a:buNone/>
+              <a:defRPr sz="3225" b="1">
+                <a:solidFill>
+                  <a:srgbClr val="193E3A"/>
+                </a:solidFill>
+                <a:latin typeface="Arial"/>
+                <a:ea typeface="Arial"/>
+                <a:cs typeface="Arial"/>
+              </a:defRPr>
+            </a:pPr>
+            <a:r>
+              <a:rPr sz="3225" b="1">
+                <a:solidFill>
+                  <a:srgbClr val="193E3A"/>
+                </a:solidFill>
+                <a:latin typeface="Arial"/>
+                <a:ea typeface="Arial"/>
+                <a:cs typeface="Arial"/>
+              </a:rPr>
+              <a:t>Сыртқы валидация: OpenI</a:t>
+            </a:r>
+          </a:p>
+        </p:txBody>
+      </p:sp>
+      <p:sp>
+        <p:nvSpPr>
+          <p:cNvPr id="2" name="">
+            <a:extLst xmlns:a="http://schemas.openxmlformats.org/drawingml/2006/main">
+              <a:ext uri="{FF2B5EF4-FFF2-40B4-BE49-F238E27FC236}">
+                <a16:creationId xmlns:a16="http://schemas.microsoft.com/office/drawing/2014/main" id="{B25AAFE9-A50D-4DAD-BD80-6609E16D158A}"/>
+              </a:ext>
+            </a:extLst>
+          </p:cNvPr>
+          <p:cNvSpPr>
+            <a:spLocks xmlns:a="http://schemas.openxmlformats.org/drawingml/2006/main" noGrp="1"/>
+          </p:cNvSpPr>
+          <p:nvPr/>
+        </p:nvSpPr>
+        <p:spPr>
+          <a:xfrm xmlns:a="http://schemas.openxmlformats.org/drawingml/2006/main">
+            <a:off x="11077575" y="6315075"/>
+            <a:ext cx="476250" cy="247650"/>
+          </a:xfrm>
+          <a:prstGeom xmlns:a="http://schemas.openxmlformats.org/drawingml/2006/main" prst="rect">
+            <a:avLst/>
+          </a:prstGeom>
+          <a:noFill xmlns:a="http://schemas.openxmlformats.org/drawingml/2006/main"/>
+          <a:ln xmlns:a="http://schemas.openxmlformats.org/drawingml/2006/main" w="0">
+            <a:noFill/>
+          </a:ln>
+        </p:spPr>
+        <p:txBody>
+          <a:bodyPr xmlns:a="http://schemas.openxmlformats.org/drawingml/2006/main" lIns="0" tIns="0" rIns="0" bIns="0" anchor="t">
+            <a:noAutofit/>
+          </a:bodyPr>
+          <a:lstStyle xmlns:a="http://schemas.openxmlformats.org/drawingml/2006/main">
+            <a:defPPr>
+              <a:defRPr sz="1275" b="0">
+                <a:solidFill>
+                  <a:srgbClr val="617C77"/>
+                </a:solidFill>
+                <a:latin typeface="Arial"/>
+                <a:ea typeface="Arial"/>
+                <a:cs typeface="Arial"/>
+              </a:defRPr>
+            </a:defPPr>
+          </a:lstStyle>
+          <a:p xmlns:a="http://schemas.openxmlformats.org/drawingml/2006/main">
+            <a:pPr>
+              <a:buNone/>
+              <a:defRPr sz="1275" b="0">
+                <a:solidFill>
+                  <a:srgbClr val="617C77"/>
+                </a:solidFill>
+                <a:latin typeface="Arial"/>
+                <a:ea typeface="Arial"/>
+                <a:cs typeface="Arial"/>
+              </a:defRPr>
+            </a:pPr>
+            <a:r>
+              <a:rPr sz="1275" b="0">
+                <a:solidFill>
+                  <a:srgbClr val="617C77"/>
+                </a:solidFill>
+                <a:latin typeface="Arial"/>
+                <a:ea typeface="Arial"/>
+                <a:cs typeface="Arial"/>
+              </a:rPr>
+              <a:t>11</a:t>
+            </a:r>
+          </a:p>
+        </p:txBody>
+      </p:sp>
+      <p:graphicFrame>
+        <p:nvGraphicFramePr>
+          <p:cNvPr id="3" name="">
+            <a:extLst xmlns:a="http://schemas.openxmlformats.org/drawingml/2006/main">
+              <a:ext uri="{FF2B5EF4-FFF2-40B4-BE49-F238E27FC236}">
+                <a16:creationId xmlns:a16="http://schemas.microsoft.com/office/drawing/2014/main" id="{BD0058B4-7E87-4BBD-9361-061C11EEF629}"/>
+              </a:ext>
+            </a:extLst>
+          </p:cNvPr>
+          <p:cNvGraphicFramePr/>
+          <p:nvPr/>
+        </p:nvGraphicFramePr>
+        <p:xfrm>
+          <a:off xmlns:a="http://schemas.openxmlformats.org/drawingml/2006/main" x="609600" y="1714500"/>
+          <a:ext xmlns:a="http://schemas.openxmlformats.org/drawingml/2006/main" cx="10972800" cy="3622675"/>
+        </p:xfrm>
+        <a:graphic xmlns:a="http://schemas.openxmlformats.org/drawingml/2006/main">
+          <a:graphicData uri="http://schemas.openxmlformats.org/drawingml/2006/table">
+            <a:tbl>
+              <a:tblPr/>
+              <a:tblGrid>
+                <a:gridCol w="4305300"/>
+                <a:gridCol w="3333750"/>
+                <a:gridCol w="3333750"/>
+              </a:tblGrid>
+              <a:tr h="443593">
+                <a:tc>
+                  <a:txBody>
+                    <a:bodyPr/>
+                    <a:lstStyle/>
+                    <a:p>
+                      <a:r>
+                        <a:rPr sz="1725" b="1">
+                          <a:solidFill>
+                            <a:srgbClr val="FFFFFF"/>
+                          </a:solidFill>
+                          <a:latin typeface="Arial"/>
+                          <a:ea typeface="Arial"/>
+                          <a:cs typeface="Arial"/>
+                        </a:rPr>
+                        <a:t>Көрсеткіш</a:t>
+                      </a:r>
+                    </a:p>
+                  </a:txBody>
+                  <a:tcPr marL="91440" marR="91440" marT="45720" marB="45720">
+                    <a:lnL w="9525">
+                      <a:solidFill>
+                        <a:srgbClr val="CBDDD6"/>
+                      </a:solidFill>
+                      <a:prstDash val="solid"/>
+                    </a:lnL>
+                    <a:lnR w="9525">
+                      <a:solidFill>
+                        <a:srgbClr val="CBDDD6"/>
+                      </a:solidFill>
+                      <a:prstDash val="solid"/>
+                    </a:lnR>
+                    <a:lnT w="9525">
+                      <a:solidFill>
+                        <a:srgbClr val="CBDDD6"/>
+                      </a:solidFill>
+                      <a:prstDash val="solid"/>
+                    </a:lnT>
+                    <a:lnB w="9525">
+                      <a:solidFill>
+                        <a:srgbClr val="CBDDD6"/>
+                      </a:solidFill>
+                      <a:prstDash val="solid"/>
+                    </a:lnB>
+                    <a:solidFill>
+                      <a:srgbClr val="193E3A"/>
+                    </a:solidFill>
+                  </a:tcPr>
+                </a:tc>
+                <a:tc>
+                  <a:txBody>
+                    <a:bodyPr/>
+                    <a:lstStyle/>
+                    <a:p>
+                      <a:r>
+                        <a:rPr sz="1725" b="1">
+                          <a:solidFill>
+                            <a:srgbClr val="FFFFFF"/>
+                          </a:solidFill>
+                          <a:latin typeface="Arial"/>
+                          <a:ea typeface="Arial"/>
+                          <a:cs typeface="Arial"/>
+                        </a:rPr>
+                        <a:t>Ішкі test, 618</a:t>
+                      </a:r>
+                    </a:p>
+                  </a:txBody>
+                  <a:tcPr marL="91440" marR="91440" marT="45720" marB="45720">
+                    <a:lnR w="9525">
+                      <a:solidFill>
+                        <a:srgbClr val="CBDDD6"/>
+                      </a:solidFill>
+                      <a:prstDash val="solid"/>
+                    </a:lnR>
+                    <a:lnT w="9525">
+                      <a:solidFill>
+                        <a:srgbClr val="CBDDD6"/>
+                      </a:solidFill>
+                      <a:prstDash val="solid"/>
+                    </a:lnT>
+                    <a:lnB w="9525">
+                      <a:solidFill>
+                        <a:srgbClr val="CBDDD6"/>
+                      </a:solidFill>
+                      <a:prstDash val="solid"/>
+                    </a:lnB>
+                    <a:solidFill>
+                      <a:srgbClr val="193E3A"/>
+                    </a:solidFill>
+                  </a:tcPr>
+                </a:tc>
+                <a:tc>
+                  <a:txBody>
+                    <a:bodyPr/>
+                    <a:lstStyle/>
+                    <a:p>
+                      <a:r>
+                        <a:rPr sz="1725" b="1">
+                          <a:solidFill>
+                            <a:srgbClr val="FFFFFF"/>
+                          </a:solidFill>
+                          <a:latin typeface="Arial"/>
+                          <a:ea typeface="Arial"/>
+                          <a:cs typeface="Arial"/>
+                        </a:rPr>
+                        <a:t>OpenI, 200</a:t>
+                      </a:r>
+                    </a:p>
+                  </a:txBody>
+                  <a:tcPr marL="91440" marR="91440" marT="45720" marB="45720">
+                    <a:lnR w="9525">
+                      <a:solidFill>
+                        <a:srgbClr val="CBDDD6"/>
+                      </a:solidFill>
+                      <a:prstDash val="solid"/>
+                    </a:lnR>
+                    <a:lnT w="9525">
+                      <a:solidFill>
+                        <a:srgbClr val="CBDDD6"/>
+                      </a:solidFill>
+                      <a:prstDash val="solid"/>
+                    </a:lnT>
+                    <a:lnB w="9525">
+                      <a:solidFill>
+                        <a:srgbClr val="CBDDD6"/>
+                      </a:solidFill>
+                      <a:prstDash val="solid"/>
+                    </a:lnB>
+                    <a:solidFill>
+                      <a:srgbClr val="193E3A"/>
+                    </a:solidFill>
+                  </a:tcPr>
+                </a:tc>
+              </a:tr>
+              <a:tr h="443593">
+                <a:tc>
+                  <a:txBody>
+                    <a:bodyPr/>
+                    <a:lstStyle/>
+                    <a:p>
+                      <a:r>
+                        <a:rPr sz="1725" b="0">
+                          <a:solidFill>
+                            <a:srgbClr val="193E3A"/>
+                          </a:solidFill>
+                          <a:latin typeface="Arial"/>
+                          <a:ea typeface="Arial"/>
+                          <a:cs typeface="Arial"/>
+                        </a:rPr>
+                        <a:t>Accuracy</a:t>
+                      </a:r>
+                    </a:p>
+                  </a:txBody>
+                  <a:tcPr marL="91440" marR="91440" marT="45720" marB="45720">
+                    <a:lnL w="9525">
+                      <a:solidFill>
+                        <a:srgbClr val="CBDDD6"/>
+                      </a:solidFill>
+                      <a:prstDash val="solid"/>
+                    </a:lnL>
+                    <a:lnR w="9525">
+                      <a:solidFill>
+                        <a:srgbClr val="CBDDD6"/>
+                      </a:solidFill>
+                      <a:prstDash val="solid"/>
+                    </a:lnR>
+                    <a:lnB w="9525">
+                      <a:solidFill>
+                        <a:srgbClr val="CBDDD6"/>
+                      </a:solidFill>
+                      <a:prstDash val="solid"/>
+                    </a:lnB>
+                    <a:solidFill>
+                      <a:srgbClr val="FFFFFF"/>
+                    </a:solidFill>
+                  </a:tcPr>
+                </a:tc>
+                <a:tc>
+                  <a:txBody>
+                    <a:bodyPr/>
+                    <a:lstStyle/>
+                    <a:p>
+                      <a:r>
+                        <a:rPr sz="1725" b="0">
+                          <a:solidFill>
+                            <a:srgbClr val="193E3A"/>
+                          </a:solidFill>
+                          <a:latin typeface="Arial"/>
+                          <a:ea typeface="Arial"/>
+                          <a:cs typeface="Arial"/>
+                        </a:rPr>
+                        <a:t>89,16%</a:t>
+                      </a:r>
+                    </a:p>
+                  </a:txBody>
+                  <a:tcPr marL="91440" marR="91440" marT="45720" marB="45720">
+                    <a:lnR w="9525">
+                      <a:solidFill>
+                        <a:srgbClr val="CBDDD6"/>
+                      </a:solidFill>
+                      <a:prstDash val="solid"/>
+                    </a:lnR>
+                    <a:lnB w="9525">
+                      <a:solidFill>
+                        <a:srgbClr val="CBDDD6"/>
+                      </a:solidFill>
+                      <a:prstDash val="solid"/>
+                    </a:lnB>
+                    <a:solidFill>
+                      <a:srgbClr val="FFFFFF"/>
+                    </a:solidFill>
+                  </a:tcPr>
+                </a:tc>
+                <a:tc>
+                  <a:txBody>
+                    <a:bodyPr/>
+                    <a:lstStyle/>
+                    <a:p>
+                      <a:r>
+                        <a:rPr sz="1725" b="0">
+                          <a:solidFill>
+                            <a:srgbClr val="193E3A"/>
+                          </a:solidFill>
+                          <a:latin typeface="Arial"/>
+                          <a:ea typeface="Arial"/>
+                          <a:cs typeface="Arial"/>
+                        </a:rPr>
+                        <a:t>55,00%</a:t>
+                      </a:r>
+                    </a:p>
+                  </a:txBody>
+                  <a:tcPr marL="91440" marR="91440" marT="45720" marB="45720">
+                    <a:lnR w="9525">
+                      <a:solidFill>
+                        <a:srgbClr val="CBDDD6"/>
+                      </a:solidFill>
+                      <a:prstDash val="solid"/>
+                    </a:lnR>
+                    <a:lnB w="9525">
+                      <a:solidFill>
+                        <a:srgbClr val="CBDDD6"/>
+                      </a:solidFill>
+                      <a:prstDash val="solid"/>
+                    </a:lnB>
+                    <a:solidFill>
+                      <a:srgbClr val="FFFFFF"/>
+                    </a:solidFill>
+                  </a:tcPr>
+                </a:tc>
+              </a:tr>
+              <a:tr h="443593">
+                <a:tc>
+                  <a:txBody>
+                    <a:bodyPr/>
+                    <a:lstStyle/>
+                    <a:p>
+                      <a:r>
+                        <a:rPr sz="1725" b="0">
+                          <a:solidFill>
+                            <a:srgbClr val="193E3A"/>
+                          </a:solidFill>
+                          <a:latin typeface="Arial"/>
+                          <a:ea typeface="Arial"/>
+                          <a:cs typeface="Arial"/>
+                        </a:rPr>
+                        <a:t>Precision</a:t>
+                      </a:r>
+                    </a:p>
+                  </a:txBody>
+                  <a:tcPr marL="91440" marR="91440" marT="45720" marB="45720">
+                    <a:lnL w="9525">
+                      <a:solidFill>
+                        <a:srgbClr val="CBDDD6"/>
+                      </a:solidFill>
+                      <a:prstDash val="solid"/>
+                    </a:lnL>
+                    <a:lnR w="9525">
+                      <a:solidFill>
+                        <a:srgbClr val="CBDDD6"/>
+                      </a:solidFill>
+                      <a:prstDash val="solid"/>
+                    </a:lnR>
+                    <a:lnB w="9525">
+                      <a:solidFill>
+                        <a:srgbClr val="CBDDD6"/>
+                      </a:solidFill>
+                      <a:prstDash val="solid"/>
+                    </a:lnB>
+                    <a:solidFill>
+                      <a:srgbClr val="E9F3EE"/>
+                    </a:solidFill>
+                  </a:tcPr>
+                </a:tc>
+                <a:tc>
+                  <a:txBody>
+                    <a:bodyPr/>
+                    <a:lstStyle/>
+                    <a:p>
+                      <a:r>
+                        <a:rPr sz="1725" b="0">
+                          <a:solidFill>
+                            <a:srgbClr val="193E3A"/>
+                          </a:solidFill>
+                          <a:latin typeface="Arial"/>
+                          <a:ea typeface="Arial"/>
+                          <a:cs typeface="Arial"/>
+                        </a:rPr>
+                        <a:t>87,74%</a:t>
+                      </a:r>
+                    </a:p>
+                  </a:txBody>
+                  <a:tcPr marL="91440" marR="91440" marT="45720" marB="45720">
+                    <a:lnR w="9525">
+                      <a:solidFill>
+                        <a:srgbClr val="CBDDD6"/>
+                      </a:solidFill>
+                      <a:prstDash val="solid"/>
+                    </a:lnR>
+                    <a:lnB w="9525">
+                      <a:solidFill>
+                        <a:srgbClr val="CBDDD6"/>
+                      </a:solidFill>
+                      <a:prstDash val="solid"/>
+                    </a:lnB>
+                    <a:solidFill>
+                      <a:srgbClr val="E9F3EE"/>
+                    </a:solidFill>
+                  </a:tcPr>
+                </a:tc>
+                <a:tc>
+                  <a:txBody>
+                    <a:bodyPr/>
+                    <a:lstStyle/>
+                    <a:p>
+                      <a:r>
+                        <a:rPr sz="1725" b="0">
+                          <a:solidFill>
+                            <a:srgbClr val="193E3A"/>
+                          </a:solidFill>
+                          <a:latin typeface="Arial"/>
+                          <a:ea typeface="Arial"/>
+                          <a:cs typeface="Arial"/>
+                        </a:rPr>
+                        <a:t>23,96%</a:t>
+                      </a:r>
+                    </a:p>
+                  </a:txBody>
+                  <a:tcPr marL="91440" marR="91440" marT="45720" marB="45720">
+                    <a:lnR w="9525">
+                      <a:solidFill>
+                        <a:srgbClr val="CBDDD6"/>
+                      </a:solidFill>
+                      <a:prstDash val="solid"/>
+                    </a:lnR>
+                    <a:lnB w="9525">
+                      <a:solidFill>
+                        <a:srgbClr val="CBDDD6"/>
+                      </a:solidFill>
+                      <a:prstDash val="solid"/>
+                    </a:lnB>
+                    <a:solidFill>
+                      <a:srgbClr val="E9F3EE"/>
+                    </a:solidFill>
+                  </a:tcPr>
+                </a:tc>
+              </a:tr>
+              <a:tr h="443593">
+                <a:tc>
+                  <a:txBody>
+                    <a:bodyPr/>
+                    <a:lstStyle/>
+                    <a:p>
+                      <a:r>
+                        <a:rPr sz="1725" b="0">
+                          <a:solidFill>
+                            <a:srgbClr val="193E3A"/>
+                          </a:solidFill>
+                          <a:latin typeface="Arial"/>
+                          <a:ea typeface="Arial"/>
+                          <a:cs typeface="Arial"/>
+                        </a:rPr>
+                        <a:t>Recall / sensitivity</a:t>
+                      </a:r>
+                    </a:p>
+                  </a:txBody>
+                  <a:tcPr marL="91440" marR="91440" marT="45720" marB="45720">
+                    <a:lnL w="9525">
+                      <a:solidFill>
+                        <a:srgbClr val="CBDDD6"/>
+                      </a:solidFill>
+                      <a:prstDash val="solid"/>
+                    </a:lnL>
+                    <a:lnR w="9525">
+                      <a:solidFill>
+                        <a:srgbClr val="CBDDD6"/>
+                      </a:solidFill>
+                      <a:prstDash val="solid"/>
+                    </a:lnR>
+                    <a:lnB w="9525">
+                      <a:solidFill>
+                        <a:srgbClr val="CBDDD6"/>
+                      </a:solidFill>
+                      <a:prstDash val="solid"/>
+                    </a:lnB>
+                    <a:solidFill>
+                      <a:srgbClr val="FFFFFF"/>
+                    </a:solidFill>
+                  </a:tcPr>
+                </a:tc>
+                <a:tc>
+                  <a:txBody>
+                    <a:bodyPr/>
+                    <a:lstStyle/>
+                    <a:p>
+                      <a:r>
+                        <a:rPr sz="1725" b="0">
+                          <a:solidFill>
+                            <a:srgbClr val="193E3A"/>
+                          </a:solidFill>
+                          <a:latin typeface="Arial"/>
+                          <a:ea typeface="Arial"/>
+                          <a:cs typeface="Arial"/>
+                        </a:rPr>
+                        <a:t>96,12%</a:t>
+                      </a:r>
+                    </a:p>
+                  </a:txBody>
+                  <a:tcPr marL="91440" marR="91440" marT="45720" marB="45720">
+                    <a:lnR w="9525">
+                      <a:solidFill>
+                        <a:srgbClr val="CBDDD6"/>
+                      </a:solidFill>
+                      <a:prstDash val="solid"/>
+                    </a:lnR>
+                    <a:lnB w="9525">
+                      <a:solidFill>
+                        <a:srgbClr val="CBDDD6"/>
+                      </a:solidFill>
+                      <a:prstDash val="solid"/>
+                    </a:lnB>
+                    <a:solidFill>
+                      <a:srgbClr val="FFFFFF"/>
+                    </a:solidFill>
+                  </a:tcPr>
+                </a:tc>
+                <a:tc>
+                  <a:txBody>
+                    <a:bodyPr/>
+                    <a:lstStyle/>
+                    <a:p>
+                      <a:r>
+                        <a:rPr sz="1725" b="0">
+                          <a:solidFill>
+                            <a:srgbClr val="193E3A"/>
+                          </a:solidFill>
+                          <a:latin typeface="Arial"/>
+                          <a:ea typeface="Arial"/>
+                          <a:cs typeface="Arial"/>
+                        </a:rPr>
+                        <a:t>57,50%</a:t>
+                      </a:r>
+                    </a:p>
+                  </a:txBody>
+                  <a:tcPr marL="91440" marR="91440" marT="45720" marB="45720">
+                    <a:lnR w="9525">
+                      <a:solidFill>
+                        <a:srgbClr val="CBDDD6"/>
+                      </a:solidFill>
+                      <a:prstDash val="solid"/>
+                    </a:lnR>
+                    <a:lnB w="9525">
+                      <a:solidFill>
+                        <a:srgbClr val="CBDDD6"/>
+                      </a:solidFill>
+                      <a:prstDash val="solid"/>
+                    </a:lnB>
+                    <a:solidFill>
+                      <a:srgbClr val="FFFFFF"/>
+                    </a:solidFill>
+                  </a:tcPr>
+                </a:tc>
+              </a:tr>
+              <a:tr h="443593">
+                <a:tc>
+                  <a:txBody>
+                    <a:bodyPr/>
+                    <a:lstStyle/>
+                    <a:p>
+                      <a:r>
+                        <a:rPr sz="1725" b="0">
+                          <a:solidFill>
+                            <a:srgbClr val="193E3A"/>
+                          </a:solidFill>
+                          <a:latin typeface="Arial"/>
+                          <a:ea typeface="Arial"/>
+                          <a:cs typeface="Arial"/>
+                        </a:rPr>
+                        <a:t>Specificity</a:t>
+                      </a:r>
+                    </a:p>
+                  </a:txBody>
+                  <a:tcPr marL="91440" marR="91440" marT="45720" marB="45720">
+                    <a:lnL w="9525">
+                      <a:solidFill>
+                        <a:srgbClr val="CBDDD6"/>
+                      </a:solidFill>
+                      <a:prstDash val="solid"/>
+                    </a:lnL>
+                    <a:lnR w="9525">
+                      <a:solidFill>
+                        <a:srgbClr val="CBDDD6"/>
+                      </a:solidFill>
+                      <a:prstDash val="solid"/>
+                    </a:lnR>
+                    <a:lnB w="9525">
+                      <a:solidFill>
+                        <a:srgbClr val="CBDDD6"/>
+                      </a:solidFill>
+                      <a:prstDash val="solid"/>
+                    </a:lnB>
+                    <a:solidFill>
+                      <a:srgbClr val="E9F3EE"/>
+                    </a:solidFill>
+                  </a:tcPr>
+                </a:tc>
+                <a:tc>
+                  <a:txBody>
+                    <a:bodyPr/>
+                    <a:lstStyle/>
+                    <a:p>
+                      <a:r>
+                        <a:rPr sz="1725" b="0">
+                          <a:solidFill>
+                            <a:srgbClr val="193E3A"/>
+                          </a:solidFill>
+                          <a:latin typeface="Arial"/>
+                          <a:ea typeface="Arial"/>
+                          <a:cs typeface="Arial"/>
+                        </a:rPr>
+                        <a:t>77,49%</a:t>
+                      </a:r>
+                    </a:p>
+                  </a:txBody>
+                  <a:tcPr marL="91440" marR="91440" marT="45720" marB="45720">
+                    <a:lnR w="9525">
+                      <a:solidFill>
+                        <a:srgbClr val="CBDDD6"/>
+                      </a:solidFill>
+                      <a:prstDash val="solid"/>
+                    </a:lnR>
+                    <a:lnB w="9525">
+                      <a:solidFill>
+                        <a:srgbClr val="CBDDD6"/>
+                      </a:solidFill>
+                      <a:prstDash val="solid"/>
+                    </a:lnB>
+                    <a:solidFill>
+                      <a:srgbClr val="E9F3EE"/>
+                    </a:solidFill>
+                  </a:tcPr>
+                </a:tc>
+                <a:tc>
+                  <a:txBody>
+                    <a:bodyPr/>
+                    <a:lstStyle/>
+                    <a:p>
+                      <a:r>
+                        <a:rPr sz="1725" b="0">
+                          <a:solidFill>
+                            <a:srgbClr val="193E3A"/>
+                          </a:solidFill>
+                          <a:latin typeface="Arial"/>
+                          <a:ea typeface="Arial"/>
+                          <a:cs typeface="Arial"/>
+                        </a:rPr>
+                        <a:t>54,37%</a:t>
+                      </a:r>
+                    </a:p>
+                  </a:txBody>
+                  <a:tcPr marL="91440" marR="91440" marT="45720" marB="45720">
+                    <a:lnR w="9525">
+                      <a:solidFill>
+                        <a:srgbClr val="CBDDD6"/>
+                      </a:solidFill>
+                      <a:prstDash val="solid"/>
+                    </a:lnR>
+                    <a:lnB w="9525">
+                      <a:solidFill>
+                        <a:srgbClr val="CBDDD6"/>
+                      </a:solidFill>
+                      <a:prstDash val="solid"/>
+                    </a:lnB>
+                    <a:solidFill>
+                      <a:srgbClr val="E9F3EE"/>
+                    </a:solidFill>
+                  </a:tcPr>
+                </a:tc>
+              </a:tr>
+              <a:tr h="443593">
+                <a:tc>
+                  <a:txBody>
+                    <a:bodyPr/>
+                    <a:lstStyle/>
+                    <a:p>
+                      <a:r>
+                        <a:rPr sz="1725" b="0">
+                          <a:solidFill>
+                            <a:srgbClr val="193E3A"/>
+                          </a:solidFill>
+                          <a:latin typeface="Arial"/>
+                          <a:ea typeface="Arial"/>
+                          <a:cs typeface="Arial"/>
+                        </a:rPr>
+                        <a:t>F1</a:t>
+                      </a:r>
+                    </a:p>
+                  </a:txBody>
+                  <a:tcPr marL="91440" marR="91440" marT="45720" marB="45720">
+                    <a:lnL w="9525">
+                      <a:solidFill>
+                        <a:srgbClr val="CBDDD6"/>
+                      </a:solidFill>
+                      <a:prstDash val="solid"/>
+                    </a:lnL>
+                    <a:lnR w="9525">
+                      <a:solidFill>
+                        <a:srgbClr val="CBDDD6"/>
+                      </a:solidFill>
+                      <a:prstDash val="solid"/>
+                    </a:lnR>
+                    <a:lnB w="9525">
+                      <a:solidFill>
+                        <a:srgbClr val="CBDDD6"/>
+                      </a:solidFill>
+                      <a:prstDash val="solid"/>
+                    </a:lnB>
+                    <a:solidFill>
+                      <a:srgbClr val="FFFFFF"/>
+                    </a:solidFill>
+                  </a:tcPr>
+                </a:tc>
+                <a:tc>
+                  <a:txBody>
+                    <a:bodyPr/>
+                    <a:lstStyle/>
+                    <a:p>
+                      <a:r>
+                        <a:rPr sz="1725" b="0">
+                          <a:solidFill>
+                            <a:srgbClr val="193E3A"/>
+                          </a:solidFill>
+                          <a:latin typeface="Arial"/>
+                          <a:ea typeface="Arial"/>
+                          <a:cs typeface="Arial"/>
+                        </a:rPr>
+                        <a:t>0,9174</a:t>
+                      </a:r>
+                    </a:p>
+                  </a:txBody>
+                  <a:tcPr marL="91440" marR="91440" marT="45720" marB="45720">
+                    <a:lnR w="9525">
+                      <a:solidFill>
+                        <a:srgbClr val="CBDDD6"/>
+                      </a:solidFill>
+                      <a:prstDash val="solid"/>
+                    </a:lnR>
+                    <a:lnB w="9525">
+                      <a:solidFill>
+                        <a:srgbClr val="CBDDD6"/>
+                      </a:solidFill>
+                      <a:prstDash val="solid"/>
+                    </a:lnB>
+                    <a:solidFill>
+                      <a:srgbClr val="FFFFFF"/>
+                    </a:solidFill>
+                  </a:tcPr>
+                </a:tc>
+                <a:tc>
+                  <a:txBody>
+                    <a:bodyPr/>
+                    <a:lstStyle/>
+                    <a:p>
+                      <a:r>
+                        <a:rPr sz="1725" b="0">
+                          <a:solidFill>
+                            <a:srgbClr val="193E3A"/>
+                          </a:solidFill>
+                          <a:latin typeface="Arial"/>
+                          <a:ea typeface="Arial"/>
+                          <a:cs typeface="Arial"/>
+                        </a:rPr>
+                        <a:t>0,3382</a:t>
+                      </a:r>
+                    </a:p>
+                  </a:txBody>
+                  <a:tcPr marL="91440" marR="91440" marT="45720" marB="45720">
+                    <a:lnR w="9525">
+                      <a:solidFill>
+                        <a:srgbClr val="CBDDD6"/>
+                      </a:solidFill>
+                      <a:prstDash val="solid"/>
+                    </a:lnR>
+                    <a:lnB w="9525">
+                      <a:solidFill>
+                        <a:srgbClr val="CBDDD6"/>
+                      </a:solidFill>
+                      <a:prstDash val="solid"/>
+                    </a:lnB>
+                    <a:solidFill>
+                      <a:srgbClr val="FFFFFF"/>
+                    </a:solidFill>
+                  </a:tcPr>
+                </a:tc>
+              </a:tr>
+              <a:tr h="443593">
+                <a:tc>
+                  <a:txBody>
+                    <a:bodyPr/>
+                    <a:lstStyle/>
+                    <a:p>
+                      <a:r>
+                        <a:rPr sz="1725" b="0">
+                          <a:solidFill>
+                            <a:srgbClr val="193E3A"/>
+                          </a:solidFill>
+                          <a:latin typeface="Arial"/>
+                          <a:ea typeface="Arial"/>
+                          <a:cs typeface="Arial"/>
+                        </a:rPr>
+                        <a:t>ROC-AUC</a:t>
+                      </a:r>
+                    </a:p>
+                  </a:txBody>
+                  <a:tcPr marL="91440" marR="91440" marT="45720" marB="45720">
+                    <a:lnL w="9525">
+                      <a:solidFill>
+                        <a:srgbClr val="CBDDD6"/>
+                      </a:solidFill>
+                      <a:prstDash val="solid"/>
+                    </a:lnL>
+                    <a:lnR w="9525">
+                      <a:solidFill>
+                        <a:srgbClr val="CBDDD6"/>
+                      </a:solidFill>
+                      <a:prstDash val="solid"/>
+                    </a:lnR>
+                    <a:lnB w="9525">
+                      <a:solidFill>
+                        <a:srgbClr val="CBDDD6"/>
+                      </a:solidFill>
+                      <a:prstDash val="solid"/>
+                    </a:lnB>
+                    <a:solidFill>
+                      <a:srgbClr val="E9F3EE"/>
+                    </a:solidFill>
+                  </a:tcPr>
+                </a:tc>
+                <a:tc>
+                  <a:txBody>
+                    <a:bodyPr/>
+                    <a:lstStyle/>
+                    <a:p>
+                      <a:r>
+                        <a:rPr sz="1725" b="0">
+                          <a:solidFill>
+                            <a:srgbClr val="193E3A"/>
+                          </a:solidFill>
+                          <a:latin typeface="Arial"/>
+                          <a:ea typeface="Arial"/>
+                          <a:cs typeface="Arial"/>
+                        </a:rPr>
+                        <a:t>0,9581</a:t>
+                      </a:r>
+                    </a:p>
+                  </a:txBody>
+                  <a:tcPr marL="91440" marR="91440" marT="45720" marB="45720">
+                    <a:lnR w="9525">
+                      <a:solidFill>
+                        <a:srgbClr val="CBDDD6"/>
+                      </a:solidFill>
+                      <a:prstDash val="solid"/>
+                    </a:lnR>
+                    <a:lnB w="9525">
+                      <a:solidFill>
+                        <a:srgbClr val="CBDDD6"/>
+                      </a:solidFill>
+                      <a:prstDash val="solid"/>
+                    </a:lnB>
+                    <a:solidFill>
+                      <a:srgbClr val="E9F3EE"/>
+                    </a:solidFill>
+                  </a:tcPr>
+                </a:tc>
+                <a:tc>
+                  <a:txBody>
+                    <a:bodyPr/>
+                    <a:lstStyle/>
+                    <a:p>
+                      <a:r>
+                        <a:rPr sz="1725" b="0">
+                          <a:solidFill>
+                            <a:srgbClr val="193E3A"/>
+                          </a:solidFill>
+                          <a:latin typeface="Arial"/>
+                          <a:ea typeface="Arial"/>
+                          <a:cs typeface="Arial"/>
+                        </a:rPr>
+                        <a:t>0,5442</a:t>
+                      </a:r>
+                    </a:p>
+                  </a:txBody>
+                  <a:tcPr marL="91440" marR="91440" marT="45720" marB="45720">
+                    <a:lnR w="9525">
+                      <a:solidFill>
+                        <a:srgbClr val="CBDDD6"/>
+                      </a:solidFill>
+                      <a:prstDash val="solid"/>
+                    </a:lnR>
+                    <a:lnB w="9525">
+                      <a:solidFill>
+                        <a:srgbClr val="CBDDD6"/>
+                      </a:solidFill>
+                      <a:prstDash val="solid"/>
+                    </a:lnB>
+                    <a:solidFill>
+                      <a:srgbClr val="E9F3EE"/>
+                    </a:solidFill>
+                  </a:tcPr>
+                </a:tc>
+              </a:tr>
+            </a:tbl>
+          </a:graphicData>
+        </a:graphic>
+      </p:graphicFrame>
+      <p:sp>
+        <p:nvSpPr>
+          <p:cNvPr id="4" name="">
+            <a:extLst xmlns:a="http://schemas.openxmlformats.org/drawingml/2006/main">
+              <a:ext uri="{FF2B5EF4-FFF2-40B4-BE49-F238E27FC236}">
+                <a16:creationId xmlns:a16="http://schemas.microsoft.com/office/drawing/2014/main" id="{0F99C5F4-4F11-4C75-BB83-E31ED3E826CF}"/>
+              </a:ext>
+            </a:extLst>
+          </p:cNvPr>
+          <p:cNvSpPr>
+            <a:spLocks xmlns:a="http://schemas.openxmlformats.org/drawingml/2006/main" noGrp="1"/>
+          </p:cNvSpPr>
+          <p:nvPr/>
+        </p:nvSpPr>
+        <p:spPr>
+          <a:xfrm xmlns:a="http://schemas.openxmlformats.org/drawingml/2006/main">
+            <a:off x="609600" y="5181600"/>
+            <a:ext cx="10858500" cy="476250"/>
+          </a:xfrm>
+          <a:prstGeom xmlns:a="http://schemas.openxmlformats.org/drawingml/2006/main" prst="rect">
+            <a:avLst/>
+          </a:prstGeom>
+          <a:noFill xmlns:a="http://schemas.openxmlformats.org/drawingml/2006/main"/>
+          <a:ln xmlns:a="http://schemas.openxmlformats.org/drawingml/2006/main" w="0">
+            <a:noFill/>
+          </a:ln>
+        </p:spPr>
+        <p:txBody>
+          <a:bodyPr xmlns:a="http://schemas.openxmlformats.org/drawingml/2006/main" lIns="0" tIns="0" rIns="0" bIns="0" anchor="t">
+            <a:noAutofit/>
+          </a:bodyPr>
+          <a:lstStyle xmlns:a="http://schemas.openxmlformats.org/drawingml/2006/main">
+            <a:defPPr>
+              <a:defRPr sz="2325" b="1">
+                <a:solidFill>
+                  <a:srgbClr val="087F77"/>
+                </a:solidFill>
+                <a:latin typeface="Arial"/>
+                <a:ea typeface="Arial"/>
+                <a:cs typeface="Arial"/>
+              </a:defRPr>
+            </a:defPPr>
+          </a:lstStyle>
+          <a:p xmlns:a="http://schemas.openxmlformats.org/drawingml/2006/main">
+            <a:pPr>
+              <a:buNone/>
+              <a:defRPr sz="2325" b="1">
+                <a:solidFill>
+                  <a:srgbClr val="087F77"/>
+                </a:solidFill>
+                <a:latin typeface="Arial"/>
+                <a:ea typeface="Arial"/>
+                <a:cs typeface="Arial"/>
+              </a:defRPr>
+            </a:pPr>
+            <a:r>
+              <a:rPr sz="2325" b="1">
+                <a:solidFill>
+                  <a:srgbClr val="087F77"/>
+                </a:solidFill>
+                <a:latin typeface="Arial"/>
+                <a:ea typeface="Arial"/>
+                <a:cs typeface="Arial"/>
+              </a:rPr>
+              <a:t>160 NORMAL / 40 PNEUMONIA</a:t>
+            </a:r>
+          </a:p>
+        </p:txBody>
+      </p:sp>
+      <p:sp>
+        <p:nvSpPr>
+          <p:cNvPr id="5" name="">
+            <a:extLst xmlns:a="http://schemas.openxmlformats.org/drawingml/2006/main">
+              <a:ext uri="{FF2B5EF4-FFF2-40B4-BE49-F238E27FC236}">
+                <a16:creationId xmlns:a16="http://schemas.microsoft.com/office/drawing/2014/main" id="{C87A1316-651F-4EE5-BB8E-44EC26898D93}"/>
+              </a:ext>
+            </a:extLst>
+          </p:cNvPr>
+          <p:cNvSpPr>
+            <a:spLocks xmlns:a="http://schemas.openxmlformats.org/drawingml/2006/main" noGrp="1"/>
+          </p:cNvSpPr>
+          <p:nvPr/>
+        </p:nvSpPr>
+        <p:spPr>
+          <a:xfrm xmlns:a="http://schemas.openxmlformats.org/drawingml/2006/main">
+            <a:off x="628650" y="5772150"/>
+            <a:ext cx="10668000" cy="400050"/>
+          </a:xfrm>
+          <a:prstGeom xmlns:a="http://schemas.openxmlformats.org/drawingml/2006/main" prst="rect">
+            <a:avLst/>
+          </a:prstGeom>
+          <a:noFill xmlns:a="http://schemas.openxmlformats.org/drawingml/2006/main"/>
+          <a:ln xmlns:a="http://schemas.openxmlformats.org/drawingml/2006/main" w="0">
+            <a:noFill/>
+          </a:ln>
+        </p:spPr>
+        <p:txBody>
+          <a:bodyPr xmlns:a="http://schemas.openxmlformats.org/drawingml/2006/main" lIns="0" tIns="0" rIns="0" bIns="0" anchor="t">
+            <a:noAutofit/>
+          </a:bodyPr>
+          <a:lstStyle xmlns:a="http://schemas.openxmlformats.org/drawingml/2006/main">
+            <a:defPPr>
+              <a:defRPr sz="1875" b="0">
+                <a:solidFill>
+                  <a:srgbClr val="617C77"/>
+                </a:solidFill>
+                <a:latin typeface="Arial"/>
+                <a:ea typeface="Arial"/>
+                <a:cs typeface="Arial"/>
+              </a:defRPr>
+            </a:defPPr>
+          </a:lstStyle>
+          <a:p xmlns:a="http://schemas.openxmlformats.org/drawingml/2006/main">
+            <a:pPr>
+              <a:buNone/>
+              <a:defRPr sz="1875" b="0">
+                <a:solidFill>
+                  <a:srgbClr val="617C77"/>
+                </a:solidFill>
+                <a:latin typeface="Arial"/>
+                <a:ea typeface="Arial"/>
+                <a:cs typeface="Arial"/>
+              </a:defRPr>
+            </a:pPr>
+            <a:r>
+              <a:rPr sz="1875" b="0">
+                <a:solidFill>
+                  <a:srgbClr val="617C77"/>
+                </a:solidFill>
+                <a:latin typeface="Arial"/>
+                <a:ea typeface="Arial"/>
+                <a:cs typeface="Arial"/>
+              </a:rPr>
+              <a:t>SHA-256 қиылысы: 0. Бір есептен бір сурет.</a:t>
+            </a:r>
+          </a:p>
+        </p:txBody>
+      </p:sp>
+      <p:sp>
+        <p:nvSpPr>
+          <p:cNvPr id="6" name="">
+            <a:extLst xmlns:a="http://schemas.openxmlformats.org/drawingml/2006/main">
+              <a:ext uri="{FF2B5EF4-FFF2-40B4-BE49-F238E27FC236}">
+                <a16:creationId xmlns:a16="http://schemas.microsoft.com/office/drawing/2014/main" id="{9B44F38A-8DE0-435D-9F58-B3AD68E1FE94}"/>
+              </a:ext>
+            </a:extLst>
+          </p:cNvPr>
+          <p:cNvSpPr>
+            <a:spLocks xmlns:a="http://schemas.openxmlformats.org/drawingml/2006/main" noGrp="1"/>
+          </p:cNvSpPr>
+          <p:nvPr/>
+        </p:nvSpPr>
+        <p:spPr>
+          <a:xfrm xmlns:a="http://schemas.openxmlformats.org/drawingml/2006/main">
+            <a:off x="628650" y="6200775"/>
+            <a:ext cx="10287000" cy="333375"/>
+          </a:xfrm>
+          <a:prstGeom xmlns:a="http://schemas.openxmlformats.org/drawingml/2006/main" prst="rect">
+            <a:avLst/>
+          </a:prstGeom>
+          <a:noFill xmlns:a="http://schemas.openxmlformats.org/drawingml/2006/main"/>
+          <a:ln xmlns:a="http://schemas.openxmlformats.org/drawingml/2006/main" w="0">
+            <a:noFill/>
+          </a:ln>
+        </p:spPr>
+        <p:txBody>
+          <a:bodyPr xmlns:a="http://schemas.openxmlformats.org/drawingml/2006/main" lIns="0" tIns="0" rIns="0" bIns="0" anchor="t">
+            <a:noAutofit/>
+          </a:bodyPr>
+          <a:lstStyle xmlns:a="http://schemas.openxmlformats.org/drawingml/2006/main">
+            <a:defPPr>
+              <a:defRPr sz="1575" b="0">
+                <a:solidFill>
+                  <a:srgbClr val="617C77"/>
+                </a:solidFill>
+                <a:latin typeface="Arial"/>
+                <a:ea typeface="Arial"/>
+                <a:cs typeface="Arial"/>
+              </a:defRPr>
+            </a:defPPr>
+          </a:lstStyle>
+          <a:p xmlns:a="http://schemas.openxmlformats.org/drawingml/2006/main">
+            <a:pPr>
+              <a:buNone/>
+              <a:defRPr sz="1575" b="0">
+                <a:solidFill>
+                  <a:srgbClr val="617C77"/>
+                </a:solidFill>
+                <a:latin typeface="Arial"/>
+                <a:ea typeface="Arial"/>
+                <a:cs typeface="Arial"/>
+              </a:defRPr>
+            </a:pPr>
+            <a:r>
+              <a:rPr sz="1575" b="0">
+                <a:solidFill>
+                  <a:srgbClr val="617C77"/>
+                </a:solidFill>
+                <a:latin typeface="Arial"/>
+                <a:ea typeface="Arial"/>
+                <a:cs typeface="Arial"/>
+              </a:rPr>
+              <a:t>Топтау есеп ID-іне сүйенеді. Пациент ID толық расталмаған.</a:t>
+            </a:r>
+          </a:p>
+        </p:txBody>
+      </p:sp>
+    </p:spTree>
+    <p:extLst>
+      <p:ext uri="{BB962C8B-B14F-4D97-AF65-F5344CB8AC3E}">
+        <p14:creationId xmlns:p14="http://schemas.microsoft.com/office/powerpoint/2010/main" val="228856872"/>
+      </p:ext>
+    </p:extLst>
+  </p:cSld>
+</p:sld>
+</file>
+
+<file path=ppt/slides/slide12.xml><?xml version="1.0" encoding="utf-8"?>
+<p:sld xmlns:p="http://schemas.openxmlformats.org/presentationml/2006/main">
+  <p:cSld>
+    <p:bg>
+      <p:bgPr>
+        <a:solidFill xmlns:a="http://schemas.openxmlformats.org/drawingml/2006/main">
+          <a:srgbClr val="193E3A"/>
+        </a:solidFill>
+      </p:bgPr>
+    </p:bg>
+    <p:spTree>
+      <p:nvGrpSpPr>
+        <p:cNvPr id="1" name=""/>
+        <p:cNvGrpSpPr/>
+        <p:nvPr/>
+      </p:nvGrpSpPr>
+      <p:grpSpPr>
+        <a:xfrm xmlns:a="http://schemas.openxmlformats.org/drawingml/2006/main"/>
+      </p:grpSpPr>
+      <p:sp>
+        <p:nvSpPr>
+          <p:cNvPr id="9" name="">
+            <a:extLst xmlns:a="http://schemas.openxmlformats.org/drawingml/2006/main">
+              <a:ext uri="{FF2B5EF4-FFF2-40B4-BE49-F238E27FC236}">
+                <a16:creationId xmlns:a16="http://schemas.microsoft.com/office/drawing/2014/main" id="{BB350165-DA83-472D-8898-368F046A6E55}"/>
+              </a:ext>
+            </a:extLst>
+          </p:cNvPr>
+          <p:cNvSpPr>
+            <a:spLocks xmlns:a="http://schemas.openxmlformats.org/drawingml/2006/main" noGrp="1"/>
+          </p:cNvSpPr>
+          <p:nvPr/>
+        </p:nvSpPr>
+        <p:spPr>
+          <a:xfrm xmlns:a="http://schemas.openxmlformats.org/drawingml/2006/main">
+            <a:off x="609600" y="495300"/>
+            <a:ext cx="10972800" cy="1066800"/>
+          </a:xfrm>
+          <a:prstGeom xmlns:a="http://schemas.openxmlformats.org/drawingml/2006/main" prst="rect">
+            <a:avLst/>
+          </a:prstGeom>
+          <a:noFill xmlns:a="http://schemas.openxmlformats.org/drawingml/2006/main"/>
+          <a:ln xmlns:a="http://schemas.openxmlformats.org/drawingml/2006/main" w="0">
+            <a:noFill/>
+          </a:ln>
+        </p:spPr>
+        <p:txBody>
+          <a:bodyPr xmlns:a="http://schemas.openxmlformats.org/drawingml/2006/main" lIns="0" tIns="0" rIns="0" bIns="0" anchor="t">
+            <a:noAutofit/>
+          </a:bodyPr>
+          <a:lstStyle xmlns:a="http://schemas.openxmlformats.org/drawingml/2006/main">
+            <a:defPPr>
+              <a:defRPr sz="3225" b="1">
+                <a:solidFill>
+                  <a:srgbClr val="FFFFFF"/>
+                </a:solidFill>
+                <a:latin typeface="Arial"/>
+                <a:ea typeface="Arial"/>
+                <a:cs typeface="Arial"/>
+              </a:defRPr>
+            </a:defPPr>
+          </a:lstStyle>
+          <a:p xmlns:a="http://schemas.openxmlformats.org/drawingml/2006/main">
+            <a:pPr>
+              <a:buNone/>
+              <a:defRPr sz="3225" b="1">
+                <a:solidFill>
+                  <a:srgbClr val="FFFFFF"/>
+                </a:solidFill>
+                <a:latin typeface="Arial"/>
+                <a:ea typeface="Arial"/>
+                <a:cs typeface="Arial"/>
+              </a:defRPr>
+            </a:pPr>
+            <a:r>
+              <a:rPr sz="3225" b="1">
+                <a:solidFill>
+                  <a:srgbClr val="FFFFFF"/>
+                </a:solidFill>
+                <a:latin typeface="Arial"/>
+                <a:ea typeface="Arial"/>
+                <a:cs typeface="Arial"/>
+              </a:rPr>
+              <a:t>Калибрлеу және OOD іске қосылды</a:t>
+            </a:r>
+          </a:p>
+        </p:txBody>
+      </p:sp>
+      <p:sp>
+        <p:nvSpPr>
+          <p:cNvPr id="2" name="">
+            <a:extLst xmlns:a="http://schemas.openxmlformats.org/drawingml/2006/main">
+              <a:ext uri="{FF2B5EF4-FFF2-40B4-BE49-F238E27FC236}">
+                <a16:creationId xmlns:a16="http://schemas.microsoft.com/office/drawing/2014/main" id="{6A2443B1-4DF8-4984-84B3-70E00F7421F5}"/>
+              </a:ext>
+            </a:extLst>
+          </p:cNvPr>
+          <p:cNvSpPr>
+            <a:spLocks xmlns:a="http://schemas.openxmlformats.org/drawingml/2006/main" noGrp="1"/>
+          </p:cNvSpPr>
+          <p:nvPr/>
+        </p:nvSpPr>
+        <p:spPr>
+          <a:xfrm xmlns:a="http://schemas.openxmlformats.org/drawingml/2006/main">
+            <a:off x="11077575" y="6315075"/>
+            <a:ext cx="476250" cy="247650"/>
+          </a:xfrm>
+          <a:prstGeom xmlns:a="http://schemas.openxmlformats.org/drawingml/2006/main" prst="rect">
+            <a:avLst/>
+          </a:prstGeom>
+          <a:noFill xmlns:a="http://schemas.openxmlformats.org/drawingml/2006/main"/>
+          <a:ln xmlns:a="http://schemas.openxmlformats.org/drawingml/2006/main" w="0">
+            <a:noFill/>
+          </a:ln>
+        </p:spPr>
+        <p:txBody>
+          <a:bodyPr xmlns:a="http://schemas.openxmlformats.org/drawingml/2006/main" lIns="0" tIns="0" rIns="0" bIns="0" anchor="t">
+            <a:noAutofit/>
+          </a:bodyPr>
+          <a:lstStyle xmlns:a="http://schemas.openxmlformats.org/drawingml/2006/main">
+            <a:defPPr>
+              <a:defRPr sz="1275" b="0">
+                <a:solidFill>
+                  <a:srgbClr val="B8E5D8"/>
+                </a:solidFill>
+                <a:latin typeface="Arial"/>
+                <a:ea typeface="Arial"/>
+                <a:cs typeface="Arial"/>
+              </a:defRPr>
+            </a:defPPr>
+          </a:lstStyle>
+          <a:p xmlns:a="http://schemas.openxmlformats.org/drawingml/2006/main">
+            <a:pPr>
+              <a:buNone/>
+              <a:defRPr sz="1275" b="0">
+                <a:solidFill>
+                  <a:srgbClr val="B8E5D8"/>
+                </a:solidFill>
+                <a:latin typeface="Arial"/>
+                <a:ea typeface="Arial"/>
+                <a:cs typeface="Arial"/>
+              </a:defRPr>
+            </a:pPr>
+            <a:r>
+              <a:rPr sz="1275" b="0">
+                <a:solidFill>
+                  <a:srgbClr val="B8E5D8"/>
+                </a:solidFill>
+                <a:latin typeface="Arial"/>
+                <a:ea typeface="Arial"/>
+                <a:cs typeface="Arial"/>
+              </a:rPr>
+              <a:t>12</a:t>
+            </a:r>
+          </a:p>
+        </p:txBody>
+      </p:sp>
+      <p:sp>
+        <p:nvSpPr>
+          <p:cNvPr id="3" name="">
+            <a:extLst xmlns:a="http://schemas.openxmlformats.org/drawingml/2006/main">
+              <a:ext uri="{FF2B5EF4-FFF2-40B4-BE49-F238E27FC236}">
+                <a16:creationId xmlns:a16="http://schemas.microsoft.com/office/drawing/2014/main" id="{918F6ED3-E708-47C7-90EC-4CFD25AF31A0}"/>
+              </a:ext>
+            </a:extLst>
+          </p:cNvPr>
+          <p:cNvSpPr>
+            <a:spLocks xmlns:a="http://schemas.openxmlformats.org/drawingml/2006/main" noGrp="1"/>
+          </p:cNvSpPr>
+          <p:nvPr/>
+        </p:nvSpPr>
+        <p:spPr>
+          <a:xfrm xmlns:a="http://schemas.openxmlformats.org/drawingml/2006/main">
+            <a:off x="609600" y="1762125"/>
+            <a:ext cx="10858500" cy="619125"/>
+          </a:xfrm>
+          <a:prstGeom xmlns:a="http://schemas.openxmlformats.org/drawingml/2006/main" prst="rect">
+            <a:avLst/>
+          </a:prstGeom>
+          <a:noFill xmlns:a="http://schemas.openxmlformats.org/drawingml/2006/main"/>
+          <a:ln xmlns:a="http://schemas.openxmlformats.org/drawingml/2006/main" w="0">
+            <a:noFill/>
+          </a:ln>
+        </p:spPr>
+        <p:txBody>
+          <a:bodyPr xmlns:a="http://schemas.openxmlformats.org/drawingml/2006/main" lIns="0" tIns="0" rIns="0" bIns="0" anchor="t">
+            <a:noAutofit/>
+          </a:bodyPr>
+          <a:lstStyle xmlns:a="http://schemas.openxmlformats.org/drawingml/2006/main">
+            <a:defPPr>
+              <a:defRPr sz="3000" b="1">
+                <a:solidFill>
+                  <a:srgbClr val="B8E5D8"/>
+                </a:solidFill>
+                <a:latin typeface="Arial"/>
+                <a:ea typeface="Arial"/>
+                <a:cs typeface="Arial"/>
+              </a:defRPr>
+            </a:defPPr>
+          </a:lstStyle>
+          <a:p xmlns:a="http://schemas.openxmlformats.org/drawingml/2006/main">
+            <a:pPr>
+              <a:buNone/>
+              <a:defRPr sz="3000" b="1">
+                <a:solidFill>
+                  <a:srgbClr val="B8E5D8"/>
+                </a:solidFill>
+                <a:latin typeface="Arial"/>
+                <a:ea typeface="Arial"/>
+                <a:cs typeface="Arial"/>
+              </a:defRPr>
+            </a:pPr>
+            <a:r>
+              <a:rPr sz="3000" b="1">
+                <a:solidFill>
+                  <a:srgbClr val="B8E5D8"/>
+                </a:solidFill>
+                <a:latin typeface="Arial"/>
+                <a:ea typeface="Arial"/>
+                <a:cs typeface="Arial"/>
+              </a:rPr>
+              <a:t>p_cal = sigmoid(logit(p) / T)</a:t>
+            </a:r>
+          </a:p>
+        </p:txBody>
+      </p:sp>
+      <p:sp>
+        <p:nvSpPr>
+          <p:cNvPr id="4" name="">
+            <a:extLst xmlns:a="http://schemas.openxmlformats.org/drawingml/2006/main">
+              <a:ext uri="{FF2B5EF4-FFF2-40B4-BE49-F238E27FC236}">
+                <a16:creationId xmlns:a16="http://schemas.microsoft.com/office/drawing/2014/main" id="{D95BEDF0-6623-491D-B109-9829CD322D1D}"/>
+              </a:ext>
+            </a:extLst>
+          </p:cNvPr>
+          <p:cNvSpPr>
+            <a:spLocks xmlns:a="http://schemas.openxmlformats.org/drawingml/2006/main" noGrp="1"/>
+          </p:cNvSpPr>
+          <p:nvPr/>
+        </p:nvSpPr>
+        <p:spPr>
+          <a:xfrm xmlns:a="http://schemas.openxmlformats.org/drawingml/2006/main">
+            <a:off x="609600" y="2828925"/>
+            <a:ext cx="5143500" cy="457200"/>
+          </a:xfrm>
+          <a:prstGeom xmlns:a="http://schemas.openxmlformats.org/drawingml/2006/main" prst="rect">
+            <a:avLst/>
+          </a:prstGeom>
+          <a:noFill xmlns:a="http://schemas.openxmlformats.org/drawingml/2006/main"/>
+          <a:ln xmlns:a="http://schemas.openxmlformats.org/drawingml/2006/main" w="0">
+            <a:noFill/>
+          </a:ln>
+        </p:spPr>
+        <p:txBody>
+          <a:bodyPr xmlns:a="http://schemas.openxmlformats.org/drawingml/2006/main" lIns="0" tIns="0" rIns="0" bIns="0" anchor="t">
+            <a:noAutofit/>
+          </a:bodyPr>
+          <a:lstStyle xmlns:a="http://schemas.openxmlformats.org/drawingml/2006/main">
+            <a:defPPr>
+              <a:defRPr sz="2325" b="1">
+                <a:solidFill>
+                  <a:srgbClr val="B8E5D8"/>
+                </a:solidFill>
+                <a:latin typeface="Arial"/>
+                <a:ea typeface="Arial"/>
+                <a:cs typeface="Arial"/>
+              </a:defRPr>
+            </a:defPPr>
+          </a:lstStyle>
+          <a:p xmlns:a="http://schemas.openxmlformats.org/drawingml/2006/main">
+            <a:pPr>
+              <a:buNone/>
+              <a:defRPr sz="2325" b="1">
+                <a:solidFill>
+                  <a:srgbClr val="B8E5D8"/>
+                </a:solidFill>
+                <a:latin typeface="Arial"/>
+                <a:ea typeface="Arial"/>
+                <a:cs typeface="Arial"/>
+              </a:defRPr>
+            </a:pPr>
+            <a:r>
+              <a:rPr sz="2325" b="1">
+                <a:solidFill>
+                  <a:srgbClr val="B8E5D8"/>
+                </a:solidFill>
+                <a:latin typeface="Arial"/>
+                <a:ea typeface="Arial"/>
+                <a:cs typeface="Arial"/>
+              </a:rPr>
+              <a:t>Қосылған код</a:t>
+            </a:r>
+          </a:p>
+        </p:txBody>
+      </p:sp>
+      <p:sp>
+        <p:nvSpPr>
+          <p:cNvPr id="5" name="">
+            <a:extLst xmlns:a="http://schemas.openxmlformats.org/drawingml/2006/main">
+              <a:ext uri="{FF2B5EF4-FFF2-40B4-BE49-F238E27FC236}">
+                <a16:creationId xmlns:a16="http://schemas.microsoft.com/office/drawing/2014/main" id="{4C7A1F8B-435A-4E16-898B-7118127FE5BE}"/>
+              </a:ext>
+            </a:extLst>
+          </p:cNvPr>
+          <p:cNvSpPr>
+            <a:spLocks xmlns:a="http://schemas.openxmlformats.org/drawingml/2006/main" noGrp="1"/>
+          </p:cNvSpPr>
+          <p:nvPr/>
+        </p:nvSpPr>
+        <p:spPr>
+          <a:xfrm xmlns:a="http://schemas.openxmlformats.org/drawingml/2006/main">
+            <a:off x="619125" y="3581400"/>
+            <a:ext cx="5381625" cy="1571625"/>
+          </a:xfrm>
+          <a:prstGeom xmlns:a="http://schemas.openxmlformats.org/drawingml/2006/main" prst="rect">
+            <a:avLst/>
+          </a:prstGeom>
+          <a:noFill xmlns:a="http://schemas.openxmlformats.org/drawingml/2006/main"/>
+          <a:ln xmlns:a="http://schemas.openxmlformats.org/drawingml/2006/main" w="0">
+            <a:noFill/>
+          </a:ln>
+        </p:spPr>
+        <p:txBody>
+          <a:bodyPr xmlns:a="http://schemas.openxmlformats.org/drawingml/2006/main" lIns="0" tIns="0" rIns="0" bIns="0" anchor="t">
+            <a:noAutofit/>
+          </a:bodyPr>
+          <a:lstStyle xmlns:a="http://schemas.openxmlformats.org/drawingml/2006/main">
+            <a:defPPr>
+              <a:defRPr sz="2100" b="0">
+                <a:solidFill>
+                  <a:srgbClr val="FFFFFF"/>
+                </a:solidFill>
+                <a:latin typeface="Arial"/>
+                <a:ea typeface="Arial"/>
+                <a:cs typeface="Arial"/>
+              </a:defRPr>
+            </a:defPPr>
+          </a:lstStyle>
+          <a:p xmlns:a="http://schemas.openxmlformats.org/drawingml/2006/main">
+            <a:pPr>
+              <a:buNone/>
+              <a:defRPr sz="2100" b="0">
+                <a:solidFill>
+                  <a:srgbClr val="FFFFFF"/>
+                </a:solidFill>
+                <a:latin typeface="Arial"/>
+                <a:ea typeface="Arial"/>
+                <a:cs typeface="Arial"/>
+              </a:defRPr>
+            </a:pPr>
+            <a:r>
+              <a:rPr sz="2100" b="0">
+                <a:solidFill>
+                  <a:srgbClr val="FFFFFF"/>
+                </a:solidFill>
+                <a:latin typeface="Arial"/>
+                <a:ea typeface="Arial"/>
+                <a:cs typeface="Arial"/>
+              </a:rPr>
+              <a:t>T: 0,2–5,0, validation NLL</a:t>
+            </a:r>
+          </a:p>
+          <a:p xmlns:a="http://schemas.openxmlformats.org/drawingml/2006/main">
+            <a:pPr>
+              <a:buNone/>
+              <a:defRPr sz="2100" b="0">
+                <a:solidFill>
+                  <a:srgbClr val="FFFFFF"/>
+                </a:solidFill>
+                <a:latin typeface="Arial"/>
+                <a:ea typeface="Arial"/>
+                <a:cs typeface="Arial"/>
+              </a:defRPr>
+            </a:pPr>
+            <a:r>
+              <a:rPr sz="2100" b="0">
+                <a:solidFill>
+                  <a:srgbClr val="FFFFFF"/>
+                </a:solidFill>
+                <a:latin typeface="Arial"/>
+                <a:ea typeface="Arial"/>
+                <a:cs typeface="Arial"/>
+              </a:rPr>
+              <a:t>Жаңа шек тек validation-да</a:t>
+            </a:r>
+          </a:p>
+          <a:p xmlns:a="http://schemas.openxmlformats.org/drawingml/2006/main">
+            <a:pPr>
+              <a:buNone/>
+              <a:defRPr sz="2100" b="0">
+                <a:solidFill>
+                  <a:srgbClr val="FFFFFF"/>
+                </a:solidFill>
+                <a:latin typeface="Arial"/>
+                <a:ea typeface="Arial"/>
+                <a:cs typeface="Arial"/>
+              </a:defRPr>
+            </a:pPr>
+            <a:r>
+              <a:rPr sz="2100" b="0">
+                <a:solidFill>
+                  <a:srgbClr val="FFFFFF"/>
+                </a:solidFill>
+                <a:latin typeface="Arial"/>
+                <a:ea typeface="Arial"/>
+                <a:cs typeface="Arial"/>
+              </a:rPr>
+              <a:t>Grad-CAM raw баллын тексереді</a:t>
+            </a:r>
+          </a:p>
+        </p:txBody>
+      </p:sp>
+      <p:sp>
+        <p:nvSpPr>
+          <p:cNvPr id="6" name="">
+            <a:extLst xmlns:a="http://schemas.openxmlformats.org/drawingml/2006/main">
+              <a:ext uri="{FF2B5EF4-FFF2-40B4-BE49-F238E27FC236}">
+                <a16:creationId xmlns:a16="http://schemas.microsoft.com/office/drawing/2014/main" id="{FA8F63BF-6D96-4BAF-B7D1-920DDD87CB74}"/>
+              </a:ext>
+            </a:extLst>
+          </p:cNvPr>
+          <p:cNvSpPr>
+            <a:spLocks xmlns:a="http://schemas.openxmlformats.org/drawingml/2006/main" noGrp="1"/>
+          </p:cNvSpPr>
+          <p:nvPr/>
+        </p:nvSpPr>
+        <p:spPr>
+          <a:xfrm xmlns:a="http://schemas.openxmlformats.org/drawingml/2006/main">
+            <a:off x="6753225" y="2828925"/>
+            <a:ext cx="4810125" cy="457200"/>
+          </a:xfrm>
+          <a:prstGeom xmlns:a="http://schemas.openxmlformats.org/drawingml/2006/main" prst="rect">
+            <a:avLst/>
+          </a:prstGeom>
+          <a:noFill xmlns:a="http://schemas.openxmlformats.org/drawingml/2006/main"/>
+          <a:ln xmlns:a="http://schemas.openxmlformats.org/drawingml/2006/main" w="0">
+            <a:noFill/>
+          </a:ln>
+        </p:spPr>
+        <p:txBody>
+          <a:bodyPr xmlns:a="http://schemas.openxmlformats.org/drawingml/2006/main" lIns="0" tIns="0" rIns="0" bIns="0" anchor="t">
+            <a:noAutofit/>
+          </a:bodyPr>
+          <a:lstStyle xmlns:a="http://schemas.openxmlformats.org/drawingml/2006/main">
+            <a:defPPr>
+              <a:defRPr sz="2325" b="1">
+                <a:solidFill>
+                  <a:srgbClr val="B8E5D8"/>
+                </a:solidFill>
+                <a:latin typeface="Arial"/>
+                <a:ea typeface="Arial"/>
+                <a:cs typeface="Arial"/>
+              </a:defRPr>
+            </a:defPPr>
+          </a:lstStyle>
+          <a:p xmlns:a="http://schemas.openxmlformats.org/drawingml/2006/main">
+            <a:pPr>
+              <a:buNone/>
+              <a:defRPr sz="2325" b="1">
+                <a:solidFill>
+                  <a:srgbClr val="B8E5D8"/>
+                </a:solidFill>
+                <a:latin typeface="Arial"/>
+                <a:ea typeface="Arial"/>
+                <a:cs typeface="Arial"/>
+              </a:defRPr>
+            </a:pPr>
+            <a:r>
+              <a:rPr sz="2325" b="1">
+                <a:solidFill>
+                  <a:srgbClr val="B8E5D8"/>
+                </a:solidFill>
+                <a:latin typeface="Arial"/>
+                <a:ea typeface="Arial"/>
+                <a:cs typeface="Arial"/>
+              </a:rPr>
+              <a:t>Қазіргі күйі</a:t>
+            </a:r>
+          </a:p>
+        </p:txBody>
+      </p:sp>
+      <p:sp>
+        <p:nvSpPr>
+          <p:cNvPr id="7" name="">
+            <a:extLst xmlns:a="http://schemas.openxmlformats.org/drawingml/2006/main">
+              <a:ext uri="{FF2B5EF4-FFF2-40B4-BE49-F238E27FC236}">
+                <a16:creationId xmlns:a16="http://schemas.microsoft.com/office/drawing/2014/main" id="{50DF91B3-2F41-464E-9973-85F9512AAF92}"/>
+              </a:ext>
+            </a:extLst>
+          </p:cNvPr>
+          <p:cNvSpPr>
+            <a:spLocks xmlns:a="http://schemas.openxmlformats.org/drawingml/2006/main" noGrp="1"/>
+          </p:cNvSpPr>
+          <p:nvPr/>
+        </p:nvSpPr>
+        <p:spPr>
+          <a:xfrm xmlns:a="http://schemas.openxmlformats.org/drawingml/2006/main">
+            <a:off x="6762750" y="3581400"/>
+            <a:ext cx="4810125" cy="1571625"/>
+          </a:xfrm>
+          <a:prstGeom xmlns:a="http://schemas.openxmlformats.org/drawingml/2006/main" prst="rect">
+            <a:avLst/>
+          </a:prstGeom>
+          <a:noFill xmlns:a="http://schemas.openxmlformats.org/drawingml/2006/main"/>
+          <a:ln xmlns:a="http://schemas.openxmlformats.org/drawingml/2006/main" w="0">
+            <a:noFill/>
+          </a:ln>
+        </p:spPr>
+        <p:txBody>
+          <a:bodyPr xmlns:a="http://schemas.openxmlformats.org/drawingml/2006/main" lIns="0" tIns="0" rIns="0" bIns="0" anchor="t">
+            <a:noAutofit/>
+          </a:bodyPr>
+          <a:lstStyle xmlns:a="http://schemas.openxmlformats.org/drawingml/2006/main">
+            <a:defPPr>
+              <a:defRPr sz="2025" b="0">
+                <a:solidFill>
+                  <a:srgbClr val="FFFFFF"/>
+                </a:solidFill>
+                <a:latin typeface="Arial"/>
+                <a:ea typeface="Arial"/>
+                <a:cs typeface="Arial"/>
+              </a:defRPr>
+            </a:defPPr>
+          </a:lstStyle>
+          <a:p xmlns:a="http://schemas.openxmlformats.org/drawingml/2006/main">
+            <a:pPr>
+              <a:buNone/>
+              <a:defRPr sz="2025" b="0">
+                <a:solidFill>
+                  <a:srgbClr val="FFFFFF"/>
+                </a:solidFill>
+                <a:latin typeface="Arial"/>
+                <a:ea typeface="Arial"/>
+                <a:cs typeface="Arial"/>
+              </a:defRPr>
+            </a:pPr>
+            <a:r>
+              <a:rPr sz="2025" b="0">
+                <a:solidFill>
+                  <a:srgbClr val="FFFFFF"/>
+                </a:solidFill>
+                <a:latin typeface="Arial"/>
+                <a:ea typeface="Arial"/>
+                <a:cs typeface="Arial"/>
+              </a:rPr>
+              <a:t>T = 0,97996, шек 0,745</a:t>
+            </a:r>
+          </a:p>
+          <a:p xmlns:a="http://schemas.openxmlformats.org/drawingml/2006/main">
+            <a:pPr>
+              <a:buNone/>
+              <a:defRPr sz="2025" b="0">
+                <a:solidFill>
+                  <a:srgbClr val="FFFFFF"/>
+                </a:solidFill>
+                <a:latin typeface="Arial"/>
+                <a:ea typeface="Arial"/>
+                <a:cs typeface="Arial"/>
+              </a:defRPr>
+            </a:pPr>
+            <a:r>
+              <a:rPr sz="2025" b="0">
+                <a:solidFill>
+                  <a:srgbClr val="FFFFFF"/>
+                </a:solidFill>
+                <a:latin typeface="Arial"/>
+                <a:ea typeface="Arial"/>
+                <a:cs typeface="Arial"/>
+              </a:rPr>
+              <a:t>952 / 952 validation тексерілді</a:t>
+            </a:r>
+          </a:p>
+          <a:p xmlns:a="http://schemas.openxmlformats.org/drawingml/2006/main">
+            <a:pPr>
+              <a:buNone/>
+              <a:defRPr sz="2025" b="0">
+                <a:solidFill>
+                  <a:srgbClr val="FFFFFF"/>
+                </a:solidFill>
+                <a:latin typeface="Arial"/>
+                <a:ea typeface="Arial"/>
+                <a:cs typeface="Arial"/>
+              </a:defRPr>
+            </a:pPr>
+            <a:r>
+              <a:rPr sz="2025" b="0">
+                <a:solidFill>
+                  <a:srgbClr val="FFFFFF"/>
+                </a:solidFill>
+                <a:latin typeface="Arial"/>
+                <a:ea typeface="Arial"/>
+                <a:cs typeface="Arial"/>
+              </a:rPr>
+              <a:t>OOD шегі: 26,3409</a:t>
+            </a:r>
+          </a:p>
+        </p:txBody>
+      </p:sp>
+      <p:sp>
+        <p:nvSpPr>
+          <p:cNvPr id="8" name="">
+            <a:extLst xmlns:a="http://schemas.openxmlformats.org/drawingml/2006/main">
+              <a:ext uri="{FF2B5EF4-FFF2-40B4-BE49-F238E27FC236}">
+                <a16:creationId xmlns:a16="http://schemas.microsoft.com/office/drawing/2014/main" id="{5F162A07-EC40-43F1-87BF-7473D67B534C}"/>
+              </a:ext>
+            </a:extLst>
+          </p:cNvPr>
+          <p:cNvSpPr>
+            <a:spLocks xmlns:a="http://schemas.openxmlformats.org/drawingml/2006/main" noGrp="1"/>
+          </p:cNvSpPr>
+          <p:nvPr/>
+        </p:nvSpPr>
+        <p:spPr>
+          <a:xfrm xmlns:a="http://schemas.openxmlformats.org/drawingml/2006/main">
+            <a:off x="609600" y="5734050"/>
+            <a:ext cx="10858500" cy="666750"/>
+          </a:xfrm>
+          <a:prstGeom xmlns:a="http://schemas.openxmlformats.org/drawingml/2006/main" prst="rect">
+            <a:avLst/>
+          </a:prstGeom>
+          <a:noFill xmlns:a="http://schemas.openxmlformats.org/drawingml/2006/main"/>
+          <a:ln xmlns:a="http://schemas.openxmlformats.org/drawingml/2006/main" w="0">
+            <a:noFill/>
+          </a:ln>
+        </p:spPr>
+        <p:txBody>
+          <a:bodyPr xmlns:a="http://schemas.openxmlformats.org/drawingml/2006/main" lIns="0" tIns="0" rIns="0" bIns="0" anchor="t">
+            <a:noAutofit/>
+          </a:bodyPr>
+          <a:lstStyle xmlns:a="http://schemas.openxmlformats.org/drawingml/2006/main">
+            <a:defPPr>
+              <a:defRPr sz="2175" b="1">
+                <a:solidFill>
+                  <a:srgbClr val="B8E5D8"/>
+                </a:solidFill>
+                <a:latin typeface="Arial"/>
+                <a:ea typeface="Arial"/>
+                <a:cs typeface="Arial"/>
+              </a:defRPr>
+            </a:defPPr>
+          </a:lstStyle>
+          <a:p xmlns:a="http://schemas.openxmlformats.org/drawingml/2006/main">
+            <a:pPr>
+              <a:buNone/>
+              <a:defRPr sz="2175" b="1">
+                <a:solidFill>
+                  <a:srgbClr val="B8E5D8"/>
+                </a:solidFill>
+                <a:latin typeface="Arial"/>
+                <a:ea typeface="Arial"/>
+                <a:cs typeface="Arial"/>
+              </a:defRPr>
+            </a:pPr>
+            <a:r>
+              <a:rPr sz="2175" b="1">
+                <a:solidFill>
+                  <a:srgbClr val="B8E5D8"/>
+                </a:solidFill>
+                <a:latin typeface="Arial"/>
+                <a:ea typeface="Arial"/>
+                <a:cs typeface="Arial"/>
+              </a:rPr>
+              <a:t>Оқу прототипі. Клиникалық қолдануға бөлек тексеру қажет.</a:t>
+            </a:r>
+          </a:p>
+        </p:txBody>
+      </p:sp>
+    </p:spTree>
+    <p:extLst>
+      <p:ext uri="{BB962C8B-B14F-4D97-AF65-F5344CB8AC3E}">
+        <p14:creationId xmlns:p14="http://schemas.microsoft.com/office/powerpoint/2010/main" val="279016535"/>
       </p:ext>
     </p:extLst>
   </p:cSld>
@@ -4709,6 +6792,7 @@
           </a:lstStyle>
           <a:p xmlns:a="http://schemas.openxmlformats.org/drawingml/2006/main">
             <a:pPr>
+              <a:buNone/>
               <a:defRPr sz="3225" b="1">
                 <a:solidFill>
                   <a:srgbClr val="193E3A"/>
@@ -4777,6 +6861,7 @@
           </a:lstStyle>
           <a:p xmlns:a="http://schemas.openxmlformats.org/drawingml/2006/main">
             <a:pPr>
+              <a:buNone/>
               <a:defRPr sz="1275" b="0">
                 <a:solidFill>
                   <a:srgbClr val="617C77"/>
@@ -4845,6 +6930,7 @@
           </a:lstStyle>
           <a:p xmlns:a="http://schemas.openxmlformats.org/drawingml/2006/main">
             <a:pPr>
+              <a:buNone/>
               <a:defRPr sz="3075" b="1">
                 <a:solidFill>
                   <a:srgbClr val="087F77"/>
@@ -4913,6 +6999,7 @@
           </a:lstStyle>
           <a:p xmlns:a="http://schemas.openxmlformats.org/drawingml/2006/main">
             <a:pPr>
+              <a:buNone/>
               <a:defRPr sz="2325" b="0">
                 <a:solidFill>
                   <a:srgbClr val="617C77"/>
@@ -4936,6 +7023,7 @@
           </a:p>
           <a:p xmlns:a="http://schemas.openxmlformats.org/drawingml/2006/main">
             <a:pPr>
+              <a:buNone/>
               <a:defRPr sz="2325" b="0">
                 <a:solidFill>
                   <a:srgbClr val="617C77"/>
@@ -5004,6 +7092,7 @@
           </a:lstStyle>
           <a:p xmlns:a="http://schemas.openxmlformats.org/drawingml/2006/main">
             <a:pPr>
+              <a:buNone/>
               <a:defRPr sz="2250" b="1">
                 <a:solidFill>
                   <a:srgbClr val="193E3A"/>
@@ -5072,6 +7161,7 @@
           </a:lstStyle>
           <a:p xmlns:a="http://schemas.openxmlformats.org/drawingml/2006/main">
             <a:pPr>
+              <a:buNone/>
               <a:defRPr sz="2325" b="0">
                 <a:solidFill>
                   <a:srgbClr val="193E3A"/>
@@ -5095,6 +7185,7 @@
           </a:p>
           <a:p xmlns:a="http://schemas.openxmlformats.org/drawingml/2006/main">
             <a:pPr>
+              <a:buNone/>
               <a:defRPr sz="2325" b="0">
                 <a:solidFill>
                   <a:srgbClr val="193E3A"/>
@@ -5163,6 +7254,7 @@
           </a:lstStyle>
           <a:p xmlns:a="http://schemas.openxmlformats.org/drawingml/2006/main">
             <a:pPr>
+              <a:buNone/>
               <a:defRPr sz="2250" b="1">
                 <a:solidFill>
                   <a:srgbClr val="087F77"/>
@@ -5231,6 +7323,7 @@
           </a:lstStyle>
           <a:p xmlns:a="http://schemas.openxmlformats.org/drawingml/2006/main">
             <a:pPr>
+              <a:buNone/>
               <a:defRPr sz="2325" b="0">
                 <a:solidFill>
                   <a:srgbClr val="193E3A"/>
@@ -5254,6 +7347,7 @@
           </a:p>
           <a:p xmlns:a="http://schemas.openxmlformats.org/drawingml/2006/main">
             <a:pPr>
+              <a:buNone/>
               <a:defRPr sz="2325" b="0">
                 <a:solidFill>
                   <a:srgbClr val="193E3A"/>
@@ -5351,6 +7445,7 @@
           </a:lstStyle>
           <a:p xmlns:a="http://schemas.openxmlformats.org/drawingml/2006/main">
             <a:pPr>
+              <a:buNone/>
               <a:defRPr sz="3225" b="1">
                 <a:solidFill>
                   <a:srgbClr val="FFFFFF"/>
@@ -5419,6 +7514,7 @@
           </a:lstStyle>
           <a:p xmlns:a="http://schemas.openxmlformats.org/drawingml/2006/main">
             <a:pPr>
+              <a:buNone/>
               <a:defRPr sz="1275" b="0">
                 <a:solidFill>
                   <a:srgbClr val="B8E5D8"/>
@@ -5487,6 +7583,7 @@
           </a:lstStyle>
           <a:p xmlns:a="http://schemas.openxmlformats.org/drawingml/2006/main">
             <a:pPr>
+              <a:buNone/>
               <a:defRPr sz="6525" b="1">
                 <a:solidFill>
                   <a:srgbClr val="B8E5D8"/>
@@ -5555,6 +7652,7 @@
           </a:lstStyle>
           <a:p xmlns:a="http://schemas.openxmlformats.org/drawingml/2006/main">
             <a:pPr>
+              <a:buNone/>
               <a:defRPr sz="2100" b="0">
                 <a:solidFill>
                   <a:srgbClr val="FFFFFF"/>
@@ -5623,6 +7721,7 @@
           </a:lstStyle>
           <a:p xmlns:a="http://schemas.openxmlformats.org/drawingml/2006/main">
             <a:pPr>
+              <a:buNone/>
               <a:defRPr sz="5775" b="1">
                 <a:solidFill>
                   <a:srgbClr val="FFFFFF"/>
@@ -5691,6 +7790,7 @@
           </a:lstStyle>
           <a:p xmlns:a="http://schemas.openxmlformats.org/drawingml/2006/main">
             <a:pPr>
+              <a:buNone/>
               <a:defRPr sz="2100" b="0">
                 <a:solidFill>
                   <a:srgbClr val="B8E5D8"/>
@@ -5759,6 +7859,7 @@
           </a:lstStyle>
           <a:p xmlns:a="http://schemas.openxmlformats.org/drawingml/2006/main">
             <a:pPr>
+              <a:buNone/>
               <a:defRPr sz="4425" b="1">
                 <a:solidFill>
                   <a:srgbClr val="FFFFFF"/>
@@ -5827,6 +7928,7 @@
           </a:lstStyle>
           <a:p xmlns:a="http://schemas.openxmlformats.org/drawingml/2006/main">
             <a:pPr>
+              <a:buNone/>
               <a:defRPr sz="2175" b="0">
                 <a:solidFill>
                   <a:srgbClr val="B8E5D8"/>
@@ -5895,6 +7997,7 @@
           </a:lstStyle>
           <a:p xmlns:a="http://schemas.openxmlformats.org/drawingml/2006/main">
             <a:pPr>
+              <a:buNone/>
               <a:defRPr sz="4425" b="1">
                 <a:solidFill>
                   <a:srgbClr val="FFFFFF"/>
@@ -5963,6 +8066,7 @@
           </a:lstStyle>
           <a:p xmlns:a="http://schemas.openxmlformats.org/drawingml/2006/main">
             <a:pPr>
+              <a:buNone/>
               <a:defRPr sz="2175" b="0">
                 <a:solidFill>
                   <a:srgbClr val="B8E5D8"/>
@@ -6031,6 +8135,7 @@
           </a:lstStyle>
           <a:p xmlns:a="http://schemas.openxmlformats.org/drawingml/2006/main">
             <a:pPr>
+              <a:buNone/>
               <a:defRPr sz="4425" b="1">
                 <a:solidFill>
                   <a:srgbClr val="FFFFFF"/>
@@ -6099,6 +8204,7 @@
           </a:lstStyle>
           <a:p xmlns:a="http://schemas.openxmlformats.org/drawingml/2006/main">
             <a:pPr>
+              <a:buNone/>
               <a:defRPr sz="2175" b="0">
                 <a:solidFill>
                   <a:srgbClr val="B8E5D8"/>
@@ -6167,6 +8273,7 @@
           </a:lstStyle>
           <a:p xmlns:a="http://schemas.openxmlformats.org/drawingml/2006/main">
             <a:pPr>
+              <a:buNone/>
               <a:defRPr sz="1650" b="0">
                 <a:solidFill>
                   <a:srgbClr val="B8E5D8"/>
@@ -6264,6 +8371,7 @@
           </a:lstStyle>
           <a:p xmlns:a="http://schemas.openxmlformats.org/drawingml/2006/main">
             <a:pPr>
+              <a:buNone/>
               <a:defRPr sz="3225" b="1">
                 <a:solidFill>
                   <a:srgbClr val="193E3A"/>
@@ -6332,6 +8440,7 @@
           </a:lstStyle>
           <a:p xmlns:a="http://schemas.openxmlformats.org/drawingml/2006/main">
             <a:pPr>
+              <a:buNone/>
               <a:defRPr sz="1275" b="0">
                 <a:solidFill>
                   <a:srgbClr val="617C77"/>
@@ -6360,7 +8469,7 @@
           <p:cNvPr id="3" name="">
             <a:extLst xmlns:a="http://schemas.openxmlformats.org/drawingml/2006/main">
               <a:ext uri="{FF2B5EF4-FFF2-40B4-BE49-F238E27FC236}">
-                <a16:creationId xmlns:a16="http://schemas.microsoft.com/office/drawing/2014/main" id="{5F78CA89-9B2E-4C7C-BDDD-A019AAE69FD8}"/>
+                <a16:creationId xmlns:a16="http://schemas.microsoft.com/office/drawing/2014/main" id="{DE1B3F6E-5B57-4F7A-9910-122E455ED9E1}"/>
               </a:ext>
             </a:extLst>
           </p:cNvPr>
@@ -6803,7 +8912,7 @@
                           <a:ea typeface="Arial"/>
                           <a:cs typeface="Arial"/>
                         </a:rPr>
-                        <a:t>0,485</a:t>
+                        <a:t>0,475</a:t>
                       </a:r>
                     </a:p>
                   </a:txBody>
@@ -6839,7 +8948,7 @@
                           <a:ea typeface="Arial"/>
                           <a:cs typeface="Arial"/>
                         </a:rPr>
-                        <a:t>0,740</a:t>
+                        <a:t>0,745</a:t>
                       </a:r>
                     </a:p>
                   </a:txBody>
@@ -6911,6 +9020,7 @@
           </a:lstStyle>
           <a:p xmlns:a="http://schemas.openxmlformats.org/drawingml/2006/main">
             <a:pPr>
+              <a:buNone/>
               <a:defRPr sz="2775" b="1">
                 <a:solidFill>
                   <a:srgbClr val="087F77"/>
@@ -6979,6 +9089,7 @@
           </a:lstStyle>
           <a:p xmlns:a="http://schemas.openxmlformats.org/drawingml/2006/main">
             <a:pPr>
+              <a:buNone/>
               <a:defRPr sz="1875" b="0">
                 <a:solidFill>
                   <a:srgbClr val="617C77"/>
@@ -7047,6 +9158,7 @@
           </a:lstStyle>
           <a:p xmlns:a="http://schemas.openxmlformats.org/drawingml/2006/main">
             <a:pPr>
+              <a:buNone/>
               <a:defRPr sz="2550" b="1">
                 <a:solidFill>
                   <a:srgbClr val="193E3A"/>
@@ -7115,6 +9227,7 @@
           </a:lstStyle>
           <a:p xmlns:a="http://schemas.openxmlformats.org/drawingml/2006/main">
             <a:pPr>
+              <a:buNone/>
               <a:defRPr sz="1875" b="0">
                 <a:solidFill>
                   <a:srgbClr val="617C77"/>
@@ -7212,6 +9325,7 @@
           </a:lstStyle>
           <a:p xmlns:a="http://schemas.openxmlformats.org/drawingml/2006/main">
             <a:pPr>
+              <a:buNone/>
               <a:defRPr sz="3225" b="1">
                 <a:solidFill>
                   <a:srgbClr val="FFFFFF"/>
@@ -7280,6 +9394,7 @@
           </a:lstStyle>
           <a:p xmlns:a="http://schemas.openxmlformats.org/drawingml/2006/main">
             <a:pPr>
+              <a:buNone/>
               <a:defRPr sz="1275" b="0">
                 <a:solidFill>
                   <a:srgbClr val="B8E5D8"/>
@@ -7348,6 +9463,7 @@
           </a:lstStyle>
           <a:p xmlns:a="http://schemas.openxmlformats.org/drawingml/2006/main">
             <a:pPr>
+              <a:buNone/>
               <a:defRPr sz="3150" b="1">
                 <a:solidFill>
                   <a:srgbClr val="B8E5D8"/>
@@ -7416,6 +9532,7 @@
           </a:lstStyle>
           <a:p xmlns:a="http://schemas.openxmlformats.org/drawingml/2006/main">
             <a:pPr>
+              <a:buNone/>
               <a:defRPr sz="2925" b="0">
                 <a:solidFill>
                   <a:srgbClr val="FFFFFF"/>
@@ -7484,6 +9601,7 @@
           </a:lstStyle>
           <a:p xmlns:a="http://schemas.openxmlformats.org/drawingml/2006/main">
             <a:pPr>
+              <a:buNone/>
               <a:defRPr sz="2550" b="0">
                 <a:solidFill>
                   <a:srgbClr val="FFFFFF"/>
@@ -7552,6 +9670,7 @@
           </a:lstStyle>
           <a:p xmlns:a="http://schemas.openxmlformats.org/drawingml/2006/main">
             <a:pPr>
+              <a:buNone/>
               <a:defRPr sz="1950" b="1">
                 <a:solidFill>
                   <a:srgbClr val="B8E5D8"/>
@@ -7620,6 +9739,7 @@
           </a:lstStyle>
           <a:p xmlns:a="http://schemas.openxmlformats.org/drawingml/2006/main">
             <a:pPr>
+              <a:buNone/>
               <a:defRPr sz="2475" b="1">
                 <a:solidFill>
                   <a:srgbClr val="FFFFFF"/>
@@ -7638,7 +9758,7 @@
                 <a:ea typeface="Arial"/>
                 <a:cs typeface="Arial"/>
               </a:rPr>
-              <a:t>z = ln 4,  p = 0,80 ≥ 0,740</a:t>
+              <a:t>p_raw = 0,80, p_cal ≈ 0,804 ≥ 0,745</a:t>
             </a:r>
           </a:p>
         </p:txBody>
@@ -7688,6 +9808,7 @@
           </a:lstStyle>
           <a:p xmlns:a="http://schemas.openxmlformats.org/drawingml/2006/main">
             <a:pPr>
+              <a:buNone/>
               <a:defRPr sz="1650" b="0">
                 <a:solidFill>
                   <a:srgbClr val="B8E5D8"/>
@@ -7785,6 +9906,7 @@
           </a:lstStyle>
           <a:p xmlns:a="http://schemas.openxmlformats.org/drawingml/2006/main">
             <a:pPr>
+              <a:buNone/>
               <a:defRPr sz="3225" b="1">
                 <a:solidFill>
                   <a:srgbClr val="193E3A"/>
@@ -7853,6 +9975,7 @@
           </a:lstStyle>
           <a:p xmlns:a="http://schemas.openxmlformats.org/drawingml/2006/main">
             <a:pPr>
+              <a:buNone/>
               <a:defRPr sz="1275" b="0">
                 <a:solidFill>
                   <a:srgbClr val="617C77"/>
@@ -7881,7 +10004,7 @@
           <p:cNvPr id="3" name="">
             <a:extLst xmlns:a="http://schemas.openxmlformats.org/drawingml/2006/main">
               <a:ext uri="{FF2B5EF4-FFF2-40B4-BE49-F238E27FC236}">
-                <a16:creationId xmlns:a16="http://schemas.microsoft.com/office/drawing/2014/main" id="{75E439C4-E3EF-4AC2-9805-0D869765F69F}"/>
+                <a16:creationId xmlns:a16="http://schemas.microsoft.com/office/drawing/2014/main" id="{76AC81A9-2618-4EE1-B190-E6C7A47CF7CF}"/>
               </a:ext>
             </a:extLst>
           </p:cNvPr>
@@ -7890,7 +10013,7 @@
         </p:nvGraphicFramePr>
         <p:xfrm>
           <a:off xmlns:a="http://schemas.openxmlformats.org/drawingml/2006/main" x="609600" y="1714500"/>
-          <a:ext xmlns:a="http://schemas.openxmlformats.org/drawingml/2006/main" cx="10972800" cy="3105150"/>
+          <a:ext xmlns:a="http://schemas.openxmlformats.org/drawingml/2006/main" cx="10972800" cy="3622675"/>
         </p:xfrm>
         <a:graphic xmlns:a="http://schemas.openxmlformats.org/drawingml/2006/main">
           <a:graphicData uri="http://schemas.openxmlformats.org/drawingml/2006/table">
@@ -7901,14 +10024,14 @@
                 <a:gridCol w="3333750"/>
                 <a:gridCol w="3333750"/>
               </a:tblGrid>
-              <a:tr h="517525">
+              <a:tr h="443593">
                 <a:tc>
                   <a:txBody>
                     <a:bodyPr/>
                     <a:lstStyle/>
                     <a:p>
                       <a:r>
-                        <a:rPr sz="1800" b="1">
+                        <a:rPr sz="1725" b="1">
                           <a:solidFill>
                             <a:srgbClr val="FFFFFF"/>
                           </a:solidFill>
@@ -7956,7 +10079,7 @@
                     <a:lstStyle/>
                     <a:p>
                       <a:r>
-                        <a:rPr sz="1800" b="1">
+                        <a:rPr sz="1725" b="1">
                           <a:solidFill>
                             <a:srgbClr val="FFFFFF"/>
                           </a:solidFill>
@@ -7998,7 +10121,7 @@
                     <a:lstStyle/>
                     <a:p>
                       <a:r>
-                        <a:rPr sz="1800" b="1">
+                        <a:rPr sz="1725" b="1">
                           <a:solidFill>
                             <a:srgbClr val="FFFFFF"/>
                           </a:solidFill>
@@ -8035,14 +10158,14 @@
                   </a:tcPr>
                 </a:tc>
               </a:tr>
-              <a:tr h="517525">
+              <a:tr h="443593">
                 <a:tc>
                   <a:txBody>
                     <a:bodyPr/>
                     <a:lstStyle/>
                     <a:p>
                       <a:r>
-                        <a:rPr sz="1800" b="0">
+                        <a:rPr sz="1725" b="0">
                           <a:solidFill>
                             <a:srgbClr val="193E3A"/>
                           </a:solidFill>
@@ -8084,7 +10207,7 @@
                     <a:lstStyle/>
                     <a:p>
                       <a:r>
-                        <a:rPr sz="1800" b="0">
+                        <a:rPr sz="1725" b="0">
                           <a:solidFill>
                             <a:srgbClr val="193E3A"/>
                           </a:solidFill>
@@ -8092,7 +10215,7 @@
                           <a:ea typeface="Arial"/>
                           <a:cs typeface="Arial"/>
                         </a:rPr>
-                        <a:t>71,68%</a:t>
+                        <a:t>71,52%</a:t>
                       </a:r>
                     </a:p>
                   </a:txBody>
@@ -8120,7 +10243,7 @@
                     <a:lstStyle/>
                     <a:p>
                       <a:r>
-                        <a:rPr sz="1800" b="0">
+                        <a:rPr sz="1725" b="0">
                           <a:solidFill>
                             <a:srgbClr val="193E3A"/>
                           </a:solidFill>
@@ -8151,14 +10274,130 @@
                   </a:tcPr>
                 </a:tc>
               </a:tr>
-              <a:tr h="517525">
+              <a:tr h="443593">
                 <a:tc>
                   <a:txBody>
                     <a:bodyPr/>
                     <a:lstStyle/>
                     <a:p>
                       <a:r>
-                        <a:rPr sz="1800" b="0">
+                        <a:rPr sz="1725" b="0">
+                          <a:solidFill>
+                            <a:srgbClr val="193E3A"/>
+                          </a:solidFill>
+                          <a:latin typeface="Arial"/>
+                          <a:ea typeface="Arial"/>
+                          <a:cs typeface="Arial"/>
+                        </a:rPr>
+                        <a:t>Precision</a:t>
+                      </a:r>
+                    </a:p>
+                  </a:txBody>
+                  <a:tcPr marL="91440" marR="91440" marT="45720" marB="45720">
+                    <a:lnL w="9525">
+                      <a:solidFill>
+                        <a:srgbClr val="CBDDD6"/>
+                      </a:solidFill>
+                      <a:prstDash val="solid"/>
+                    </a:lnL>
+                    <a:lnR w="9525">
+                      <a:solidFill>
+                        <a:srgbClr val="CBDDD6"/>
+                      </a:solidFill>
+                      <a:prstDash val="solid"/>
+                    </a:lnR>
+                    <a:lnB w="9525">
+                      <a:solidFill>
+                        <a:srgbClr val="CBDDD6"/>
+                      </a:solidFill>
+                      <a:prstDash val="solid"/>
+                    </a:lnB>
+                    <a:solidFill>
+                      <a:srgbClr val="E9F3EE"/>
+                    </a:solidFill>
+                  </a:tcPr>
+                </a:tc>
+                <a:tc>
+                  <a:txBody>
+                    <a:bodyPr/>
+                    <a:lstStyle/>
+                    <a:p>
+                      <a:r>
+                        <a:rPr sz="1725" b="0">
+                          <a:solidFill>
+                            <a:srgbClr val="193E3A"/>
+                          </a:solidFill>
+                          <a:latin typeface="Arial"/>
+                          <a:ea typeface="Arial"/>
+                          <a:cs typeface="Arial"/>
+                        </a:rPr>
+                        <a:t>70,81%</a:t>
+                      </a:r>
+                    </a:p>
+                  </a:txBody>
+                  <a:tcPr marL="91440" marR="91440" marT="45720" marB="45720">
+                    <a:lnR w="9525">
+                      <a:solidFill>
+                        <a:srgbClr val="CBDDD6"/>
+                      </a:solidFill>
+                      <a:prstDash val="solid"/>
+                    </a:lnR>
+                    <a:lnB w="9525">
+                      <a:solidFill>
+                        <a:srgbClr val="CBDDD6"/>
+                      </a:solidFill>
+                      <a:prstDash val="solid"/>
+                    </a:lnB>
+                    <a:solidFill>
+                      <a:srgbClr val="E9F3EE"/>
+                    </a:solidFill>
+                  </a:tcPr>
+                </a:tc>
+                <a:tc>
+                  <a:txBody>
+                    <a:bodyPr/>
+                    <a:lstStyle/>
+                    <a:p>
+                      <a:r>
+                        <a:rPr sz="1725" b="0">
+                          <a:solidFill>
+                            <a:srgbClr val="193E3A"/>
+                          </a:solidFill>
+                          <a:latin typeface="Arial"/>
+                          <a:ea typeface="Arial"/>
+                          <a:cs typeface="Arial"/>
+                        </a:rPr>
+                        <a:t>87,74%</a:t>
+                      </a:r>
+                    </a:p>
+                  </a:txBody>
+                  <a:tcPr marL="91440" marR="91440" marT="45720" marB="45720">
+                    <a:lnR w="9525">
+                      <a:solidFill>
+                        <a:srgbClr val="CBDDD6"/>
+                      </a:solidFill>
+                      <a:prstDash val="solid"/>
+                    </a:lnR>
+                    <a:lnB w="9525">
+                      <a:solidFill>
+                        <a:srgbClr val="CBDDD6"/>
+                      </a:solidFill>
+                      <a:prstDash val="solid"/>
+                    </a:lnB>
+                    <a:solidFill>
+                      <a:srgbClr val="E9F3EE"/>
+                    </a:solidFill>
+                  </a:tcPr>
+                </a:tc>
+              </a:tr>
+              <a:tr h="443593">
+                <a:tc>
+                  <a:txBody>
+                    <a:bodyPr/>
+                    <a:lstStyle/>
+                    <a:p>
+                      <a:r>
+                        <a:rPr sz="1725" b="0">
                           <a:solidFill>
                             <a:srgbClr val="193E3A"/>
                           </a:solidFill>
@@ -8190,7 +10429,7 @@
                       <a:prstDash val="solid"/>
                     </a:lnB>
                     <a:solidFill>
-                      <a:srgbClr val="E9F3EE"/>
+                      <a:srgbClr val="FFFFFF"/>
                     </a:solidFill>
                   </a:tcPr>
                 </a:tc>
@@ -8200,7 +10439,7 @@
                     <a:lstStyle/>
                     <a:p>
                       <a:r>
-                        <a:rPr sz="1800" b="0">
+                        <a:rPr sz="1725" b="0">
                           <a:solidFill>
                             <a:srgbClr val="193E3A"/>
                           </a:solidFill>
@@ -8226,7 +10465,7 @@
                       <a:prstDash val="solid"/>
                     </a:lnB>
                     <a:solidFill>
-                      <a:srgbClr val="E9F3EE"/>
+                      <a:srgbClr val="FFFFFF"/>
                     </a:solidFill>
                   </a:tcPr>
                 </a:tc>
@@ -8236,7 +10475,7 @@
                     <a:lstStyle/>
                     <a:p>
                       <a:r>
-                        <a:rPr sz="1800" b="0">
+                        <a:rPr sz="1725" b="0">
                           <a:solidFill>
                             <a:srgbClr val="193E3A"/>
                           </a:solidFill>
@@ -8262,19 +10501,19 @@
                       <a:prstDash val="solid"/>
                     </a:lnB>
                     <a:solidFill>
-                      <a:srgbClr val="E9F3EE"/>
+                      <a:srgbClr val="FFFFFF"/>
                     </a:solidFill>
                   </a:tcPr>
                 </a:tc>
               </a:tr>
-              <a:tr h="517525">
+              <a:tr h="443593">
                 <a:tc>
                   <a:txBody>
                     <a:bodyPr/>
                     <a:lstStyle/>
                     <a:p>
                       <a:r>
-                        <a:rPr sz="1800" b="0">
+                        <a:rPr sz="1725" b="0">
                           <a:solidFill>
                             <a:srgbClr val="193E3A"/>
                           </a:solidFill>
@@ -8306,7 +10545,7 @@
                       <a:prstDash val="solid"/>
                     </a:lnB>
                     <a:solidFill>
-                      <a:srgbClr val="FFFFFF"/>
+                      <a:srgbClr val="E9F3EE"/>
                     </a:solidFill>
                   </a:tcPr>
                 </a:tc>
@@ -8316,7 +10555,7 @@
                     <a:lstStyle/>
                     <a:p>
                       <a:r>
-                        <a:rPr sz="1800" b="0">
+                        <a:rPr sz="1725" b="0">
                           <a:solidFill>
                             <a:srgbClr val="193E3A"/>
                           </a:solidFill>
@@ -8324,7 +10563,7 @@
                           <a:ea typeface="Arial"/>
                           <a:cs typeface="Arial"/>
                         </a:rPr>
-                        <a:t>36,36%</a:t>
+                        <a:t>35,93%</a:t>
                       </a:r>
                     </a:p>
                   </a:txBody>
@@ -8342,7 +10581,7 @@
                       <a:prstDash val="solid"/>
                     </a:lnB>
                     <a:solidFill>
-                      <a:srgbClr val="FFFFFF"/>
+                      <a:srgbClr val="E9F3EE"/>
                     </a:solidFill>
                   </a:tcPr>
                 </a:tc>
@@ -8352,7 +10591,7 @@
                     <a:lstStyle/>
                     <a:p>
                       <a:r>
-                        <a:rPr sz="1800" b="0">
+                        <a:rPr sz="1725" b="0">
                           <a:solidFill>
                             <a:srgbClr val="193E3A"/>
                           </a:solidFill>
@@ -8378,19 +10617,19 @@
                       <a:prstDash val="solid"/>
                     </a:lnB>
                     <a:solidFill>
-                      <a:srgbClr val="FFFFFF"/>
+                      <a:srgbClr val="E9F3EE"/>
                     </a:solidFill>
                   </a:tcPr>
                 </a:tc>
               </a:tr>
-              <a:tr h="517525">
+              <a:tr h="443593">
                 <a:tc>
                   <a:txBody>
                     <a:bodyPr/>
                     <a:lstStyle/>
                     <a:p>
                       <a:r>
-                        <a:rPr sz="1800" b="0">
+                        <a:rPr sz="1725" b="0">
                           <a:solidFill>
                             <a:srgbClr val="193E3A"/>
                           </a:solidFill>
@@ -8422,7 +10661,7 @@
                       <a:prstDash val="solid"/>
                     </a:lnB>
                     <a:solidFill>
-                      <a:srgbClr val="E9F3EE"/>
+                      <a:srgbClr val="FFFFFF"/>
                     </a:solidFill>
                   </a:tcPr>
                 </a:tc>
@@ -8432,7 +10671,7 @@
                     <a:lstStyle/>
                     <a:p>
                       <a:r>
-                        <a:rPr sz="1800" b="0">
+                        <a:rPr sz="1725" b="0">
                           <a:solidFill>
                             <a:srgbClr val="193E3A"/>
                           </a:solidFill>
@@ -8440,7 +10679,7 @@
                           <a:ea typeface="Arial"/>
                           <a:cs typeface="Arial"/>
                         </a:rPr>
-                        <a:t>0,8040</a:t>
+                        <a:t>0,8031</a:t>
                       </a:r>
                     </a:p>
                   </a:txBody>
@@ -8458,7 +10697,7 @@
                       <a:prstDash val="solid"/>
                     </a:lnB>
                     <a:solidFill>
-                      <a:srgbClr val="E9F3EE"/>
+                      <a:srgbClr val="FFFFFF"/>
                     </a:solidFill>
                   </a:tcPr>
                 </a:tc>
@@ -8468,7 +10707,7 @@
                     <a:lstStyle/>
                     <a:p>
                       <a:r>
-                        <a:rPr sz="1800" b="0">
+                        <a:rPr sz="1725" b="0">
                           <a:solidFill>
                             <a:srgbClr val="193E3A"/>
                           </a:solidFill>
@@ -8494,19 +10733,19 @@
                       <a:prstDash val="solid"/>
                     </a:lnB>
                     <a:solidFill>
-                      <a:srgbClr val="E9F3EE"/>
+                      <a:srgbClr val="FFFFFF"/>
                     </a:solidFill>
                   </a:tcPr>
                 </a:tc>
               </a:tr>
-              <a:tr h="517525">
+              <a:tr h="443593">
                 <a:tc>
                   <a:txBody>
                     <a:bodyPr/>
                     <a:lstStyle/>
                     <a:p>
                       <a:r>
-                        <a:rPr sz="1800" b="0">
+                        <a:rPr sz="1725" b="0">
                           <a:solidFill>
                             <a:srgbClr val="193E3A"/>
                           </a:solidFill>
@@ -8538,7 +10777,7 @@
                       <a:prstDash val="solid"/>
                     </a:lnB>
                     <a:solidFill>
-                      <a:srgbClr val="FFFFFF"/>
+                      <a:srgbClr val="E9F3EE"/>
                     </a:solidFill>
                   </a:tcPr>
                 </a:tc>
@@ -8548,7 +10787,7 @@
                     <a:lstStyle/>
                     <a:p>
                       <a:r>
-                        <a:rPr sz="1800" b="0">
+                        <a:rPr sz="1725" b="0">
                           <a:solidFill>
                             <a:srgbClr val="193E3A"/>
                           </a:solidFill>
@@ -8574,7 +10813,7 @@
                       <a:prstDash val="solid"/>
                     </a:lnB>
                     <a:solidFill>
-                      <a:srgbClr val="FFFFFF"/>
+                      <a:srgbClr val="E9F3EE"/>
                     </a:solidFill>
                   </a:tcPr>
                 </a:tc>
@@ -8584,7 +10823,7 @@
                     <a:lstStyle/>
                     <a:p>
                       <a:r>
-                        <a:rPr sz="1800" b="0">
+                        <a:rPr sz="1725" b="0">
                           <a:solidFill>
                             <a:srgbClr val="193E3A"/>
                           </a:solidFill>
@@ -8610,7 +10849,7 @@
                       <a:prstDash val="solid"/>
                     </a:lnB>
                     <a:solidFill>
-                      <a:srgbClr val="FFFFFF"/>
+                      <a:srgbClr val="E9F3EE"/>
                     </a:solidFill>
                   </a:tcPr>
                 </a:tc>
@@ -8664,6 +10903,7 @@
           </a:lstStyle>
           <a:p xmlns:a="http://schemas.openxmlformats.org/drawingml/2006/main">
             <a:pPr>
+              <a:buNone/>
               <a:defRPr sz="3150" b="1">
                 <a:solidFill>
                   <a:srgbClr val="087F77"/>
@@ -8682,7 +10922,7 @@
                 <a:ea typeface="Arial"/>
                 <a:cs typeface="Arial"/>
               </a:rPr>
-              <a:t>+17,48 п.п.</a:t>
+              <a:t>p = 4,83 × 10⁻²¹</a:t>
             </a:r>
           </a:p>
         </p:txBody>
@@ -8732,6 +10972,7 @@
           </a:lstStyle>
           <a:p xmlns:a="http://schemas.openxmlformats.org/drawingml/2006/main">
             <a:pPr>
+              <a:buNone/>
               <a:defRPr sz="1725" b="0">
                 <a:solidFill>
                   <a:srgbClr val="617C77"/>
@@ -8750,7 +10991,7 @@
                 <a:ea typeface="Arial"/>
                 <a:cs typeface="Arial"/>
               </a:rPr>
-              <a:t>accuracy өсімі, CNN-мен салыстырғанда</a:t>
+              <a:t>McNemar: осы тестте айырма маңызды</a:t>
             </a:r>
           </a:p>
         </p:txBody>
@@ -8800,6 +11041,7 @@
           </a:lstStyle>
           <a:p xmlns:a="http://schemas.openxmlformats.org/drawingml/2006/main">
             <a:pPr>
+              <a:buNone/>
               <a:defRPr sz="2775" b="1">
                 <a:solidFill>
                   <a:srgbClr val="193E3A"/>
@@ -8868,6 +11110,7 @@
           </a:lstStyle>
           <a:p xmlns:a="http://schemas.openxmlformats.org/drawingml/2006/main">
             <a:pPr>
+              <a:buNone/>
               <a:defRPr sz="1725" b="0">
                 <a:solidFill>
                   <a:srgbClr val="617C77"/>
@@ -8965,6 +11208,7 @@
           </a:lstStyle>
           <a:p xmlns:a="http://schemas.openxmlformats.org/drawingml/2006/main">
             <a:pPr>
+              <a:buNone/>
               <a:defRPr sz="3225" b="1">
                 <a:solidFill>
                   <a:srgbClr val="193E3A"/>
@@ -9033,6 +11277,7 @@
           </a:lstStyle>
           <a:p xmlns:a="http://schemas.openxmlformats.org/drawingml/2006/main">
             <a:pPr>
+              <a:buNone/>
               <a:defRPr sz="1275" b="0">
                 <a:solidFill>
                   <a:srgbClr val="617C77"/>
@@ -9061,7 +11306,7 @@
           <p:cNvPr id="3" name="">
             <a:extLst xmlns:a="http://schemas.openxmlformats.org/drawingml/2006/main">
               <a:ext uri="{FF2B5EF4-FFF2-40B4-BE49-F238E27FC236}">
-                <a16:creationId xmlns:a16="http://schemas.microsoft.com/office/drawing/2014/main" id="{4ADB8296-A7EC-4EF5-9FD9-71678BE8B6C5}"/>
+                <a16:creationId xmlns:a16="http://schemas.microsoft.com/office/drawing/2014/main" id="{889621C8-30E2-4672-9413-2F2A6A04C086}"/>
               </a:ext>
             </a:extLst>
           </p:cNvPr>
@@ -9071,7 +11316,7 @@
           <p:nvPr/>
         </p:nvPicPr>
         <p:blipFill>
-          <a:blip xmlns:r="http://schemas.openxmlformats.org/officeDocument/2006/relationships" xmlns:a="http://schemas.openxmlformats.org/drawingml/2006/main" r:embed="Rb264804023b54073"/>
+          <a:blip xmlns:r="http://schemas.openxmlformats.org/officeDocument/2006/relationships" xmlns:a="http://schemas.openxmlformats.org/drawingml/2006/main" r:embed="Ra4f547400dda46cc"/>
           <a:stretch xmlns:a="http://schemas.openxmlformats.org/drawingml/2006/main"/>
         </p:blipFill>
         <p:spPr>
@@ -9117,7 +11362,7 @@
           </a:bodyPr>
           <a:lstStyle xmlns:a="http://schemas.openxmlformats.org/drawingml/2006/main">
             <a:defPPr>
-              <a:defRPr sz="2400" b="1">
+              <a:defRPr sz="2025" b="1">
                 <a:solidFill>
                   <a:srgbClr val="087F77"/>
                 </a:solidFill>
@@ -9129,7 +11374,8 @@
           </a:lstStyle>
           <a:p xmlns:a="http://schemas.openxmlformats.org/drawingml/2006/main">
             <a:pPr>
-              <a:defRPr sz="2400" b="1">
+              <a:buNone/>
+              <a:defRPr sz="2025" b="1">
                 <a:solidFill>
                   <a:srgbClr val="087F77"/>
                 </a:solidFill>
@@ -9139,7 +11385,7 @@
               </a:defRPr>
             </a:pPr>
             <a:r>
-              <a:rPr sz="2400" b="1">
+              <a:rPr sz="2025" b="1">
                 <a:solidFill>
                   <a:srgbClr val="087F77"/>
                 </a:solidFill>
@@ -9147,7 +11393,7 @@
                 <a:ea typeface="Arial"/>
                 <a:cs typeface="Arial"/>
               </a:rPr>
-              <a:t>JPG / PNG</a:t>
+              <a:t>JPG / PNG / DICOM</a:t>
             </a:r>
           </a:p>
         </p:txBody>
@@ -9197,6 +11443,7 @@
           </a:lstStyle>
           <a:p xmlns:a="http://schemas.openxmlformats.org/drawingml/2006/main">
             <a:pPr>
+              <a:buNone/>
               <a:defRPr sz="1950" b="0">
                 <a:solidFill>
                   <a:srgbClr val="617C77"/>
@@ -9220,6 +11467,7 @@
           </a:p>
           <a:p xmlns:a="http://schemas.openxmlformats.org/drawingml/2006/main">
             <a:pPr>
+              <a:buNone/>
               <a:defRPr sz="1950" b="0">
                 <a:solidFill>
                   <a:srgbClr val="617C77"/>
@@ -9288,6 +11536,7 @@
           </a:lstStyle>
           <a:p xmlns:a="http://schemas.openxmlformats.org/drawingml/2006/main">
             <a:pPr>
+              <a:buNone/>
               <a:defRPr sz="2325" b="1">
                 <a:solidFill>
                   <a:srgbClr val="193E3A"/>
@@ -9311,6 +11560,7 @@
           </a:p>
           <a:p xmlns:a="http://schemas.openxmlformats.org/drawingml/2006/main">
             <a:pPr>
+              <a:buNone/>
               <a:defRPr sz="2325" b="1">
                 <a:solidFill>
                   <a:srgbClr val="193E3A"/>
@@ -9379,6 +11629,7 @@
           </a:lstStyle>
           <a:p xmlns:a="http://schemas.openxmlformats.org/drawingml/2006/main">
             <a:pPr>
+              <a:buNone/>
               <a:defRPr sz="1875" b="0">
                 <a:solidFill>
                   <a:srgbClr val="617C77"/>
@@ -9402,6 +11653,7 @@
           </a:p>
           <a:p xmlns:a="http://schemas.openxmlformats.org/drawingml/2006/main">
             <a:pPr>
+              <a:buNone/>
               <a:defRPr sz="1875" b="0">
                 <a:solidFill>
                   <a:srgbClr val="617C77"/>
@@ -9499,6 +11751,7 @@
           </a:lstStyle>
           <a:p xmlns:a="http://schemas.openxmlformats.org/drawingml/2006/main">
             <a:pPr>
+              <a:buNone/>
               <a:defRPr sz="3225" b="1">
                 <a:solidFill>
                   <a:srgbClr val="193E3A"/>
@@ -9567,6 +11820,7 @@
           </a:lstStyle>
           <a:p xmlns:a="http://schemas.openxmlformats.org/drawingml/2006/main">
             <a:pPr>
+              <a:buNone/>
               <a:defRPr sz="1275" b="0">
                 <a:solidFill>
                   <a:srgbClr val="617C77"/>
@@ -9595,7 +11849,7 @@
           <p:cNvPr id="3" name="">
             <a:extLst xmlns:a="http://schemas.openxmlformats.org/drawingml/2006/main">
               <a:ext uri="{FF2B5EF4-FFF2-40B4-BE49-F238E27FC236}">
-                <a16:creationId xmlns:a16="http://schemas.microsoft.com/office/drawing/2014/main" id="{F43296C3-5451-4C60-A28D-F8853848611C}"/>
+                <a16:creationId xmlns:a16="http://schemas.microsoft.com/office/drawing/2014/main" id="{97B6F7E9-331C-44CA-AEAE-E127888CA0AA}"/>
               </a:ext>
             </a:extLst>
           </p:cNvPr>
@@ -9605,7 +11859,7 @@
           <p:nvPr/>
         </p:nvPicPr>
         <p:blipFill>
-          <a:blip xmlns:r="http://schemas.openxmlformats.org/officeDocument/2006/relationships" xmlns:a="http://schemas.openxmlformats.org/drawingml/2006/main" r:embed="Ra4b335d3672040e8"/>
+          <a:blip xmlns:r="http://schemas.openxmlformats.org/officeDocument/2006/relationships" xmlns:a="http://schemas.openxmlformats.org/drawingml/2006/main" r:embed="Re8c1dcefbfc349cc"/>
           <a:stretch xmlns:a="http://schemas.openxmlformats.org/drawingml/2006/main"/>
         </p:blipFill>
         <p:spPr>
@@ -9663,6 +11917,7 @@
           </a:lstStyle>
           <a:p xmlns:a="http://schemas.openxmlformats.org/drawingml/2006/main">
             <a:pPr>
+              <a:buNone/>
               <a:defRPr sz="2550" b="1">
                 <a:solidFill>
                   <a:srgbClr val="087F77"/>
@@ -9731,6 +11986,7 @@
           </a:lstStyle>
           <a:p xmlns:a="http://schemas.openxmlformats.org/drawingml/2006/main">
             <a:pPr>
+              <a:buNone/>
               <a:defRPr sz="2025" b="0">
                 <a:solidFill>
                   <a:srgbClr val="193E3A"/>
@@ -9754,6 +12010,7 @@
           </a:p>
           <a:p xmlns:a="http://schemas.openxmlformats.org/drawingml/2006/main">
             <a:pPr>
+              <a:buNone/>
               <a:defRPr sz="2025" b="0">
                 <a:solidFill>
                   <a:srgbClr val="193E3A"/>
@@ -9822,6 +12079,7 @@
           </a:lstStyle>
           <a:p xmlns:a="http://schemas.openxmlformats.org/drawingml/2006/main">
             <a:pPr>
+              <a:buNone/>
               <a:defRPr sz="1875" b="0">
                 <a:solidFill>
                   <a:srgbClr val="617C77"/>
@@ -9845,6 +12103,7 @@
           </a:p>
           <a:p xmlns:a="http://schemas.openxmlformats.org/drawingml/2006/main">
             <a:pPr>
+              <a:buNone/>
               <a:defRPr sz="1875" b="0">
                 <a:solidFill>
                   <a:srgbClr val="617C77"/>
@@ -9868,6 +12127,7 @@
           </a:p>
           <a:p xmlns:a="http://schemas.openxmlformats.org/drawingml/2006/main">
             <a:pPr>
+              <a:buNone/>
               <a:defRPr sz="1875" b="0">
                 <a:solidFill>
                   <a:srgbClr val="617C77"/>
@@ -9965,6 +12225,7 @@
           </a:lstStyle>
           <a:p xmlns:a="http://schemas.openxmlformats.org/drawingml/2006/main">
             <a:pPr>
+              <a:buNone/>
               <a:defRPr sz="3225" b="1">
                 <a:solidFill>
                   <a:srgbClr val="193E3A"/>
@@ -10033,6 +12294,7 @@
           </a:lstStyle>
           <a:p xmlns:a="http://schemas.openxmlformats.org/drawingml/2006/main">
             <a:pPr>
+              <a:buNone/>
               <a:defRPr sz="1275" b="0">
                 <a:solidFill>
                   <a:srgbClr val="617C77"/>
@@ -10061,7 +12323,7 @@
           <p:cNvPr id="3" name="">
             <a:extLst xmlns:a="http://schemas.openxmlformats.org/drawingml/2006/main">
               <a:ext uri="{FF2B5EF4-FFF2-40B4-BE49-F238E27FC236}">
-                <a16:creationId xmlns:a16="http://schemas.microsoft.com/office/drawing/2014/main" id="{EAAF0538-6580-4CA4-89F2-E006D613247D}"/>
+                <a16:creationId xmlns:a16="http://schemas.microsoft.com/office/drawing/2014/main" id="{CE93AABE-DCB3-45F9-B88F-812A13E2A2C7}"/>
               </a:ext>
             </a:extLst>
           </p:cNvPr>
@@ -10071,7 +12333,7 @@
           <p:nvPr/>
         </p:nvPicPr>
         <p:blipFill>
-          <a:blip xmlns:r="http://schemas.openxmlformats.org/officeDocument/2006/relationships" xmlns:a="http://schemas.openxmlformats.org/drawingml/2006/main" r:embed="R53c038bdb16e4ad0"/>
+          <a:blip xmlns:r="http://schemas.openxmlformats.org/officeDocument/2006/relationships" xmlns:a="http://schemas.openxmlformats.org/drawingml/2006/main" r:embed="R2887cf7f91c14c9e"/>
           <a:stretch xmlns:a="http://schemas.openxmlformats.org/drawingml/2006/main"/>
         </p:blipFill>
         <p:spPr>
@@ -10089,7 +12351,7 @@
           <p:cNvPr id="4" name="">
             <a:extLst xmlns:a="http://schemas.openxmlformats.org/drawingml/2006/main">
               <a:ext uri="{FF2B5EF4-FFF2-40B4-BE49-F238E27FC236}">
-                <a16:creationId xmlns:a16="http://schemas.microsoft.com/office/drawing/2014/main" id="{27665AD7-32BF-45A2-8545-816328CE618A}"/>
+                <a16:creationId xmlns:a16="http://schemas.microsoft.com/office/drawing/2014/main" id="{E201A30C-9F54-4E1C-9449-7697B8144189}"/>
               </a:ext>
             </a:extLst>
           </p:cNvPr>
@@ -10099,13 +12361,13 @@
           <p:nvPr/>
         </p:nvPicPr>
         <p:blipFill>
-          <a:blip xmlns:r="http://schemas.openxmlformats.org/officeDocument/2006/relationships" xmlns:a="http://schemas.openxmlformats.org/drawingml/2006/main" r:embed="R1df61b873fcf4630"/>
+          <a:blip xmlns:r="http://schemas.openxmlformats.org/officeDocument/2006/relationships" xmlns:a="http://schemas.openxmlformats.org/drawingml/2006/main" r:embed="Rbfefb9a7013b46cb"/>
           <a:stretch xmlns:a="http://schemas.openxmlformats.org/drawingml/2006/main"/>
         </p:blipFill>
         <p:spPr>
           <a:xfrm xmlns:a="http://schemas.openxmlformats.org/drawingml/2006/main">
-            <a:off x="7419975" y="1677160"/>
-            <a:ext cx="2867025" cy="4056130"/>
+            <a:off x="7419975" y="1680490"/>
+            <a:ext cx="2867025" cy="4049470"/>
           </a:xfrm>
           <a:prstGeom xmlns:a="http://schemas.openxmlformats.org/drawingml/2006/main" prst="rect">
             <a:avLst/>
@@ -10157,6 +12419,7 @@
           </a:lstStyle>
           <a:p xmlns:a="http://schemas.openxmlformats.org/drawingml/2006/main">
             <a:pPr>
+              <a:buNone/>
               <a:defRPr sz="1725" b="1">
                 <a:solidFill>
                   <a:srgbClr val="087F77"/>
@@ -10225,6 +12488,7 @@
           </a:lstStyle>
           <a:p xmlns:a="http://schemas.openxmlformats.org/drawingml/2006/main">
             <a:pPr>
+              <a:buNone/>
               <a:defRPr sz="1725" b="1">
                 <a:solidFill>
                   <a:srgbClr val="087F77"/>

</xml_diff>

<commit_message>
feat(ensemble): fit validation weights and compare three predictions with measured reports
</commit_message>
<xml_diff>
--- a/presentation/tynys_project_10slides_kz.pptx
+++ b/presentation/tynys_project_10slides_kz.pptx
@@ -2,24 +2,24 @@
 <file path=ppt/presentation.xml><?xml version="1.0" encoding="utf-8"?>
 <p:presentation xmlns:p="http://schemas.openxmlformats.org/presentationml/2006/main">
   <p:sldMasterIdLst>
-    <p:sldMasterId xmlns:r="http://schemas.openxmlformats.org/officeDocument/2006/relationships" id="2147483648" r:id="Rf6ca39ad066a4f2e"/>
+    <p:sldMasterId xmlns:r="http://schemas.openxmlformats.org/officeDocument/2006/relationships" id="2147483648" r:id="R9b898f1b7e544db7"/>
   </p:sldMasterIdLst>
   <p:notesMasterIdLst>
-    <p:notesMasterId xmlns:r="http://schemas.openxmlformats.org/officeDocument/2006/relationships" r:id="R7296dc908b164706"/>
+    <p:notesMasterId xmlns:r="http://schemas.openxmlformats.org/officeDocument/2006/relationships" r:id="Rd69a1c60fb7449dc"/>
   </p:notesMasterIdLst>
   <p:sldIdLst>
-    <p:sldId xmlns:r="http://schemas.openxmlformats.org/officeDocument/2006/relationships" id="256" r:id="R00e62bdc6d2d430e"/>
-    <p:sldId xmlns:r="http://schemas.openxmlformats.org/officeDocument/2006/relationships" id="257" r:id="R8fb2e52f4532441d"/>
-    <p:sldId xmlns:r="http://schemas.openxmlformats.org/officeDocument/2006/relationships" id="258" r:id="R07ada17e20604cff"/>
-    <p:sldId xmlns:r="http://schemas.openxmlformats.org/officeDocument/2006/relationships" id="259" r:id="Rb0145468882841eb"/>
-    <p:sldId xmlns:r="http://schemas.openxmlformats.org/officeDocument/2006/relationships" id="260" r:id="R7d3882c1225c4a84"/>
-    <p:sldId xmlns:r="http://schemas.openxmlformats.org/officeDocument/2006/relationships" id="261" r:id="R2ed3aaad64a849cf"/>
-    <p:sldId xmlns:r="http://schemas.openxmlformats.org/officeDocument/2006/relationships" id="262" r:id="R68d10881bedf408b"/>
-    <p:sldId xmlns:r="http://schemas.openxmlformats.org/officeDocument/2006/relationships" id="263" r:id="Rad21329a70424b60"/>
-    <p:sldId xmlns:r="http://schemas.openxmlformats.org/officeDocument/2006/relationships" id="264" r:id="Rcda2d06ea15f4c22"/>
-    <p:sldId xmlns:r="http://schemas.openxmlformats.org/officeDocument/2006/relationships" id="265" r:id="R7fbb8ef651184338"/>
-    <p:sldId xmlns:r="http://schemas.openxmlformats.org/officeDocument/2006/relationships" id="266" r:id="R46d79641aa1b4ead"/>
-    <p:sldId xmlns:r="http://schemas.openxmlformats.org/officeDocument/2006/relationships" id="267" r:id="Re278e2e6f8624623"/>
+    <p:sldId xmlns:r="http://schemas.openxmlformats.org/officeDocument/2006/relationships" id="256" r:id="R1b2e5fe732ac4778"/>
+    <p:sldId xmlns:r="http://schemas.openxmlformats.org/officeDocument/2006/relationships" id="257" r:id="R65e303c2197d4c51"/>
+    <p:sldId xmlns:r="http://schemas.openxmlformats.org/officeDocument/2006/relationships" id="258" r:id="Ra1b953a122bd4916"/>
+    <p:sldId xmlns:r="http://schemas.openxmlformats.org/officeDocument/2006/relationships" id="259" r:id="R0405ac2a13b243ba"/>
+    <p:sldId xmlns:r="http://schemas.openxmlformats.org/officeDocument/2006/relationships" id="260" r:id="R813e260fc2b94faf"/>
+    <p:sldId xmlns:r="http://schemas.openxmlformats.org/officeDocument/2006/relationships" id="261" r:id="R0612909b74c149db"/>
+    <p:sldId xmlns:r="http://schemas.openxmlformats.org/officeDocument/2006/relationships" id="262" r:id="R885820e2036849e3"/>
+    <p:sldId xmlns:r="http://schemas.openxmlformats.org/officeDocument/2006/relationships" id="263" r:id="Re28ee74237f547a3"/>
+    <p:sldId xmlns:r="http://schemas.openxmlformats.org/officeDocument/2006/relationships" id="264" r:id="R4c0763f9496b4369"/>
+    <p:sldId xmlns:r="http://schemas.openxmlformats.org/officeDocument/2006/relationships" id="265" r:id="Re0371f9110534038"/>
+    <p:sldId xmlns:r="http://schemas.openxmlformats.org/officeDocument/2006/relationships" id="266" r:id="R2ebe23c8396d4045"/>
+    <p:sldId xmlns:r="http://schemas.openxmlformats.org/officeDocument/2006/relationships" id="267" r:id="Rcbe88b6a2b374663"/>
   </p:sldIdLst>
   <p:sldSz cx="12192000" cy="6858000"/>
   <p:notesSz cx="6858000" cy="9144000"/>
@@ -533,7 +533,7 @@
           <a:lstStyle xmlns:a="http://schemas.openxmlformats.org/drawingml/2006/main"/>
           <a:p xmlns:a="http://schemas.openxmlformats.org/drawingml/2006/main">
             <a:r>
-              <a:t>Калибрлеу, OOD және DICOM жұмыс істейді, 40 тест өтті. Docker конфигурациясы бар, бірақ daemon өшірулі болғандықтан контейнер тексерілмеді. Келесі кезең — ensemble, кейін multi-label жеке эксперименті.</a:t>
+              <a:t>Ensemble қосылды, 49 тест өтті. Калибрлеу мен OOD жұмыс істейді. Docker daemon өшірулі, контейнер тексерілмеді. Келесі кезең — сайттан бөлек multi-label эксперименті.</a:t>
             </a:r>
           </a:p>
           <a:p xmlns:a="http://schemas.openxmlformats.org/drawingml/2006/main">
@@ -613,7 +613,7 @@
           <a:lstStyle xmlns:a="http://schemas.openxmlformats.org/drawingml/2006/main"/>
           <a:p xmlns:a="http://schemas.openxmlformats.org/drawingml/2006/main">
             <a:r>
-              <a:t>OpenI-дің сол 200 суретін жаңа калибрленген балл және 0,745 шегімен қайта бағаладым. Accuracy 55,00%, recall 57,50%, AUC 0,5442. Таңдау мен шекті сыртқы белгілерге қарап өзгерткен жоқпын. Report UID — surrogate топ, нақты пациент ID толық расталмаған.</a:t>
+              <a:t>OpenI-дің сол 200 суретін жаңа калибрленген балл және 0,745 шегімен қайта бағаладым. Accuracy 55,00%, recall 57,50%, AUC 0,5442. Таңдау мен шекті сыртқы белгілерге қарап өзгерткен жоқпын. Report UID — surrogate топ, нақты пациент ID толық расталмаған. Сыртқы CNN accuracy 21,50%, Ensemble 55,00%. Екі модельді біріктіру осы сыртқы жиындағы мәселені шешпеді.</a:t>
             </a:r>
           </a:p>
           <a:p xmlns:a="http://schemas.openxmlformats.org/drawingml/2006/main">
@@ -1093,7 +1093,7 @@
           <a:lstStyle xmlns:a="http://schemas.openxmlformats.org/drawingml/2006/main"/>
           <a:p xmlns:a="http://schemas.openxmlformats.org/drawingml/2006/main">
             <a:r>
-              <a:t>Қазіргі калибрленген test: CNN accuracy 71,52%, MobileNetV2 89,16%. MobileNetV2 recall 96,12%, FN 15, FP 52. 90% мақсатына жетпеді. McNemar: CNN-only 19, MobileNetV2-only 128, p=4,83×10⁻²¹.</a:t>
+              <a:t>Қазіргі калибрленген test: CNN accuracy 71,52%, MobileNetV2 89,16%. MobileNetV2 recall 96,12%, FN 15, FP 52. 90% мақсатына жетпеді. McNemar: CNN-only 19, MobileNetV2-only 128, p=4,83×10⁻²¹. Ensemble accuracy 89,16%, ROC-AUC 0,9583. Accuracy өскен жоқ.</a:t>
             </a:r>
           </a:p>
           <a:p xmlns:a="http://schemas.openxmlformats.org/drawingml/2006/main">
@@ -1173,7 +1173,7 @@
           <a:lstStyle xmlns:a="http://schemas.openxmlformats.org/drawingml/2006/main"/>
           <a:p xmlns:a="http://schemas.openxmlformats.org/drawingml/2006/main">
             <a:r>
-              <a:t>Сайт бір суретке екі модельдің калибрленген баллын, санатын және өз шегін көрсетеді. JPG, PNG, CR/DX DICOM қолданылады. Бір топта 10 файлға дейін, әрқайсысы 12 МБ-қа дейін. CT/MR қабылданбайды.</a:t>
+              <a:t>Бір суретке CNN, MobileNetV2 және Ensemble санаты, баллы және өз шешім шегі көрсетіледі. Ensemble коэффициенттері тек validation NLL бойынша таңдалған: CNN шамамен 0,10%, MobileNetV2 99,90%. Сайт пен PDF осы конфигурацияны қолданады.</a:t>
             </a:r>
           </a:p>
           <a:p xmlns:a="http://schemas.openxmlformats.org/drawingml/2006/main">
@@ -3156,12 +3156,12 @@
   </p:cSld>
   <p:clrMap bg1="lt1" tx1="dk1" bg2="lt2" tx2="dk2" accent1="accent1" accent2="accent2" accent3="accent3" accent4="accent4" accent5="accent5" accent6="accent6" hlink="hlink" folHlink="folHlink"/>
   <p:sldLayoutIdLst>
-    <p:sldLayoutId xmlns:r="http://schemas.openxmlformats.org/officeDocument/2006/relationships" id="2147483649" r:id="Rc85075be2c11472a"/>
-    <p:sldLayoutId xmlns:r="http://schemas.openxmlformats.org/officeDocument/2006/relationships" id="2147483650" r:id="R5587874fa2774627"/>
-    <p:sldLayoutId xmlns:r="http://schemas.openxmlformats.org/officeDocument/2006/relationships" id="2147483651" r:id="R09ca4ece41bd4c65"/>
-    <p:sldLayoutId xmlns:r="http://schemas.openxmlformats.org/officeDocument/2006/relationships" id="2147483652" r:id="R8575af8970684e9d"/>
-    <p:sldLayoutId xmlns:r="http://schemas.openxmlformats.org/officeDocument/2006/relationships" id="2147483653" r:id="Rbd6d5d0273f141ef"/>
-    <p:sldLayoutId xmlns:r="http://schemas.openxmlformats.org/officeDocument/2006/relationships" id="2147483654" r:id="R84beafb5e8774597"/>
+    <p:sldLayoutId xmlns:r="http://schemas.openxmlformats.org/officeDocument/2006/relationships" id="2147483649" r:id="R94689dfb6a854703"/>
+    <p:sldLayoutId xmlns:r="http://schemas.openxmlformats.org/officeDocument/2006/relationships" id="2147483650" r:id="Rbcafe72e3a4347ef"/>
+    <p:sldLayoutId xmlns:r="http://schemas.openxmlformats.org/officeDocument/2006/relationships" id="2147483651" r:id="R0b07750e32f04d09"/>
+    <p:sldLayoutId xmlns:r="http://schemas.openxmlformats.org/officeDocument/2006/relationships" id="2147483652" r:id="Re6fa33d4f5134e69"/>
+    <p:sldLayoutId xmlns:r="http://schemas.openxmlformats.org/officeDocument/2006/relationships" id="2147483653" r:id="R896af372174d4139"/>
+    <p:sldLayoutId xmlns:r="http://schemas.openxmlformats.org/officeDocument/2006/relationships" id="2147483654" r:id="R980dc8e64c2441db"/>
   </p:sldLayoutIdLst>
   <p:txStyles>
     <p:titleStyle>
@@ -3781,7 +3781,7 @@
           <p:cNvPr id="2" name="">
             <a:extLst xmlns:a="http://schemas.openxmlformats.org/drawingml/2006/main">
               <a:ext uri="{FF2B5EF4-FFF2-40B4-BE49-F238E27FC236}">
-                <a16:creationId xmlns:a16="http://schemas.microsoft.com/office/drawing/2014/main" id="{1AB3641E-C9A6-406B-9F15-6250F535801F}"/>
+                <a16:creationId xmlns:a16="http://schemas.microsoft.com/office/drawing/2014/main" id="{F335674D-31DC-4AEA-B2A4-58CE6C9B23A6}"/>
               </a:ext>
             </a:extLst>
           </p:cNvPr>
@@ -3791,7 +3791,7 @@
           <p:nvPr/>
         </p:nvPicPr>
         <p:blipFill>
-          <a:blip xmlns:r="http://schemas.openxmlformats.org/officeDocument/2006/relationships" xmlns:a="http://schemas.openxmlformats.org/drawingml/2006/main" r:embed="R7dce5e7ed50b4d6c"/>
+          <a:blip xmlns:r="http://schemas.openxmlformats.org/officeDocument/2006/relationships" xmlns:a="http://schemas.openxmlformats.org/drawingml/2006/main" r:embed="Raa6e9852ec824968"/>
           <a:stretch xmlns:a="http://schemas.openxmlformats.org/drawingml/2006/main"/>
         </p:blipFill>
         <p:spPr>
@@ -4383,7 +4383,7 @@
                 <a:ea typeface="Arial"/>
                 <a:cs typeface="Arial"/>
               </a:rPr>
-              <a:t>CR / DX DICOM қолдауы</a:t>
+              <a:t>DICOM, калибрлеу және OOD</a:t>
             </a:r>
           </a:p>
           <a:p xmlns:a="http://schemas.openxmlformats.org/drawingml/2006/main">
@@ -4407,7 +4407,7 @@
                 <a:ea typeface="Arial"/>
                 <a:cs typeface="Arial"/>
               </a:rPr>
-              <a:t>Калибрлеу және OOD</a:t>
+              <a:t>CNN + MobileNetV2 + Ensemble</a:t>
             </a:r>
           </a:p>
           <a:p xmlns:a="http://schemas.openxmlformats.org/drawingml/2006/main">
@@ -4431,7 +4431,7 @@
                 <a:ea typeface="Arial"/>
                 <a:cs typeface="Arial"/>
               </a:rPr>
-              <a:t>40 тест және CI</a:t>
+              <a:t>49 тест және CI</a:t>
             </a:r>
           </a:p>
           <a:p xmlns:a="http://schemas.openxmlformats.org/drawingml/2006/main">
@@ -4455,7 +4455,7 @@
                 <a:ea typeface="Arial"/>
                 <a:cs typeface="Arial"/>
               </a:rPr>
-              <a:t>Сыртқы бағалау</a:t>
+              <a:t>Ішкі және сыртқы бағалау</a:t>
             </a:r>
           </a:p>
         </p:txBody>
@@ -4593,7 +4593,7 @@
                 <a:ea typeface="Arial"/>
                 <a:cs typeface="Arial"/>
               </a:rPr>
-              <a:t>Ensemble дайындау</a:t>
+              <a:t>Multi-label жеке тәжірибесі</a:t>
             </a:r>
           </a:p>
           <a:p xmlns:a="http://schemas.openxmlformats.org/drawingml/2006/main">
@@ -4617,7 +4617,7 @@
                 <a:ea typeface="Arial"/>
                 <a:cs typeface="Arial"/>
               </a:rPr>
-              <a:t>Multi-label жеке тәжірибесі</a:t>
+              <a:t>Сыртқы деректе сапаны өсіру</a:t>
             </a:r>
           </a:p>
           <a:p xmlns:a="http://schemas.openxmlformats.org/drawingml/2006/main">
@@ -4980,7 +4980,7 @@
           <p:cNvPr id="3" name="">
             <a:extLst xmlns:a="http://schemas.openxmlformats.org/drawingml/2006/main">
               <a:ext uri="{FF2B5EF4-FFF2-40B4-BE49-F238E27FC236}">
-                <a16:creationId xmlns:a16="http://schemas.microsoft.com/office/drawing/2014/main" id="{BD0058B4-7E87-4BBD-9361-061C11EEF629}"/>
+                <a16:creationId xmlns:a16="http://schemas.microsoft.com/office/drawing/2014/main" id="{D00DE33D-D614-4669-910D-A142556D1B4B}"/>
               </a:ext>
             </a:extLst>
           </p:cNvPr>
@@ -4989,16 +4989,17 @@
         </p:nvGraphicFramePr>
         <p:xfrm>
           <a:off xmlns:a="http://schemas.openxmlformats.org/drawingml/2006/main" x="609600" y="1714500"/>
-          <a:ext xmlns:a="http://schemas.openxmlformats.org/drawingml/2006/main" cx="10972800" cy="3622675"/>
+          <a:ext xmlns:a="http://schemas.openxmlformats.org/drawingml/2006/main" cx="10972800" cy="3105150"/>
         </p:xfrm>
         <a:graphic xmlns:a="http://schemas.openxmlformats.org/drawingml/2006/main">
           <a:graphicData uri="http://schemas.openxmlformats.org/drawingml/2006/table">
             <a:tbl>
               <a:tblPr/>
               <a:tblGrid>
-                <a:gridCol w="4305300"/>
-                <a:gridCol w="3333750"/>
-                <a:gridCol w="3333750"/>
+                <a:gridCol w="3714750"/>
+                <a:gridCol w="2419350"/>
+                <a:gridCol w="2419350"/>
+                <a:gridCol w="2419350"/>
               </a:tblGrid>
               <a:tr h="443593">
                 <a:tc>
@@ -5007,7 +5008,7 @@
                     <a:lstStyle/>
                     <a:p>
                       <a:r>
-                        <a:rPr sz="1725" b="1">
+                        <a:rPr sz="1575" b="1">
                           <a:solidFill>
                             <a:srgbClr val="FFFFFF"/>
                           </a:solidFill>
@@ -5055,7 +5056,7 @@
                     <a:lstStyle/>
                     <a:p>
                       <a:r>
-                        <a:rPr sz="1725" b="1">
+                        <a:rPr sz="1575" b="1">
                           <a:solidFill>
                             <a:srgbClr val="FFFFFF"/>
                           </a:solidFill>
@@ -5063,7 +5064,7 @@
                           <a:ea typeface="Arial"/>
                           <a:cs typeface="Arial"/>
                         </a:rPr>
-                        <a:t>Ішкі test, 618</a:t>
+                        <a:t>CNN</a:t>
                       </a:r>
                     </a:p>
                   </a:txBody>
@@ -5097,7 +5098,7 @@
                     <a:lstStyle/>
                     <a:p>
                       <a:r>
-                        <a:rPr sz="1725" b="1">
+                        <a:rPr sz="1575" b="1">
                           <a:solidFill>
                             <a:srgbClr val="FFFFFF"/>
                           </a:solidFill>
@@ -5105,7 +5106,49 @@
                           <a:ea typeface="Arial"/>
                           <a:cs typeface="Arial"/>
                         </a:rPr>
-                        <a:t>OpenI, 200</a:t>
+                        <a:t>MobileNetV2</a:t>
+                      </a:r>
+                    </a:p>
+                  </a:txBody>
+                  <a:tcPr marL="91440" marR="91440" marT="45720" marB="45720">
+                    <a:lnR w="9525">
+                      <a:solidFill>
+                        <a:srgbClr val="CBDDD6"/>
+                      </a:solidFill>
+                      <a:prstDash val="solid"/>
+                    </a:lnR>
+                    <a:lnT w="9525">
+                      <a:solidFill>
+                        <a:srgbClr val="CBDDD6"/>
+                      </a:solidFill>
+                      <a:prstDash val="solid"/>
+                    </a:lnT>
+                    <a:lnB w="9525">
+                      <a:solidFill>
+                        <a:srgbClr val="CBDDD6"/>
+                      </a:solidFill>
+                      <a:prstDash val="solid"/>
+                    </a:lnB>
+                    <a:solidFill>
+                      <a:srgbClr val="193E3A"/>
+                    </a:solidFill>
+                  </a:tcPr>
+                </a:tc>
+                <a:tc>
+                  <a:txBody>
+                    <a:bodyPr/>
+                    <a:lstStyle/>
+                    <a:p>
+                      <a:r>
+                        <a:rPr sz="1575" b="1">
+                          <a:solidFill>
+                            <a:srgbClr val="FFFFFF"/>
+                          </a:solidFill>
+                          <a:latin typeface="Arial"/>
+                          <a:ea typeface="Arial"/>
+                          <a:cs typeface="Arial"/>
+                        </a:rPr>
+                        <a:t>Ensemble</a:t>
                       </a:r>
                     </a:p>
                   </a:txBody>
@@ -5141,7 +5184,7 @@
                     <a:lstStyle/>
                     <a:p>
                       <a:r>
-                        <a:rPr sz="1725" b="0">
+                        <a:rPr sz="1575" b="0">
                           <a:solidFill>
                             <a:srgbClr val="193E3A"/>
                           </a:solidFill>
@@ -5183,7 +5226,7 @@
                     <a:lstStyle/>
                     <a:p>
                       <a:r>
-                        <a:rPr sz="1725" b="0">
+                        <a:rPr sz="1575" b="0">
                           <a:solidFill>
                             <a:srgbClr val="193E3A"/>
                           </a:solidFill>
@@ -5191,7 +5234,7 @@
                           <a:ea typeface="Arial"/>
                           <a:cs typeface="Arial"/>
                         </a:rPr>
-                        <a:t>89,16%</a:t>
+                        <a:t>21,50%</a:t>
                       </a:r>
                     </a:p>
                   </a:txBody>
@@ -5219,7 +5262,43 @@
                     <a:lstStyle/>
                     <a:p>
                       <a:r>
-                        <a:rPr sz="1725" b="0">
+                        <a:rPr sz="1575" b="0">
+                          <a:solidFill>
+                            <a:srgbClr val="193E3A"/>
+                          </a:solidFill>
+                          <a:latin typeface="Arial"/>
+                          <a:ea typeface="Arial"/>
+                          <a:cs typeface="Arial"/>
+                        </a:rPr>
+                        <a:t>55,00%</a:t>
+                      </a:r>
+                    </a:p>
+                  </a:txBody>
+                  <a:tcPr marL="91440" marR="91440" marT="45720" marB="45720">
+                    <a:lnR w="9525">
+                      <a:solidFill>
+                        <a:srgbClr val="CBDDD6"/>
+                      </a:solidFill>
+                      <a:prstDash val="solid"/>
+                    </a:lnR>
+                    <a:lnB w="9525">
+                      <a:solidFill>
+                        <a:srgbClr val="CBDDD6"/>
+                      </a:solidFill>
+                      <a:prstDash val="solid"/>
+                    </a:lnB>
+                    <a:solidFill>
+                      <a:srgbClr val="FFFFFF"/>
+                    </a:solidFill>
+                  </a:tcPr>
+                </a:tc>
+                <a:tc>
+                  <a:txBody>
+                    <a:bodyPr/>
+                    <a:lstStyle/>
+                    <a:p>
+                      <a:r>
+                        <a:rPr sz="1575" b="0">
                           <a:solidFill>
                             <a:srgbClr val="193E3A"/>
                           </a:solidFill>
@@ -5257,7 +5336,7 @@
                     <a:lstStyle/>
                     <a:p>
                       <a:r>
-                        <a:rPr sz="1725" b="0">
+                        <a:rPr sz="1575" b="0">
                           <a:solidFill>
                             <a:srgbClr val="193E3A"/>
                           </a:solidFill>
@@ -5299,7 +5378,7 @@
                     <a:lstStyle/>
                     <a:p>
                       <a:r>
-                        <a:rPr sz="1725" b="0">
+                        <a:rPr sz="1575" b="0">
                           <a:solidFill>
                             <a:srgbClr val="193E3A"/>
                           </a:solidFill>
@@ -5307,7 +5386,7 @@
                           <a:ea typeface="Arial"/>
                           <a:cs typeface="Arial"/>
                         </a:rPr>
-                        <a:t>87,74%</a:t>
+                        <a:t>20,30%</a:t>
                       </a:r>
                     </a:p>
                   </a:txBody>
@@ -5335,7 +5414,43 @@
                     <a:lstStyle/>
                     <a:p>
                       <a:r>
-                        <a:rPr sz="1725" b="0">
+                        <a:rPr sz="1575" b="0">
+                          <a:solidFill>
+                            <a:srgbClr val="193E3A"/>
+                          </a:solidFill>
+                          <a:latin typeface="Arial"/>
+                          <a:ea typeface="Arial"/>
+                          <a:cs typeface="Arial"/>
+                        </a:rPr>
+                        <a:t>23,96%</a:t>
+                      </a:r>
+                    </a:p>
+                  </a:txBody>
+                  <a:tcPr marL="91440" marR="91440" marT="45720" marB="45720">
+                    <a:lnR w="9525">
+                      <a:solidFill>
+                        <a:srgbClr val="CBDDD6"/>
+                      </a:solidFill>
+                      <a:prstDash val="solid"/>
+                    </a:lnR>
+                    <a:lnB w="9525">
+                      <a:solidFill>
+                        <a:srgbClr val="CBDDD6"/>
+                      </a:solidFill>
+                      <a:prstDash val="solid"/>
+                    </a:lnB>
+                    <a:solidFill>
+                      <a:srgbClr val="E9F3EE"/>
+                    </a:solidFill>
+                  </a:tcPr>
+                </a:tc>
+                <a:tc>
+                  <a:txBody>
+                    <a:bodyPr/>
+                    <a:lstStyle/>
+                    <a:p>
+                      <a:r>
+                        <a:rPr sz="1575" b="0">
                           <a:solidFill>
                             <a:srgbClr val="193E3A"/>
                           </a:solidFill>
@@ -5373,7 +5488,7 @@
                     <a:lstStyle/>
                     <a:p>
                       <a:r>
-                        <a:rPr sz="1725" b="0">
+                        <a:rPr sz="1575" b="0">
                           <a:solidFill>
                             <a:srgbClr val="193E3A"/>
                           </a:solidFill>
@@ -5415,7 +5530,7 @@
                     <a:lstStyle/>
                     <a:p>
                       <a:r>
-                        <a:rPr sz="1725" b="0">
+                        <a:rPr sz="1575" b="0">
                           <a:solidFill>
                             <a:srgbClr val="193E3A"/>
                           </a:solidFill>
@@ -5423,7 +5538,7 @@
                           <a:ea typeface="Arial"/>
                           <a:cs typeface="Arial"/>
                         </a:rPr>
-                        <a:t>96,12%</a:t>
+                        <a:t>100,00%</a:t>
                       </a:r>
                     </a:p>
                   </a:txBody>
@@ -5451,7 +5566,43 @@
                     <a:lstStyle/>
                     <a:p>
                       <a:r>
-                        <a:rPr sz="1725" b="0">
+                        <a:rPr sz="1575" b="0">
+                          <a:solidFill>
+                            <a:srgbClr val="193E3A"/>
+                          </a:solidFill>
+                          <a:latin typeface="Arial"/>
+                          <a:ea typeface="Arial"/>
+                          <a:cs typeface="Arial"/>
+                        </a:rPr>
+                        <a:t>57,50%</a:t>
+                      </a:r>
+                    </a:p>
+                  </a:txBody>
+                  <a:tcPr marL="91440" marR="91440" marT="45720" marB="45720">
+                    <a:lnR w="9525">
+                      <a:solidFill>
+                        <a:srgbClr val="CBDDD6"/>
+                      </a:solidFill>
+                      <a:prstDash val="solid"/>
+                    </a:lnR>
+                    <a:lnB w="9525">
+                      <a:solidFill>
+                        <a:srgbClr val="CBDDD6"/>
+                      </a:solidFill>
+                      <a:prstDash val="solid"/>
+                    </a:lnB>
+                    <a:solidFill>
+                      <a:srgbClr val="FFFFFF"/>
+                    </a:solidFill>
+                  </a:tcPr>
+                </a:tc>
+                <a:tc>
+                  <a:txBody>
+                    <a:bodyPr/>
+                    <a:lstStyle/>
+                    <a:p>
+                      <a:r>
+                        <a:rPr sz="1575" b="0">
                           <a:solidFill>
                             <a:srgbClr val="193E3A"/>
                           </a:solidFill>
@@ -5489,7 +5640,7 @@
                     <a:lstStyle/>
                     <a:p>
                       <a:r>
-                        <a:rPr sz="1725" b="0">
+                        <a:rPr sz="1575" b="0">
                           <a:solidFill>
                             <a:srgbClr val="193E3A"/>
                           </a:solidFill>
@@ -5531,7 +5682,7 @@
                     <a:lstStyle/>
                     <a:p>
                       <a:r>
-                        <a:rPr sz="1725" b="0">
+                        <a:rPr sz="1575" b="0">
                           <a:solidFill>
                             <a:srgbClr val="193E3A"/>
                           </a:solidFill>
@@ -5539,7 +5690,7 @@
                           <a:ea typeface="Arial"/>
                           <a:cs typeface="Arial"/>
                         </a:rPr>
-                        <a:t>77,49%</a:t>
+                        <a:t>1,88%</a:t>
                       </a:r>
                     </a:p>
                   </a:txBody>
@@ -5567,7 +5718,43 @@
                     <a:lstStyle/>
                     <a:p>
                       <a:r>
-                        <a:rPr sz="1725" b="0">
+                        <a:rPr sz="1575" b="0">
+                          <a:solidFill>
+                            <a:srgbClr val="193E3A"/>
+                          </a:solidFill>
+                          <a:latin typeface="Arial"/>
+                          <a:ea typeface="Arial"/>
+                          <a:cs typeface="Arial"/>
+                        </a:rPr>
+                        <a:t>54,37%</a:t>
+                      </a:r>
+                    </a:p>
+                  </a:txBody>
+                  <a:tcPr marL="91440" marR="91440" marT="45720" marB="45720">
+                    <a:lnR w="9525">
+                      <a:solidFill>
+                        <a:srgbClr val="CBDDD6"/>
+                      </a:solidFill>
+                      <a:prstDash val="solid"/>
+                    </a:lnR>
+                    <a:lnB w="9525">
+                      <a:solidFill>
+                        <a:srgbClr val="CBDDD6"/>
+                      </a:solidFill>
+                      <a:prstDash val="solid"/>
+                    </a:lnB>
+                    <a:solidFill>
+                      <a:srgbClr val="E9F3EE"/>
+                    </a:solidFill>
+                  </a:tcPr>
+                </a:tc>
+                <a:tc>
+                  <a:txBody>
+                    <a:bodyPr/>
+                    <a:lstStyle/>
+                    <a:p>
+                      <a:r>
+                        <a:rPr sz="1575" b="0">
                           <a:solidFill>
                             <a:srgbClr val="193E3A"/>
                           </a:solidFill>
@@ -5605,7 +5792,7 @@
                     <a:lstStyle/>
                     <a:p>
                       <a:r>
-                        <a:rPr sz="1725" b="0">
+                        <a:rPr sz="1575" b="0">
                           <a:solidFill>
                             <a:srgbClr val="193E3A"/>
                           </a:solidFill>
@@ -5647,7 +5834,7 @@
                     <a:lstStyle/>
                     <a:p>
                       <a:r>
-                        <a:rPr sz="1725" b="0">
+                        <a:rPr sz="1575" b="0">
                           <a:solidFill>
                             <a:srgbClr val="193E3A"/>
                           </a:solidFill>
@@ -5655,7 +5842,7 @@
                           <a:ea typeface="Arial"/>
                           <a:cs typeface="Arial"/>
                         </a:rPr>
-                        <a:t>0,9174</a:t>
+                        <a:t>0,3376</a:t>
                       </a:r>
                     </a:p>
                   </a:txBody>
@@ -5683,7 +5870,43 @@
                     <a:lstStyle/>
                     <a:p>
                       <a:r>
-                        <a:rPr sz="1725" b="0">
+                        <a:rPr sz="1575" b="0">
+                          <a:solidFill>
+                            <a:srgbClr val="193E3A"/>
+                          </a:solidFill>
+                          <a:latin typeface="Arial"/>
+                          <a:ea typeface="Arial"/>
+                          <a:cs typeface="Arial"/>
+                        </a:rPr>
+                        <a:t>0,3382</a:t>
+                      </a:r>
+                    </a:p>
+                  </a:txBody>
+                  <a:tcPr marL="91440" marR="91440" marT="45720" marB="45720">
+                    <a:lnR w="9525">
+                      <a:solidFill>
+                        <a:srgbClr val="CBDDD6"/>
+                      </a:solidFill>
+                      <a:prstDash val="solid"/>
+                    </a:lnR>
+                    <a:lnB w="9525">
+                      <a:solidFill>
+                        <a:srgbClr val="CBDDD6"/>
+                      </a:solidFill>
+                      <a:prstDash val="solid"/>
+                    </a:lnB>
+                    <a:solidFill>
+                      <a:srgbClr val="FFFFFF"/>
+                    </a:solidFill>
+                  </a:tcPr>
+                </a:tc>
+                <a:tc>
+                  <a:txBody>
+                    <a:bodyPr/>
+                    <a:lstStyle/>
+                    <a:p>
+                      <a:r>
+                        <a:rPr sz="1575" b="0">
                           <a:solidFill>
                             <a:srgbClr val="193E3A"/>
                           </a:solidFill>
@@ -5721,7 +5944,7 @@
                     <a:lstStyle/>
                     <a:p>
                       <a:r>
-                        <a:rPr sz="1725" b="0">
+                        <a:rPr sz="1575" b="0">
                           <a:solidFill>
                             <a:srgbClr val="193E3A"/>
                           </a:solidFill>
@@ -5763,7 +5986,7 @@
                     <a:lstStyle/>
                     <a:p>
                       <a:r>
-                        <a:rPr sz="1725" b="0">
+                        <a:rPr sz="1575" b="0">
                           <a:solidFill>
                             <a:srgbClr val="193E3A"/>
                           </a:solidFill>
@@ -5771,7 +5994,7 @@
                           <a:ea typeface="Arial"/>
                           <a:cs typeface="Arial"/>
                         </a:rPr>
-                        <a:t>0,9581</a:t>
+                        <a:t>0,4706</a:t>
                       </a:r>
                     </a:p>
                   </a:txBody>
@@ -5799,7 +6022,7 @@
                     <a:lstStyle/>
                     <a:p>
                       <a:r>
-                        <a:rPr sz="1725" b="0">
+                        <a:rPr sz="1575" b="0">
                           <a:solidFill>
                             <a:srgbClr val="193E3A"/>
                           </a:solidFill>
@@ -5808,6 +6031,42 @@
                           <a:cs typeface="Arial"/>
                         </a:rPr>
                         <a:t>0,5442</a:t>
+                      </a:r>
+                    </a:p>
+                  </a:txBody>
+                  <a:tcPr marL="91440" marR="91440" marT="45720" marB="45720">
+                    <a:lnR w="9525">
+                      <a:solidFill>
+                        <a:srgbClr val="CBDDD6"/>
+                      </a:solidFill>
+                      <a:prstDash val="solid"/>
+                    </a:lnR>
+                    <a:lnB w="9525">
+                      <a:solidFill>
+                        <a:srgbClr val="CBDDD6"/>
+                      </a:solidFill>
+                      <a:prstDash val="solid"/>
+                    </a:lnB>
+                    <a:solidFill>
+                      <a:srgbClr val="E9F3EE"/>
+                    </a:solidFill>
+                  </a:tcPr>
+                </a:tc>
+                <a:tc>
+                  <a:txBody>
+                    <a:bodyPr/>
+                    <a:lstStyle/>
+                    <a:p>
+                      <a:r>
+                        <a:rPr sz="1575" b="0">
+                          <a:solidFill>
+                            <a:srgbClr val="193E3A"/>
+                          </a:solidFill>
+                          <a:latin typeface="Arial"/>
+                          <a:ea typeface="Arial"/>
+                          <a:cs typeface="Arial"/>
+                        </a:rPr>
+                        <a:t>0,5441</a:t>
                       </a:r>
                     </a:p>
                   </a:txBody>
@@ -6713,7 +6972,7 @@
                 <a:ea typeface="Arial"/>
                 <a:cs typeface="Arial"/>
               </a:rPr>
-              <a:t>Оқу прототипі. Клиникалық қолдануға бөлек тексеру қажет.</a:t>
+              <a:t>Ensemble: CNN 0,10% + MobileNetV2 99,90%</a:t>
             </a:r>
           </a:p>
         </p:txBody>
@@ -8469,7 +8728,7 @@
           <p:cNvPr id="3" name="">
             <a:extLst xmlns:a="http://schemas.openxmlformats.org/drawingml/2006/main">
               <a:ext uri="{FF2B5EF4-FFF2-40B4-BE49-F238E27FC236}">
-                <a16:creationId xmlns:a16="http://schemas.microsoft.com/office/drawing/2014/main" id="{DE1B3F6E-5B57-4F7A-9910-122E455ED9E1}"/>
+                <a16:creationId xmlns:a16="http://schemas.microsoft.com/office/drawing/2014/main" id="{97CE959E-5972-4F08-97B7-AA35FED2B336}"/>
               </a:ext>
             </a:extLst>
           </p:cNvPr>
@@ -10004,7 +10263,7 @@
           <p:cNvPr id="3" name="">
             <a:extLst xmlns:a="http://schemas.openxmlformats.org/drawingml/2006/main">
               <a:ext uri="{FF2B5EF4-FFF2-40B4-BE49-F238E27FC236}">
-                <a16:creationId xmlns:a16="http://schemas.microsoft.com/office/drawing/2014/main" id="{76AC81A9-2618-4EE1-B190-E6C7A47CF7CF}"/>
+                <a16:creationId xmlns:a16="http://schemas.microsoft.com/office/drawing/2014/main" id="{43BCF6B9-B082-4D99-B3F2-A8E255513F0C}"/>
               </a:ext>
             </a:extLst>
           </p:cNvPr>
@@ -10013,16 +10272,17 @@
         </p:nvGraphicFramePr>
         <p:xfrm>
           <a:off xmlns:a="http://schemas.openxmlformats.org/drawingml/2006/main" x="609600" y="1714500"/>
-          <a:ext xmlns:a="http://schemas.openxmlformats.org/drawingml/2006/main" cx="10972800" cy="3622675"/>
+          <a:ext xmlns:a="http://schemas.openxmlformats.org/drawingml/2006/main" cx="10972800" cy="3105150"/>
         </p:xfrm>
         <a:graphic xmlns:a="http://schemas.openxmlformats.org/drawingml/2006/main">
           <a:graphicData uri="http://schemas.openxmlformats.org/drawingml/2006/table">
             <a:tbl>
               <a:tblPr/>
               <a:tblGrid>
-                <a:gridCol w="4305300"/>
-                <a:gridCol w="3333750"/>
-                <a:gridCol w="3333750"/>
+                <a:gridCol w="3714750"/>
+                <a:gridCol w="2419350"/>
+                <a:gridCol w="2419350"/>
+                <a:gridCol w="2419350"/>
               </a:tblGrid>
               <a:tr h="443593">
                 <a:tc>
@@ -10031,7 +10291,7 @@
                     <a:lstStyle/>
                     <a:p>
                       <a:r>
-                        <a:rPr sz="1725" b="1">
+                        <a:rPr sz="1575" b="1">
                           <a:solidFill>
                             <a:srgbClr val="FFFFFF"/>
                           </a:solidFill>
@@ -10079,7 +10339,7 @@
                     <a:lstStyle/>
                     <a:p>
                       <a:r>
-                        <a:rPr sz="1725" b="1">
+                        <a:rPr sz="1575" b="1">
                           <a:solidFill>
                             <a:srgbClr val="FFFFFF"/>
                           </a:solidFill>
@@ -10121,7 +10381,7 @@
                     <a:lstStyle/>
                     <a:p>
                       <a:r>
-                        <a:rPr sz="1725" b="1">
+                        <a:rPr sz="1575" b="1">
                           <a:solidFill>
                             <a:srgbClr val="FFFFFF"/>
                           </a:solidFill>
@@ -10130,6 +10390,48 @@
                           <a:cs typeface="Arial"/>
                         </a:rPr>
                         <a:t>MobileNetV2</a:t>
+                      </a:r>
+                    </a:p>
+                  </a:txBody>
+                  <a:tcPr marL="91440" marR="91440" marT="45720" marB="45720">
+                    <a:lnR w="9525">
+                      <a:solidFill>
+                        <a:srgbClr val="CBDDD6"/>
+                      </a:solidFill>
+                      <a:prstDash val="solid"/>
+                    </a:lnR>
+                    <a:lnT w="9525">
+                      <a:solidFill>
+                        <a:srgbClr val="CBDDD6"/>
+                      </a:solidFill>
+                      <a:prstDash val="solid"/>
+                    </a:lnT>
+                    <a:lnB w="9525">
+                      <a:solidFill>
+                        <a:srgbClr val="CBDDD6"/>
+                      </a:solidFill>
+                      <a:prstDash val="solid"/>
+                    </a:lnB>
+                    <a:solidFill>
+                      <a:srgbClr val="193E3A"/>
+                    </a:solidFill>
+                  </a:tcPr>
+                </a:tc>
+                <a:tc>
+                  <a:txBody>
+                    <a:bodyPr/>
+                    <a:lstStyle/>
+                    <a:p>
+                      <a:r>
+                        <a:rPr sz="1575" b="1">
+                          <a:solidFill>
+                            <a:srgbClr val="FFFFFF"/>
+                          </a:solidFill>
+                          <a:latin typeface="Arial"/>
+                          <a:ea typeface="Arial"/>
+                          <a:cs typeface="Arial"/>
+                        </a:rPr>
+                        <a:t>Ensemble</a:t>
                       </a:r>
                     </a:p>
                   </a:txBody>
@@ -10165,7 +10467,7 @@
                     <a:lstStyle/>
                     <a:p>
                       <a:r>
-                        <a:rPr sz="1725" b="0">
+                        <a:rPr sz="1575" b="0">
                           <a:solidFill>
                             <a:srgbClr val="193E3A"/>
                           </a:solidFill>
@@ -10207,7 +10509,7 @@
                     <a:lstStyle/>
                     <a:p>
                       <a:r>
-                        <a:rPr sz="1725" b="0">
+                        <a:rPr sz="1575" b="0">
                           <a:solidFill>
                             <a:srgbClr val="193E3A"/>
                           </a:solidFill>
@@ -10243,7 +10545,43 @@
                     <a:lstStyle/>
                     <a:p>
                       <a:r>
-                        <a:rPr sz="1725" b="0">
+                        <a:rPr sz="1575" b="0">
+                          <a:solidFill>
+                            <a:srgbClr val="193E3A"/>
+                          </a:solidFill>
+                          <a:latin typeface="Arial"/>
+                          <a:ea typeface="Arial"/>
+                          <a:cs typeface="Arial"/>
+                        </a:rPr>
+                        <a:t>89,16%</a:t>
+                      </a:r>
+                    </a:p>
+                  </a:txBody>
+                  <a:tcPr marL="91440" marR="91440" marT="45720" marB="45720">
+                    <a:lnR w="9525">
+                      <a:solidFill>
+                        <a:srgbClr val="CBDDD6"/>
+                      </a:solidFill>
+                      <a:prstDash val="solid"/>
+                    </a:lnR>
+                    <a:lnB w="9525">
+                      <a:solidFill>
+                        <a:srgbClr val="CBDDD6"/>
+                      </a:solidFill>
+                      <a:prstDash val="solid"/>
+                    </a:lnB>
+                    <a:solidFill>
+                      <a:srgbClr val="FFFFFF"/>
+                    </a:solidFill>
+                  </a:tcPr>
+                </a:tc>
+                <a:tc>
+                  <a:txBody>
+                    <a:bodyPr/>
+                    <a:lstStyle/>
+                    <a:p>
+                      <a:r>
+                        <a:rPr sz="1575" b="0">
                           <a:solidFill>
                             <a:srgbClr val="193E3A"/>
                           </a:solidFill>
@@ -10281,7 +10619,7 @@
                     <a:lstStyle/>
                     <a:p>
                       <a:r>
-                        <a:rPr sz="1725" b="0">
+                        <a:rPr sz="1575" b="0">
                           <a:solidFill>
                             <a:srgbClr val="193E3A"/>
                           </a:solidFill>
@@ -10323,7 +10661,7 @@
                     <a:lstStyle/>
                     <a:p>
                       <a:r>
-                        <a:rPr sz="1725" b="0">
+                        <a:rPr sz="1575" b="0">
                           <a:solidFill>
                             <a:srgbClr val="193E3A"/>
                           </a:solidFill>
@@ -10359,7 +10697,43 @@
                     <a:lstStyle/>
                     <a:p>
                       <a:r>
-                        <a:rPr sz="1725" b="0">
+                        <a:rPr sz="1575" b="0">
+                          <a:solidFill>
+                            <a:srgbClr val="193E3A"/>
+                          </a:solidFill>
+                          <a:latin typeface="Arial"/>
+                          <a:ea typeface="Arial"/>
+                          <a:cs typeface="Arial"/>
+                        </a:rPr>
+                        <a:t>87,74%</a:t>
+                      </a:r>
+                    </a:p>
+                  </a:txBody>
+                  <a:tcPr marL="91440" marR="91440" marT="45720" marB="45720">
+                    <a:lnR w="9525">
+                      <a:solidFill>
+                        <a:srgbClr val="CBDDD6"/>
+                      </a:solidFill>
+                      <a:prstDash val="solid"/>
+                    </a:lnR>
+                    <a:lnB w="9525">
+                      <a:solidFill>
+                        <a:srgbClr val="CBDDD6"/>
+                      </a:solidFill>
+                      <a:prstDash val="solid"/>
+                    </a:lnB>
+                    <a:solidFill>
+                      <a:srgbClr val="E9F3EE"/>
+                    </a:solidFill>
+                  </a:tcPr>
+                </a:tc>
+                <a:tc>
+                  <a:txBody>
+                    <a:bodyPr/>
+                    <a:lstStyle/>
+                    <a:p>
+                      <a:r>
+                        <a:rPr sz="1575" b="0">
                           <a:solidFill>
                             <a:srgbClr val="193E3A"/>
                           </a:solidFill>
@@ -10397,7 +10771,7 @@
                     <a:lstStyle/>
                     <a:p>
                       <a:r>
-                        <a:rPr sz="1725" b="0">
+                        <a:rPr sz="1575" b="0">
                           <a:solidFill>
                             <a:srgbClr val="193E3A"/>
                           </a:solidFill>
@@ -10439,7 +10813,7 @@
                     <a:lstStyle/>
                     <a:p>
                       <a:r>
-                        <a:rPr sz="1725" b="0">
+                        <a:rPr sz="1575" b="0">
                           <a:solidFill>
                             <a:srgbClr val="193E3A"/>
                           </a:solidFill>
@@ -10475,7 +10849,43 @@
                     <a:lstStyle/>
                     <a:p>
                       <a:r>
-                        <a:rPr sz="1725" b="0">
+                        <a:rPr sz="1575" b="0">
+                          <a:solidFill>
+                            <a:srgbClr val="193E3A"/>
+                          </a:solidFill>
+                          <a:latin typeface="Arial"/>
+                          <a:ea typeface="Arial"/>
+                          <a:cs typeface="Arial"/>
+                        </a:rPr>
+                        <a:t>96,12%</a:t>
+                      </a:r>
+                    </a:p>
+                  </a:txBody>
+                  <a:tcPr marL="91440" marR="91440" marT="45720" marB="45720">
+                    <a:lnR w="9525">
+                      <a:solidFill>
+                        <a:srgbClr val="CBDDD6"/>
+                      </a:solidFill>
+                      <a:prstDash val="solid"/>
+                    </a:lnR>
+                    <a:lnB w="9525">
+                      <a:solidFill>
+                        <a:srgbClr val="CBDDD6"/>
+                      </a:solidFill>
+                      <a:prstDash val="solid"/>
+                    </a:lnB>
+                    <a:solidFill>
+                      <a:srgbClr val="FFFFFF"/>
+                    </a:solidFill>
+                  </a:tcPr>
+                </a:tc>
+                <a:tc>
+                  <a:txBody>
+                    <a:bodyPr/>
+                    <a:lstStyle/>
+                    <a:p>
+                      <a:r>
+                        <a:rPr sz="1575" b="0">
                           <a:solidFill>
                             <a:srgbClr val="193E3A"/>
                           </a:solidFill>
@@ -10513,7 +10923,7 @@
                     <a:lstStyle/>
                     <a:p>
                       <a:r>
-                        <a:rPr sz="1725" b="0">
+                        <a:rPr sz="1575" b="0">
                           <a:solidFill>
                             <a:srgbClr val="193E3A"/>
                           </a:solidFill>
@@ -10555,7 +10965,7 @@
                     <a:lstStyle/>
                     <a:p>
                       <a:r>
-                        <a:rPr sz="1725" b="0">
+                        <a:rPr sz="1575" b="0">
                           <a:solidFill>
                             <a:srgbClr val="193E3A"/>
                           </a:solidFill>
@@ -10591,7 +11001,43 @@
                     <a:lstStyle/>
                     <a:p>
                       <a:r>
-                        <a:rPr sz="1725" b="0">
+                        <a:rPr sz="1575" b="0">
+                          <a:solidFill>
+                            <a:srgbClr val="193E3A"/>
+                          </a:solidFill>
+                          <a:latin typeface="Arial"/>
+                          <a:ea typeface="Arial"/>
+                          <a:cs typeface="Arial"/>
+                        </a:rPr>
+                        <a:t>77,49%</a:t>
+                      </a:r>
+                    </a:p>
+                  </a:txBody>
+                  <a:tcPr marL="91440" marR="91440" marT="45720" marB="45720">
+                    <a:lnR w="9525">
+                      <a:solidFill>
+                        <a:srgbClr val="CBDDD6"/>
+                      </a:solidFill>
+                      <a:prstDash val="solid"/>
+                    </a:lnR>
+                    <a:lnB w="9525">
+                      <a:solidFill>
+                        <a:srgbClr val="CBDDD6"/>
+                      </a:solidFill>
+                      <a:prstDash val="solid"/>
+                    </a:lnB>
+                    <a:solidFill>
+                      <a:srgbClr val="E9F3EE"/>
+                    </a:solidFill>
+                  </a:tcPr>
+                </a:tc>
+                <a:tc>
+                  <a:txBody>
+                    <a:bodyPr/>
+                    <a:lstStyle/>
+                    <a:p>
+                      <a:r>
+                        <a:rPr sz="1575" b="0">
                           <a:solidFill>
                             <a:srgbClr val="193E3A"/>
                           </a:solidFill>
@@ -10629,7 +11075,7 @@
                     <a:lstStyle/>
                     <a:p>
                       <a:r>
-                        <a:rPr sz="1725" b="0">
+                        <a:rPr sz="1575" b="0">
                           <a:solidFill>
                             <a:srgbClr val="193E3A"/>
                           </a:solidFill>
@@ -10671,7 +11117,7 @@
                     <a:lstStyle/>
                     <a:p>
                       <a:r>
-                        <a:rPr sz="1725" b="0">
+                        <a:rPr sz="1575" b="0">
                           <a:solidFill>
                             <a:srgbClr val="193E3A"/>
                           </a:solidFill>
@@ -10707,7 +11153,43 @@
                     <a:lstStyle/>
                     <a:p>
                       <a:r>
-                        <a:rPr sz="1725" b="0">
+                        <a:rPr sz="1575" b="0">
+                          <a:solidFill>
+                            <a:srgbClr val="193E3A"/>
+                          </a:solidFill>
+                          <a:latin typeface="Arial"/>
+                          <a:ea typeface="Arial"/>
+                          <a:cs typeface="Arial"/>
+                        </a:rPr>
+                        <a:t>0,9174</a:t>
+                      </a:r>
+                    </a:p>
+                  </a:txBody>
+                  <a:tcPr marL="91440" marR="91440" marT="45720" marB="45720">
+                    <a:lnR w="9525">
+                      <a:solidFill>
+                        <a:srgbClr val="CBDDD6"/>
+                      </a:solidFill>
+                      <a:prstDash val="solid"/>
+                    </a:lnR>
+                    <a:lnB w="9525">
+                      <a:solidFill>
+                        <a:srgbClr val="CBDDD6"/>
+                      </a:solidFill>
+                      <a:prstDash val="solid"/>
+                    </a:lnB>
+                    <a:solidFill>
+                      <a:srgbClr val="FFFFFF"/>
+                    </a:solidFill>
+                  </a:tcPr>
+                </a:tc>
+                <a:tc>
+                  <a:txBody>
+                    <a:bodyPr/>
+                    <a:lstStyle/>
+                    <a:p>
+                      <a:r>
+                        <a:rPr sz="1575" b="0">
                           <a:solidFill>
                             <a:srgbClr val="193E3A"/>
                           </a:solidFill>
@@ -10745,7 +11227,7 @@
                     <a:lstStyle/>
                     <a:p>
                       <a:r>
-                        <a:rPr sz="1725" b="0">
+                        <a:rPr sz="1575" b="0">
                           <a:solidFill>
                             <a:srgbClr val="193E3A"/>
                           </a:solidFill>
@@ -10787,7 +11269,7 @@
                     <a:lstStyle/>
                     <a:p>
                       <a:r>
-                        <a:rPr sz="1725" b="0">
+                        <a:rPr sz="1575" b="0">
                           <a:solidFill>
                             <a:srgbClr val="193E3A"/>
                           </a:solidFill>
@@ -10823,7 +11305,7 @@
                     <a:lstStyle/>
                     <a:p>
                       <a:r>
-                        <a:rPr sz="1725" b="0">
+                        <a:rPr sz="1575" b="0">
                           <a:solidFill>
                             <a:srgbClr val="193E3A"/>
                           </a:solidFill>
@@ -10832,6 +11314,42 @@
                           <a:cs typeface="Arial"/>
                         </a:rPr>
                         <a:t>0,9581</a:t>
+                      </a:r>
+                    </a:p>
+                  </a:txBody>
+                  <a:tcPr marL="91440" marR="91440" marT="45720" marB="45720">
+                    <a:lnR w="9525">
+                      <a:solidFill>
+                        <a:srgbClr val="CBDDD6"/>
+                      </a:solidFill>
+                      <a:prstDash val="solid"/>
+                    </a:lnR>
+                    <a:lnB w="9525">
+                      <a:solidFill>
+                        <a:srgbClr val="CBDDD6"/>
+                      </a:solidFill>
+                      <a:prstDash val="solid"/>
+                    </a:lnB>
+                    <a:solidFill>
+                      <a:srgbClr val="E9F3EE"/>
+                    </a:solidFill>
+                  </a:tcPr>
+                </a:tc>
+                <a:tc>
+                  <a:txBody>
+                    <a:bodyPr/>
+                    <a:lstStyle/>
+                    <a:p>
+                      <a:r>
+                        <a:rPr sz="1575" b="0">
+                          <a:solidFill>
+                            <a:srgbClr val="193E3A"/>
+                          </a:solidFill>
+                          <a:latin typeface="Arial"/>
+                          <a:ea typeface="Arial"/>
+                          <a:cs typeface="Arial"/>
+                        </a:rPr>
+                        <a:t>0,9583</a:t>
                       </a:r>
                     </a:p>
                   </a:txBody>
@@ -11227,7 +11745,7 @@
                 <a:ea typeface="Arial"/>
                 <a:cs typeface="Arial"/>
               </a:rPr>
-              <a:t>Бір сурет және екі модель</a:t>
+              <a:t>Бір сурет және үш болжам</a:t>
             </a:r>
           </a:p>
         </p:txBody>
@@ -11306,7 +11824,7 @@
           <p:cNvPr id="3" name="">
             <a:extLst xmlns:a="http://schemas.openxmlformats.org/drawingml/2006/main">
               <a:ext uri="{FF2B5EF4-FFF2-40B4-BE49-F238E27FC236}">
-                <a16:creationId xmlns:a16="http://schemas.microsoft.com/office/drawing/2014/main" id="{889621C8-30E2-4672-9413-2F2A6A04C086}"/>
+                <a16:creationId xmlns:a16="http://schemas.microsoft.com/office/drawing/2014/main" id="{EC4C0078-F1F0-4CF1-8B19-81DBB315FD99}"/>
               </a:ext>
             </a:extLst>
           </p:cNvPr>
@@ -11316,7 +11834,7 @@
           <p:nvPr/>
         </p:nvPicPr>
         <p:blipFill>
-          <a:blip xmlns:r="http://schemas.openxmlformats.org/officeDocument/2006/relationships" xmlns:a="http://schemas.openxmlformats.org/drawingml/2006/main" r:embed="Ra4f547400dda46cc"/>
+          <a:blip xmlns:r="http://schemas.openxmlformats.org/officeDocument/2006/relationships" xmlns:a="http://schemas.openxmlformats.org/drawingml/2006/main" r:embed="Rcc5a2091772d4a0e"/>
           <a:stretch xmlns:a="http://schemas.openxmlformats.org/drawingml/2006/main"/>
         </p:blipFill>
         <p:spPr>
@@ -11849,7 +12367,7 @@
           <p:cNvPr id="3" name="">
             <a:extLst xmlns:a="http://schemas.openxmlformats.org/drawingml/2006/main">
               <a:ext uri="{FF2B5EF4-FFF2-40B4-BE49-F238E27FC236}">
-                <a16:creationId xmlns:a16="http://schemas.microsoft.com/office/drawing/2014/main" id="{97B6F7E9-331C-44CA-AEAE-E127888CA0AA}"/>
+                <a16:creationId xmlns:a16="http://schemas.microsoft.com/office/drawing/2014/main" id="{A3F02817-160A-44AC-B501-A3BDE9DFE7E3}"/>
               </a:ext>
             </a:extLst>
           </p:cNvPr>
@@ -11859,7 +12377,7 @@
           <p:nvPr/>
         </p:nvPicPr>
         <p:blipFill>
-          <a:blip xmlns:r="http://schemas.openxmlformats.org/officeDocument/2006/relationships" xmlns:a="http://schemas.openxmlformats.org/drawingml/2006/main" r:embed="Re8c1dcefbfc349cc"/>
+          <a:blip xmlns:r="http://schemas.openxmlformats.org/officeDocument/2006/relationships" xmlns:a="http://schemas.openxmlformats.org/drawingml/2006/main" r:embed="R5718f91a63374204"/>
           <a:stretch xmlns:a="http://schemas.openxmlformats.org/drawingml/2006/main"/>
         </p:blipFill>
         <p:spPr>
@@ -12323,7 +12841,7 @@
           <p:cNvPr id="3" name="">
             <a:extLst xmlns:a="http://schemas.openxmlformats.org/drawingml/2006/main">
               <a:ext uri="{FF2B5EF4-FFF2-40B4-BE49-F238E27FC236}">
-                <a16:creationId xmlns:a16="http://schemas.microsoft.com/office/drawing/2014/main" id="{CE93AABE-DCB3-45F9-B88F-812A13E2A2C7}"/>
+                <a16:creationId xmlns:a16="http://schemas.microsoft.com/office/drawing/2014/main" id="{BB1D2741-EF95-4683-8380-AA884B39168A}"/>
               </a:ext>
             </a:extLst>
           </p:cNvPr>
@@ -12333,7 +12851,7 @@
           <p:nvPr/>
         </p:nvPicPr>
         <p:blipFill>
-          <a:blip xmlns:r="http://schemas.openxmlformats.org/officeDocument/2006/relationships" xmlns:a="http://schemas.openxmlformats.org/drawingml/2006/main" r:embed="R2887cf7f91c14c9e"/>
+          <a:blip xmlns:r="http://schemas.openxmlformats.org/officeDocument/2006/relationships" xmlns:a="http://schemas.openxmlformats.org/drawingml/2006/main" r:embed="R6e97e4b68b614603"/>
           <a:stretch xmlns:a="http://schemas.openxmlformats.org/drawingml/2006/main"/>
         </p:blipFill>
         <p:spPr>
@@ -12351,7 +12869,7 @@
           <p:cNvPr id="4" name="">
             <a:extLst xmlns:a="http://schemas.openxmlformats.org/drawingml/2006/main">
               <a:ext uri="{FF2B5EF4-FFF2-40B4-BE49-F238E27FC236}">
-                <a16:creationId xmlns:a16="http://schemas.microsoft.com/office/drawing/2014/main" id="{E201A30C-9F54-4E1C-9449-7697B8144189}"/>
+                <a16:creationId xmlns:a16="http://schemas.microsoft.com/office/drawing/2014/main" id="{4E447657-A80A-4CA7-AB18-E2BEB98F31FC}"/>
               </a:ext>
             </a:extLst>
           </p:cNvPr>
@@ -12361,7 +12879,7 @@
           <p:nvPr/>
         </p:nvPicPr>
         <p:blipFill>
-          <a:blip xmlns:r="http://schemas.openxmlformats.org/officeDocument/2006/relationships" xmlns:a="http://schemas.openxmlformats.org/drawingml/2006/main" r:embed="Rbfefb9a7013b46cb"/>
+          <a:blip xmlns:r="http://schemas.openxmlformats.org/officeDocument/2006/relationships" xmlns:a="http://schemas.openxmlformats.org/drawingml/2006/main" r:embed="R15fc9e56a24c4c83"/>
           <a:stretch xmlns:a="http://schemas.openxmlformats.org/drawingml/2006/main"/>
         </p:blipFill>
         <p:spPr>

</xml_diff>